<commit_message>
report: split synthetic table, fill video E2E results, expand next steps
Speech draft adds the video vs single-image grouping of the six baselines.

Co-Authored-By: Claude Opus 5.5 (1M context) <noreply@anthropic.com>
</commit_message>
<xml_diff>
--- a/汇报/2026-09-30_基线方法复现结果/基线方法复现结果_0930.pptx
+++ b/汇报/2026-09-30_基线方法复现结果/基线方法复现结果_0930.pptx
@@ -8057,22 +8057,58 @@
                 <a:latin typeface="Arial"/>
                 <a:ea typeface="Microsoft YaHei"/>
               </a:rPr>
-              <a:t>200 段合成视频 × 25 帧，1024×576，有虚化真值；每种方法两行：本项目结果 / 论文报告值</a:t>
+              <a:t>200 段合成视频 × 25 帧，1024×576，有虚化真值；每格上方为本项目结果，下方灰色为论文报告值</a:t>
+            </a:r>
+          </a:p>
+        </p:txBody>
+      </p:sp>
+      <p:sp>
+        <p:nvSpPr>
+          <p:cNvPr id="24" name="TextBox 23"/>
+          <p:cNvSpPr txBox="1"/>
+          <p:nvPr/>
+        </p:nvSpPr>
+        <p:spPr>
+          <a:xfrm>
+            <a:off x="731520" y="1481328"/>
+            <a:ext cx="5166359" cy="365760"/>
+          </a:xfrm>
+          <a:prstGeom prst="rect">
+            <a:avLst/>
+          </a:prstGeom>
+          <a:noFill/>
+        </p:spPr>
+        <p:txBody>
+          <a:bodyPr wrap="square" anchor="ctr">
+            <a:spAutoFit/>
+          </a:bodyPr>
+          <a:lstStyle/>
+          <a:p>
+            <a:pPr algn="ctr"/>
+            <a:r>
+              <a:rPr sz="1700" b="1">
+                <a:solidFill>
+                  <a:srgbClr val="0D569A"/>
+                </a:solidFill>
+                <a:latin typeface="Arial"/>
+                <a:ea typeface="Microsoft YaHei"/>
+              </a:rPr>
+              <a:t>单帧质量</a:t>
             </a:r>
           </a:p>
         </p:txBody>
       </p:sp>
       <p:graphicFrame>
         <p:nvGraphicFramePr>
-          <p:cNvPr id="24" name="Table 23"/>
+          <p:cNvPr id="25" name="Table 24"/>
           <p:cNvGraphicFramePr>
             <a:graphicFrameLocks noGrp="1"/>
           </p:cNvGraphicFramePr>
           <p:nvPr/>
         </p:nvGraphicFramePr>
         <p:xfrm>
-          <a:off x="960119" y="1554480"/>
-          <a:ext cx="10149840" cy="4279392"/>
+          <a:off x="731520" y="1874519"/>
+          <a:ext cx="5166359" cy="3840480"/>
         </p:xfrm>
         <a:graphic>
           <a:graphicData uri="http://schemas.openxmlformats.org/drawingml/2006/table">
@@ -8081,16 +8117,12 @@
                 <a:tableStyleId>{5C22544A-7EE6-4342-B048-85BDC9FD1C3A}</a:tableStyleId>
               </a:tblPr>
               <a:tblGrid>
-                <a:gridCol w="2011680"/>
-                <a:gridCol w="1005840"/>
-                <a:gridCol w="1188720"/>
-                <a:gridCol w="1188720"/>
-                <a:gridCol w="1188720"/>
-                <a:gridCol w="1188720"/>
-                <a:gridCol w="1188720"/>
-                <a:gridCol w="1188720"/>
+                <a:gridCol w="1874519"/>
+                <a:gridCol w="1097280"/>
+                <a:gridCol w="1097280"/>
+                <a:gridCol w="1097280"/>
               </a:tblGrid>
-              <a:tr h="329184">
+              <a:tr h="548640">
                 <a:tc>
                   <a:txBody>
                     <a:bodyPr/>
@@ -8129,7 +8161,7 @@
                           <a:latin typeface="Arial"/>
                           <a:ea typeface="Microsoft YaHei"/>
                         </a:rPr>
-                        <a:t>来源</a:t>
+                        <a:t>PSNR ↑</a:t>
                       </a:r>
                     </a:p>
                   </a:txBody>
@@ -8153,7 +8185,7 @@
                           <a:latin typeface="Arial"/>
                           <a:ea typeface="Microsoft YaHei"/>
                         </a:rPr>
-                        <a:t>PSNR ↑</a:t>
+                        <a:t>SSIM ↑</a:t>
                       </a:r>
                     </a:p>
                   </a:txBody>
@@ -8177,7 +8209,919 @@
                           <a:latin typeface="Arial"/>
                           <a:ea typeface="Microsoft YaHei"/>
                         </a:rPr>
-                        <a:t>SSIM ↑</a:t>
+                        <a:t>LPIPS ↓</a:t>
+                      </a:r>
+                    </a:p>
+                  </a:txBody>
+                  <a:tcPr anchor="ctr" marL="45720" marR="45720" marT="18288" marB="18288">
+                    <a:solidFill>
+                      <a:srgbClr val="0D569A"/>
+                    </a:solidFill>
+                  </a:tcPr>
+                </a:tc>
+              </a:tr>
+              <a:tr h="548640">
+                <a:tc>
+                  <a:txBody>
+                    <a:bodyPr/>
+                    <a:lstStyle/>
+                    <a:p>
+                      <a:pPr algn="ctr"/>
+                      <a:r>
+                        <a:rPr sz="1500" b="1">
+                          <a:solidFill>
+                            <a:srgbClr val="101F37"/>
+                          </a:solidFill>
+                          <a:latin typeface="Arial"/>
+                          <a:ea typeface="Microsoft YaHei"/>
+                        </a:rPr>
+                        <a:t>DeepLens</a:t>
+                      </a:r>
+                    </a:p>
+                  </a:txBody>
+                  <a:tcPr anchor="ctr" marL="45720" marR="45720" marT="18288" marB="18288">
+                    <a:solidFill>
+                      <a:srgbClr val="EEF5FB"/>
+                    </a:solidFill>
+                  </a:tcPr>
+                </a:tc>
+                <a:tc>
+                  <a:txBody>
+                    <a:bodyPr/>
+                    <a:lstStyle/>
+                    <a:p>
+                      <a:pPr algn="ctr"/>
+                      <a:r>
+                        <a:rPr sz="1500" b="0">
+                          <a:solidFill>
+                            <a:srgbClr val="101F37"/>
+                          </a:solidFill>
+                          <a:latin typeface="Arial"/>
+                          <a:ea typeface="Microsoft YaHei"/>
+                        </a:rPr>
+                        <a:t>28.17</a:t>
+                      </a:r>
+                    </a:p>
+                    <a:p>
+                      <a:pPr algn="ctr"/>
+                      <a:r>
+                        <a:rPr sz="1100" b="0">
+                          <a:solidFill>
+                            <a:srgbClr val="6B7A90"/>
+                          </a:solidFill>
+                          <a:latin typeface="Arial"/>
+                          <a:ea typeface="Microsoft YaHei"/>
+                        </a:rPr>
+                        <a:t>24.574</a:t>
+                      </a:r>
+                    </a:p>
+                  </a:txBody>
+                  <a:tcPr anchor="ctr" marL="45720" marR="45720" marT="18288" marB="18288">
+                    <a:solidFill>
+                      <a:srgbClr val="EEF5FB"/>
+                    </a:solidFill>
+                  </a:tcPr>
+                </a:tc>
+                <a:tc>
+                  <a:txBody>
+                    <a:bodyPr/>
+                    <a:lstStyle/>
+                    <a:p>
+                      <a:pPr algn="ctr"/>
+                      <a:r>
+                        <a:rPr sz="1500" b="0">
+                          <a:solidFill>
+                            <a:srgbClr val="101F37"/>
+                          </a:solidFill>
+                          <a:latin typeface="Arial"/>
+                          <a:ea typeface="Microsoft YaHei"/>
+                        </a:rPr>
+                        <a:t>0.944</a:t>
+                      </a:r>
+                    </a:p>
+                    <a:p>
+                      <a:pPr algn="ctr"/>
+                      <a:r>
+                        <a:rPr sz="1100" b="0">
+                          <a:solidFill>
+                            <a:srgbClr val="6B7A90"/>
+                          </a:solidFill>
+                          <a:latin typeface="Arial"/>
+                          <a:ea typeface="Microsoft YaHei"/>
+                        </a:rPr>
+                        <a:t>0.819</a:t>
+                      </a:r>
+                    </a:p>
+                  </a:txBody>
+                  <a:tcPr anchor="ctr" marL="45720" marR="45720" marT="18288" marB="18288">
+                    <a:solidFill>
+                      <a:srgbClr val="EEF5FB"/>
+                    </a:solidFill>
+                  </a:tcPr>
+                </a:tc>
+                <a:tc>
+                  <a:txBody>
+                    <a:bodyPr/>
+                    <a:lstStyle/>
+                    <a:p>
+                      <a:pPr algn="ctr"/>
+                      <a:r>
+                        <a:rPr sz="1500" b="0">
+                          <a:solidFill>
+                            <a:srgbClr val="101F37"/>
+                          </a:solidFill>
+                          <a:latin typeface="Arial"/>
+                          <a:ea typeface="Microsoft YaHei"/>
+                        </a:rPr>
+                        <a:t>0.063</a:t>
+                      </a:r>
+                    </a:p>
+                    <a:p>
+                      <a:pPr algn="ctr"/>
+                      <a:r>
+                        <a:rPr sz="1100" b="0">
+                          <a:solidFill>
+                            <a:srgbClr val="6B7A90"/>
+                          </a:solidFill>
+                          <a:latin typeface="Arial"/>
+                          <a:ea typeface="Microsoft YaHei"/>
+                        </a:rPr>
+                        <a:t>0.183</a:t>
+                      </a:r>
+                    </a:p>
+                  </a:txBody>
+                  <a:tcPr anchor="ctr" marL="45720" marR="45720" marT="18288" marB="18288">
+                    <a:solidFill>
+                      <a:srgbClr val="EEF5FB"/>
+                    </a:solidFill>
+                  </a:tcPr>
+                </a:tc>
+              </a:tr>
+              <a:tr h="548640">
+                <a:tc>
+                  <a:txBody>
+                    <a:bodyPr/>
+                    <a:lstStyle/>
+                    <a:p>
+                      <a:pPr algn="ctr"/>
+                      <a:r>
+                        <a:rPr sz="1500" b="1">
+                          <a:solidFill>
+                            <a:srgbClr val="101F37"/>
+                          </a:solidFill>
+                          <a:latin typeface="Arial"/>
+                          <a:ea typeface="Microsoft YaHei"/>
+                        </a:rPr>
+                        <a:t>Dr.Bokeh</a:t>
+                      </a:r>
+                    </a:p>
+                  </a:txBody>
+                  <a:tcPr anchor="ctr" marL="45720" marR="45720" marT="18288" marB="18288">
+                    <a:solidFill>
+                      <a:srgbClr val="FFFFFF"/>
+                    </a:solidFill>
+                  </a:tcPr>
+                </a:tc>
+                <a:tc>
+                  <a:txBody>
+                    <a:bodyPr/>
+                    <a:lstStyle/>
+                    <a:p>
+                      <a:pPr algn="ctr"/>
+                      <a:r>
+                        <a:rPr sz="1500" b="0">
+                          <a:solidFill>
+                            <a:srgbClr val="101F37"/>
+                          </a:solidFill>
+                          <a:latin typeface="Arial"/>
+                          <a:ea typeface="Microsoft YaHei"/>
+                        </a:rPr>
+                        <a:t>31.59</a:t>
+                      </a:r>
+                    </a:p>
+                    <a:p>
+                      <a:pPr algn="ctr"/>
+                      <a:r>
+                        <a:rPr sz="1100" b="0">
+                          <a:solidFill>
+                            <a:srgbClr val="6B7A90"/>
+                          </a:solidFill>
+                          <a:latin typeface="Arial"/>
+                          <a:ea typeface="Microsoft YaHei"/>
+                        </a:rPr>
+                        <a:t>31.273</a:t>
+                      </a:r>
+                    </a:p>
+                  </a:txBody>
+                  <a:tcPr anchor="ctr" marL="45720" marR="45720" marT="18288" marB="18288">
+                    <a:solidFill>
+                      <a:srgbClr val="FFFFFF"/>
+                    </a:solidFill>
+                  </a:tcPr>
+                </a:tc>
+                <a:tc>
+                  <a:txBody>
+                    <a:bodyPr/>
+                    <a:lstStyle/>
+                    <a:p>
+                      <a:pPr algn="ctr"/>
+                      <a:r>
+                        <a:rPr sz="1500" b="0">
+                          <a:solidFill>
+                            <a:srgbClr val="101F37"/>
+                          </a:solidFill>
+                          <a:latin typeface="Arial"/>
+                          <a:ea typeface="Microsoft YaHei"/>
+                        </a:rPr>
+                        <a:t>0.973</a:t>
+                      </a:r>
+                    </a:p>
+                    <a:p>
+                      <a:pPr algn="ctr"/>
+                      <a:r>
+                        <a:rPr sz="1100" b="0">
+                          <a:solidFill>
+                            <a:srgbClr val="6B7A90"/>
+                          </a:solidFill>
+                          <a:latin typeface="Arial"/>
+                          <a:ea typeface="Microsoft YaHei"/>
+                        </a:rPr>
+                        <a:t>0.950</a:t>
+                      </a:r>
+                    </a:p>
+                  </a:txBody>
+                  <a:tcPr anchor="ctr" marL="45720" marR="45720" marT="18288" marB="18288">
+                    <a:solidFill>
+                      <a:srgbClr val="FFFFFF"/>
+                    </a:solidFill>
+                  </a:tcPr>
+                </a:tc>
+                <a:tc>
+                  <a:txBody>
+                    <a:bodyPr/>
+                    <a:lstStyle/>
+                    <a:p>
+                      <a:pPr algn="ctr"/>
+                      <a:r>
+                        <a:rPr sz="1500" b="0">
+                          <a:solidFill>
+                            <a:srgbClr val="101F37"/>
+                          </a:solidFill>
+                          <a:latin typeface="Arial"/>
+                          <a:ea typeface="Microsoft YaHei"/>
+                        </a:rPr>
+                        <a:t>0.029</a:t>
+                      </a:r>
+                    </a:p>
+                    <a:p>
+                      <a:pPr algn="ctr"/>
+                      <a:r>
+                        <a:rPr sz="1100" b="0">
+                          <a:solidFill>
+                            <a:srgbClr val="6B7A90"/>
+                          </a:solidFill>
+                          <a:latin typeface="Arial"/>
+                          <a:ea typeface="Microsoft YaHei"/>
+                        </a:rPr>
+                        <a:t>0.046</a:t>
+                      </a:r>
+                    </a:p>
+                  </a:txBody>
+                  <a:tcPr anchor="ctr" marL="45720" marR="45720" marT="18288" marB="18288">
+                    <a:solidFill>
+                      <a:srgbClr val="FFFFFF"/>
+                    </a:solidFill>
+                  </a:tcPr>
+                </a:tc>
+              </a:tr>
+              <a:tr h="548640">
+                <a:tc>
+                  <a:txBody>
+                    <a:bodyPr/>
+                    <a:lstStyle/>
+                    <a:p>
+                      <a:pPr algn="ctr"/>
+                      <a:r>
+                        <a:rPr sz="1500" b="1">
+                          <a:solidFill>
+                            <a:srgbClr val="101F37"/>
+                          </a:solidFill>
+                          <a:latin typeface="Arial"/>
+                          <a:ea typeface="Microsoft YaHei"/>
+                        </a:rPr>
+                        <a:t>BokehMe</a:t>
+                      </a:r>
+                    </a:p>
+                  </a:txBody>
+                  <a:tcPr anchor="ctr" marL="45720" marR="45720" marT="18288" marB="18288">
+                    <a:solidFill>
+                      <a:srgbClr val="EEF5FB"/>
+                    </a:solidFill>
+                  </a:tcPr>
+                </a:tc>
+                <a:tc>
+                  <a:txBody>
+                    <a:bodyPr/>
+                    <a:lstStyle/>
+                    <a:p>
+                      <a:pPr algn="ctr"/>
+                      <a:r>
+                        <a:rPr sz="1500" b="0">
+                          <a:solidFill>
+                            <a:srgbClr val="101F37"/>
+                          </a:solidFill>
+                          <a:latin typeface="Arial"/>
+                          <a:ea typeface="Microsoft YaHei"/>
+                        </a:rPr>
+                        <a:t>33.33</a:t>
+                      </a:r>
+                    </a:p>
+                    <a:p>
+                      <a:pPr algn="ctr"/>
+                      <a:r>
+                        <a:rPr sz="1100" b="0">
+                          <a:solidFill>
+                            <a:srgbClr val="6B7A90"/>
+                          </a:solidFill>
+                          <a:latin typeface="Arial"/>
+                          <a:ea typeface="Microsoft YaHei"/>
+                        </a:rPr>
+                        <a:t>27.992</a:t>
+                      </a:r>
+                    </a:p>
+                  </a:txBody>
+                  <a:tcPr anchor="ctr" marL="45720" marR="45720" marT="18288" marB="18288">
+                    <a:solidFill>
+                      <a:srgbClr val="EEF5FB"/>
+                    </a:solidFill>
+                  </a:tcPr>
+                </a:tc>
+                <a:tc>
+                  <a:txBody>
+                    <a:bodyPr/>
+                    <a:lstStyle/>
+                    <a:p>
+                      <a:pPr algn="ctr"/>
+                      <a:r>
+                        <a:rPr sz="1500" b="0">
+                          <a:solidFill>
+                            <a:srgbClr val="101F37"/>
+                          </a:solidFill>
+                          <a:latin typeface="Arial"/>
+                          <a:ea typeface="Microsoft YaHei"/>
+                        </a:rPr>
+                        <a:t>0.979</a:t>
+                      </a:r>
+                    </a:p>
+                    <a:p>
+                      <a:pPr algn="ctr"/>
+                      <a:r>
+                        <a:rPr sz="1100" b="0">
+                          <a:solidFill>
+                            <a:srgbClr val="6B7A90"/>
+                          </a:solidFill>
+                          <a:latin typeface="Arial"/>
+                          <a:ea typeface="Microsoft YaHei"/>
+                        </a:rPr>
+                        <a:t>0.936</a:t>
+                      </a:r>
+                    </a:p>
+                  </a:txBody>
+                  <a:tcPr anchor="ctr" marL="45720" marR="45720" marT="18288" marB="18288">
+                    <a:solidFill>
+                      <a:srgbClr val="EEF5FB"/>
+                    </a:solidFill>
+                  </a:tcPr>
+                </a:tc>
+                <a:tc>
+                  <a:txBody>
+                    <a:bodyPr/>
+                    <a:lstStyle/>
+                    <a:p>
+                      <a:pPr algn="ctr"/>
+                      <a:r>
+                        <a:rPr sz="1500" b="0">
+                          <a:solidFill>
+                            <a:srgbClr val="101F37"/>
+                          </a:solidFill>
+                          <a:latin typeface="Arial"/>
+                          <a:ea typeface="Microsoft YaHei"/>
+                        </a:rPr>
+                        <a:t>0.025</a:t>
+                      </a:r>
+                    </a:p>
+                    <a:p>
+                      <a:pPr algn="ctr"/>
+                      <a:r>
+                        <a:rPr sz="1100" b="0">
+                          <a:solidFill>
+                            <a:srgbClr val="6B7A90"/>
+                          </a:solidFill>
+                          <a:latin typeface="Arial"/>
+                          <a:ea typeface="Microsoft YaHei"/>
+                        </a:rPr>
+                        <a:t>0.060</a:t>
+                      </a:r>
+                    </a:p>
+                  </a:txBody>
+                  <a:tcPr anchor="ctr" marL="45720" marR="45720" marT="18288" marB="18288">
+                    <a:solidFill>
+                      <a:srgbClr val="EEF5FB"/>
+                    </a:solidFill>
+                  </a:tcPr>
+                </a:tc>
+              </a:tr>
+              <a:tr h="548640">
+                <a:tc>
+                  <a:txBody>
+                    <a:bodyPr/>
+                    <a:lstStyle/>
+                    <a:p>
+                      <a:pPr algn="ctr"/>
+                      <a:r>
+                        <a:rPr sz="1500" b="1">
+                          <a:solidFill>
+                            <a:srgbClr val="101F37"/>
+                          </a:solidFill>
+                          <a:latin typeface="Arial"/>
+                          <a:ea typeface="Microsoft YaHei"/>
+                        </a:rPr>
+                        <a:t>MPIB</a:t>
+                      </a:r>
+                    </a:p>
+                  </a:txBody>
+                  <a:tcPr anchor="ctr" marL="45720" marR="45720" marT="18288" marB="18288">
+                    <a:solidFill>
+                      <a:srgbClr val="FFFFFF"/>
+                    </a:solidFill>
+                  </a:tcPr>
+                </a:tc>
+                <a:tc>
+                  <a:txBody>
+                    <a:bodyPr/>
+                    <a:lstStyle/>
+                    <a:p>
+                      <a:pPr algn="ctr"/>
+                      <a:r>
+                        <a:rPr sz="1500" b="0">
+                          <a:solidFill>
+                            <a:srgbClr val="101F37"/>
+                          </a:solidFill>
+                          <a:latin typeface="Arial"/>
+                          <a:ea typeface="Microsoft YaHei"/>
+                        </a:rPr>
+                        <a:t>31.62</a:t>
+                      </a:r>
+                    </a:p>
+                    <a:p>
+                      <a:pPr algn="ctr"/>
+                      <a:r>
+                        <a:rPr sz="1100" b="0">
+                          <a:solidFill>
+                            <a:srgbClr val="6B7A90"/>
+                          </a:solidFill>
+                          <a:latin typeface="Arial"/>
+                          <a:ea typeface="Microsoft YaHei"/>
+                        </a:rPr>
+                        <a:t>31.390</a:t>
+                      </a:r>
+                    </a:p>
+                  </a:txBody>
+                  <a:tcPr anchor="ctr" marL="45720" marR="45720" marT="18288" marB="18288">
+                    <a:solidFill>
+                      <a:srgbClr val="FFFFFF"/>
+                    </a:solidFill>
+                  </a:tcPr>
+                </a:tc>
+                <a:tc>
+                  <a:txBody>
+                    <a:bodyPr/>
+                    <a:lstStyle/>
+                    <a:p>
+                      <a:pPr algn="ctr"/>
+                      <a:r>
+                        <a:rPr sz="1500" b="0">
+                          <a:solidFill>
+                            <a:srgbClr val="101F37"/>
+                          </a:solidFill>
+                          <a:latin typeface="Arial"/>
+                          <a:ea typeface="Microsoft YaHei"/>
+                        </a:rPr>
+                        <a:t>0.974</a:t>
+                      </a:r>
+                    </a:p>
+                    <a:p>
+                      <a:pPr algn="ctr"/>
+                      <a:r>
+                        <a:rPr sz="1100" b="0">
+                          <a:solidFill>
+                            <a:srgbClr val="6B7A90"/>
+                          </a:solidFill>
+                          <a:latin typeface="Arial"/>
+                          <a:ea typeface="Microsoft YaHei"/>
+                        </a:rPr>
+                        <a:t>0.950</a:t>
+                      </a:r>
+                    </a:p>
+                  </a:txBody>
+                  <a:tcPr anchor="ctr" marL="45720" marR="45720" marT="18288" marB="18288">
+                    <a:solidFill>
+                      <a:srgbClr val="FFFFFF"/>
+                    </a:solidFill>
+                  </a:tcPr>
+                </a:tc>
+                <a:tc>
+                  <a:txBody>
+                    <a:bodyPr/>
+                    <a:lstStyle/>
+                    <a:p>
+                      <a:pPr algn="ctr"/>
+                      <a:r>
+                        <a:rPr sz="1500" b="0">
+                          <a:solidFill>
+                            <a:srgbClr val="101F37"/>
+                          </a:solidFill>
+                          <a:latin typeface="Arial"/>
+                          <a:ea typeface="Microsoft YaHei"/>
+                        </a:rPr>
+                        <a:t>0.028</a:t>
+                      </a:r>
+                    </a:p>
+                    <a:p>
+                      <a:pPr algn="ctr"/>
+                      <a:r>
+                        <a:rPr sz="1100" b="0">
+                          <a:solidFill>
+                            <a:srgbClr val="6B7A90"/>
+                          </a:solidFill>
+                          <a:latin typeface="Arial"/>
+                          <a:ea typeface="Microsoft YaHei"/>
+                        </a:rPr>
+                        <a:t>0.040</a:t>
+                      </a:r>
+                    </a:p>
+                  </a:txBody>
+                  <a:tcPr anchor="ctr" marL="45720" marR="45720" marT="18288" marB="18288">
+                    <a:solidFill>
+                      <a:srgbClr val="FFFFFF"/>
+                    </a:solidFill>
+                  </a:tcPr>
+                </a:tc>
+              </a:tr>
+              <a:tr h="548640">
+                <a:tc>
+                  <a:txBody>
+                    <a:bodyPr/>
+                    <a:lstStyle/>
+                    <a:p>
+                      <a:pPr algn="ctr"/>
+                      <a:r>
+                        <a:rPr sz="1500" b="1">
+                          <a:solidFill>
+                            <a:srgbClr val="101F37"/>
+                          </a:solidFill>
+                          <a:latin typeface="Arial"/>
+                          <a:ea typeface="Microsoft YaHei"/>
+                        </a:rPr>
+                        <a:t>BokehDiff</a:t>
+                      </a:r>
+                    </a:p>
+                  </a:txBody>
+                  <a:tcPr anchor="ctr" marL="45720" marR="45720" marT="18288" marB="18288">
+                    <a:solidFill>
+                      <a:srgbClr val="EEF5FB"/>
+                    </a:solidFill>
+                  </a:tcPr>
+                </a:tc>
+                <a:tc>
+                  <a:txBody>
+                    <a:bodyPr/>
+                    <a:lstStyle/>
+                    <a:p>
+                      <a:pPr algn="ctr"/>
+                      <a:r>
+                        <a:rPr sz="1500" b="0">
+                          <a:solidFill>
+                            <a:srgbClr val="101F37"/>
+                          </a:solidFill>
+                          <a:latin typeface="Arial"/>
+                          <a:ea typeface="Microsoft YaHei"/>
+                        </a:rPr>
+                        <a:t>27.06</a:t>
+                      </a:r>
+                    </a:p>
+                    <a:p>
+                      <a:pPr algn="ctr"/>
+                      <a:r>
+                        <a:rPr sz="1100" b="0">
+                          <a:solidFill>
+                            <a:srgbClr val="6B7A90"/>
+                          </a:solidFill>
+                          <a:latin typeface="Arial"/>
+                          <a:ea typeface="Microsoft YaHei"/>
+                        </a:rPr>
+                        <a:t>27.525</a:t>
+                      </a:r>
+                    </a:p>
+                  </a:txBody>
+                  <a:tcPr anchor="ctr" marL="45720" marR="45720" marT="18288" marB="18288">
+                    <a:solidFill>
+                      <a:srgbClr val="EEF5FB"/>
+                    </a:solidFill>
+                  </a:tcPr>
+                </a:tc>
+                <a:tc>
+                  <a:txBody>
+                    <a:bodyPr/>
+                    <a:lstStyle/>
+                    <a:p>
+                      <a:pPr algn="ctr"/>
+                      <a:r>
+                        <a:rPr sz="1500" b="0">
+                          <a:solidFill>
+                            <a:srgbClr val="101F37"/>
+                          </a:solidFill>
+                          <a:latin typeface="Arial"/>
+                          <a:ea typeface="Microsoft YaHei"/>
+                        </a:rPr>
+                        <a:t>0.844</a:t>
+                      </a:r>
+                    </a:p>
+                    <a:p>
+                      <a:pPr algn="ctr"/>
+                      <a:r>
+                        <a:rPr sz="1100" b="0">
+                          <a:solidFill>
+                            <a:srgbClr val="6B7A90"/>
+                          </a:solidFill>
+                          <a:latin typeface="Arial"/>
+                          <a:ea typeface="Microsoft YaHei"/>
+                        </a:rPr>
+                        <a:t>0.834</a:t>
+                      </a:r>
+                    </a:p>
+                  </a:txBody>
+                  <a:tcPr anchor="ctr" marL="45720" marR="45720" marT="18288" marB="18288">
+                    <a:solidFill>
+                      <a:srgbClr val="EEF5FB"/>
+                    </a:solidFill>
+                  </a:tcPr>
+                </a:tc>
+                <a:tc>
+                  <a:txBody>
+                    <a:bodyPr/>
+                    <a:lstStyle/>
+                    <a:p>
+                      <a:pPr algn="ctr"/>
+                      <a:r>
+                        <a:rPr sz="1500" b="0">
+                          <a:solidFill>
+                            <a:srgbClr val="101F37"/>
+                          </a:solidFill>
+                          <a:latin typeface="Arial"/>
+                          <a:ea typeface="Microsoft YaHei"/>
+                        </a:rPr>
+                        <a:t>0.132</a:t>
+                      </a:r>
+                    </a:p>
+                    <a:p>
+                      <a:pPr algn="ctr"/>
+                      <a:r>
+                        <a:rPr sz="1100" b="0">
+                          <a:solidFill>
+                            <a:srgbClr val="6B7A90"/>
+                          </a:solidFill>
+                          <a:latin typeface="Arial"/>
+                          <a:ea typeface="Microsoft YaHei"/>
+                        </a:rPr>
+                        <a:t>0.127</a:t>
+                      </a:r>
+                    </a:p>
+                  </a:txBody>
+                  <a:tcPr anchor="ctr" marL="45720" marR="45720" marT="18288" marB="18288">
+                    <a:solidFill>
+                      <a:srgbClr val="EEF5FB"/>
+                    </a:solidFill>
+                  </a:tcPr>
+                </a:tc>
+              </a:tr>
+              <a:tr h="548640">
+                <a:tc>
+                  <a:txBody>
+                    <a:bodyPr/>
+                    <a:lstStyle/>
+                    <a:p>
+                      <a:pPr algn="ctr"/>
+                      <a:r>
+                        <a:rPr sz="1500" b="1">
+                          <a:solidFill>
+                            <a:srgbClr val="101F37"/>
+                          </a:solidFill>
+                          <a:latin typeface="Arial"/>
+                          <a:ea typeface="Microsoft YaHei"/>
+                        </a:rPr>
+                        <a:t>Any-to-Bokeh</a:t>
+                      </a:r>
+                    </a:p>
+                  </a:txBody>
+                  <a:tcPr anchor="ctr" marL="45720" marR="45720" marT="18288" marB="18288">
+                    <a:solidFill>
+                      <a:srgbClr val="FFFFFF"/>
+                    </a:solidFill>
+                  </a:tcPr>
+                </a:tc>
+                <a:tc>
+                  <a:txBody>
+                    <a:bodyPr/>
+                    <a:lstStyle/>
+                    <a:p>
+                      <a:pPr algn="ctr"/>
+                      <a:r>
+                        <a:rPr sz="1500" b="1">
+                          <a:solidFill>
+                            <a:srgbClr val="101F37"/>
+                          </a:solidFill>
+                          <a:latin typeface="Arial"/>
+                          <a:ea typeface="Microsoft YaHei"/>
+                        </a:rPr>
+                        <a:t>39.71</a:t>
+                      </a:r>
+                    </a:p>
+                    <a:p>
+                      <a:pPr algn="ctr"/>
+                      <a:r>
+                        <a:rPr sz="1100" b="0">
+                          <a:solidFill>
+                            <a:srgbClr val="6B7A90"/>
+                          </a:solidFill>
+                          <a:latin typeface="Arial"/>
+                          <a:ea typeface="Microsoft YaHei"/>
+                        </a:rPr>
+                        <a:t>38.899</a:t>
+                      </a:r>
+                    </a:p>
+                  </a:txBody>
+                  <a:tcPr anchor="ctr" marL="45720" marR="45720" marT="18288" marB="18288">
+                    <a:solidFill>
+                      <a:srgbClr val="FFFFFF"/>
+                    </a:solidFill>
+                  </a:tcPr>
+                </a:tc>
+                <a:tc>
+                  <a:txBody>
+                    <a:bodyPr/>
+                    <a:lstStyle/>
+                    <a:p>
+                      <a:pPr algn="ctr"/>
+                      <a:r>
+                        <a:rPr sz="1500" b="1">
+                          <a:solidFill>
+                            <a:srgbClr val="101F37"/>
+                          </a:solidFill>
+                          <a:latin typeface="Arial"/>
+                          <a:ea typeface="Microsoft YaHei"/>
+                        </a:rPr>
+                        <a:t>0.986</a:t>
+                      </a:r>
+                    </a:p>
+                    <a:p>
+                      <a:pPr algn="ctr"/>
+                      <a:r>
+                        <a:rPr sz="1100" b="0">
+                          <a:solidFill>
+                            <a:srgbClr val="6B7A90"/>
+                          </a:solidFill>
+                          <a:latin typeface="Arial"/>
+                          <a:ea typeface="Microsoft YaHei"/>
+                        </a:rPr>
+                        <a:t>0.974</a:t>
+                      </a:r>
+                    </a:p>
+                  </a:txBody>
+                  <a:tcPr anchor="ctr" marL="45720" marR="45720" marT="18288" marB="18288">
+                    <a:solidFill>
+                      <a:srgbClr val="FFFFFF"/>
+                    </a:solidFill>
+                  </a:tcPr>
+                </a:tc>
+                <a:tc>
+                  <a:txBody>
+                    <a:bodyPr/>
+                    <a:lstStyle/>
+                    <a:p>
+                      <a:pPr algn="ctr"/>
+                      <a:r>
+                        <a:rPr sz="1500" b="1">
+                          <a:solidFill>
+                            <a:srgbClr val="101F37"/>
+                          </a:solidFill>
+                          <a:latin typeface="Arial"/>
+                          <a:ea typeface="Microsoft YaHei"/>
+                        </a:rPr>
+                        <a:t>0.015</a:t>
+                      </a:r>
+                    </a:p>
+                    <a:p>
+                      <a:pPr algn="ctr"/>
+                      <a:r>
+                        <a:rPr sz="1100" b="0">
+                          <a:solidFill>
+                            <a:srgbClr val="6B7A90"/>
+                          </a:solidFill>
+                          <a:latin typeface="Arial"/>
+                          <a:ea typeface="Microsoft YaHei"/>
+                        </a:rPr>
+                        <a:t>0.019</a:t>
+                      </a:r>
+                    </a:p>
+                  </a:txBody>
+                  <a:tcPr anchor="ctr" marL="45720" marR="45720" marT="18288" marB="18288">
+                    <a:solidFill>
+                      <a:srgbClr val="FFFFFF"/>
+                    </a:solidFill>
+                  </a:tcPr>
+                </a:tc>
+              </a:tr>
+            </a:tbl>
+          </a:graphicData>
+        </a:graphic>
+      </p:graphicFrame>
+      <p:sp>
+        <p:nvSpPr>
+          <p:cNvPr id="26" name="TextBox 25"/>
+          <p:cNvSpPr txBox="1"/>
+          <p:nvPr/>
+        </p:nvSpPr>
+        <p:spPr>
+          <a:xfrm>
+            <a:off x="6172200" y="1481328"/>
+            <a:ext cx="5166359" cy="365760"/>
+          </a:xfrm>
+          <a:prstGeom prst="rect">
+            <a:avLst/>
+          </a:prstGeom>
+          <a:noFill/>
+        </p:spPr>
+        <p:txBody>
+          <a:bodyPr wrap="square" anchor="ctr">
+            <a:spAutoFit/>
+          </a:bodyPr>
+          <a:lstStyle/>
+          <a:p>
+            <a:pPr algn="ctr"/>
+            <a:r>
+              <a:rPr sz="1700" b="1">
+                <a:solidFill>
+                  <a:srgbClr val="0D569A"/>
+                </a:solidFill>
+                <a:latin typeface="Arial"/>
+                <a:ea typeface="Microsoft YaHei"/>
+              </a:rPr>
+              <a:t>视频质量与时序稳定</a:t>
+            </a:r>
+          </a:p>
+        </p:txBody>
+      </p:sp>
+      <p:graphicFrame>
+        <p:nvGraphicFramePr>
+          <p:cNvPr id="27" name="Table 26"/>
+          <p:cNvGraphicFramePr>
+            <a:graphicFrameLocks noGrp="1"/>
+          </p:cNvGraphicFramePr>
+          <p:nvPr/>
+        </p:nvGraphicFramePr>
+        <p:xfrm>
+          <a:off x="6172200" y="1874519"/>
+          <a:ext cx="5166359" cy="3840480"/>
+        </p:xfrm>
+        <a:graphic>
+          <a:graphicData uri="http://schemas.openxmlformats.org/drawingml/2006/table">
+            <a:tbl>
+              <a:tblPr firstRow="1">
+                <a:tableStyleId>{5C22544A-7EE6-4342-B048-85BDC9FD1C3A}</a:tableStyleId>
+              </a:tblPr>
+              <a:tblGrid>
+                <a:gridCol w="1874519"/>
+                <a:gridCol w="1097280"/>
+                <a:gridCol w="1097280"/>
+                <a:gridCol w="1097280"/>
+              </a:tblGrid>
+              <a:tr h="548640">
+                <a:tc>
+                  <a:txBody>
+                    <a:bodyPr/>
+                    <a:lstStyle/>
+                    <a:p>
+                      <a:pPr algn="ctr"/>
+                      <a:r>
+                        <a:rPr sz="1500" b="1">
+                          <a:solidFill>
+                            <a:srgbClr val="FFFFFF"/>
+                          </a:solidFill>
+                          <a:latin typeface="Arial"/>
+                          <a:ea typeface="Microsoft YaHei"/>
+                        </a:rPr>
+                        <a:t>方法</a:t>
                       </a:r>
                     </a:p>
                   </a:txBody>
@@ -8201,7 +9145,7 @@
                           <a:latin typeface="Arial"/>
                           <a:ea typeface="Microsoft YaHei"/>
                         </a:rPr>
-                        <a:t>LPIPS ↓</a:t>
+                        <a:t>FVD ↓</a:t>
                       </a:r>
                     </a:p>
                   </a:txBody>
@@ -8225,7 +9169,7 @@
                           <a:latin typeface="Arial"/>
                           <a:ea typeface="Microsoft YaHei"/>
                         </a:rPr>
-                        <a:t>FVD ↓</a:t>
+                        <a:t>FD ↓</a:t>
                       </a:r>
                     </a:p>
                   </a:txBody>
@@ -8249,30 +9193,6 @@
                           <a:latin typeface="Arial"/>
                           <a:ea typeface="Microsoft YaHei"/>
                         </a:rPr>
-                        <a:t>FD ↓</a:t>
-                      </a:r>
-                    </a:p>
-                  </a:txBody>
-                  <a:tcPr anchor="ctr" marL="45720" marR="45720" marT="18288" marB="18288">
-                    <a:solidFill>
-                      <a:srgbClr val="0D569A"/>
-                    </a:solidFill>
-                  </a:tcPr>
-                </a:tc>
-                <a:tc>
-                  <a:txBody>
-                    <a:bodyPr/>
-                    <a:lstStyle/>
-                    <a:p>
-                      <a:pPr algn="ctr"/>
-                      <a:r>
-                        <a:rPr sz="1500" b="1">
-                          <a:solidFill>
-                            <a:srgbClr val="FFFFFF"/>
-                          </a:solidFill>
-                          <a:latin typeface="Arial"/>
-                          <a:ea typeface="Microsoft YaHei"/>
-                        </a:rPr>
                         <a:t>RM ↓</a:t>
                       </a:r>
                     </a:p>
@@ -8284,8 +9204,8 @@
                   </a:tcPr>
                 </a:tc>
               </a:tr>
-              <a:tr h="329184">
-                <a:tc rowSpan="2">
+              <a:tr h="548640">
+                <a:tc>
                   <a:txBody>
                     <a:bodyPr/>
                     <a:lstStyle/>
@@ -8323,7 +9243,20 @@
                           <a:latin typeface="Arial"/>
                           <a:ea typeface="Microsoft YaHei"/>
                         </a:rPr>
-                        <a:t>本项目</a:t>
+                        <a:t>40.12</a:t>
+                      </a:r>
+                    </a:p>
+                    <a:p>
+                      <a:pPr algn="ctr"/>
+                      <a:r>
+                        <a:rPr sz="1100" b="0">
+                          <a:solidFill>
+                            <a:srgbClr val="6B7A90"/>
+                          </a:solidFill>
+                          <a:latin typeface="Arial"/>
+                          <a:ea typeface="Microsoft YaHei"/>
+                        </a:rPr>
+                        <a:t>125.338</a:t>
                       </a:r>
                     </a:p>
                   </a:txBody>
@@ -8347,7 +9280,20 @@
                           <a:latin typeface="Arial"/>
                           <a:ea typeface="Microsoft YaHei"/>
                         </a:rPr>
-                        <a:t>28.17</a:t>
+                        <a:t>0.583</a:t>
+                      </a:r>
+                    </a:p>
+                    <a:p>
+                      <a:pPr algn="ctr"/>
+                      <a:r>
+                        <a:rPr sz="1100" b="0">
+                          <a:solidFill>
+                            <a:srgbClr val="6B7A90"/>
+                          </a:solidFill>
+                          <a:latin typeface="Arial"/>
+                          <a:ea typeface="Microsoft YaHei"/>
+                        </a:rPr>
+                        <a:t>1.162</a:t>
                       </a:r>
                     </a:p>
                   </a:txBody>
@@ -8371,7 +9317,183 @@
                           <a:latin typeface="Arial"/>
                           <a:ea typeface="Microsoft YaHei"/>
                         </a:rPr>
-                        <a:t>0.944</a:t>
+                        <a:t>0.0124</a:t>
+                      </a:r>
+                    </a:p>
+                    <a:p>
+                      <a:pPr algn="ctr"/>
+                      <a:r>
+                        <a:rPr sz="1100" b="0">
+                          <a:solidFill>
+                            <a:srgbClr val="6B7A90"/>
+                          </a:solidFill>
+                          <a:latin typeface="Arial"/>
+                          <a:ea typeface="Microsoft YaHei"/>
+                        </a:rPr>
+                        <a:t>0.030</a:t>
+                      </a:r>
+                    </a:p>
+                  </a:txBody>
+                  <a:tcPr anchor="ctr" marL="45720" marR="45720" marT="18288" marB="18288">
+                    <a:solidFill>
+                      <a:srgbClr val="EEF5FB"/>
+                    </a:solidFill>
+                  </a:tcPr>
+                </a:tc>
+              </a:tr>
+              <a:tr h="548640">
+                <a:tc>
+                  <a:txBody>
+                    <a:bodyPr/>
+                    <a:lstStyle/>
+                    <a:p>
+                      <a:pPr algn="ctr"/>
+                      <a:r>
+                        <a:rPr sz="1500" b="1">
+                          <a:solidFill>
+                            <a:srgbClr val="101F37"/>
+                          </a:solidFill>
+                          <a:latin typeface="Arial"/>
+                          <a:ea typeface="Microsoft YaHei"/>
+                        </a:rPr>
+                        <a:t>Dr.Bokeh</a:t>
+                      </a:r>
+                    </a:p>
+                  </a:txBody>
+                  <a:tcPr anchor="ctr" marL="45720" marR="45720" marT="18288" marB="18288">
+                    <a:solidFill>
+                      <a:srgbClr val="FFFFFF"/>
+                    </a:solidFill>
+                  </a:tcPr>
+                </a:tc>
+                <a:tc>
+                  <a:txBody>
+                    <a:bodyPr/>
+                    <a:lstStyle/>
+                    <a:p>
+                      <a:pPr algn="ctr"/>
+                      <a:r>
+                        <a:rPr sz="1500" b="0">
+                          <a:solidFill>
+                            <a:srgbClr val="101F37"/>
+                          </a:solidFill>
+                          <a:latin typeface="Arial"/>
+                          <a:ea typeface="Microsoft YaHei"/>
+                        </a:rPr>
+                        <a:t>25.86</a:t>
+                      </a:r>
+                    </a:p>
+                    <a:p>
+                      <a:pPr algn="ctr"/>
+                      <a:r>
+                        <a:rPr sz="1100" b="0">
+                          <a:solidFill>
+                            <a:srgbClr val="6B7A90"/>
+                          </a:solidFill>
+                          <a:latin typeface="Arial"/>
+                          <a:ea typeface="Microsoft YaHei"/>
+                        </a:rPr>
+                        <a:t>32.710</a:t>
+                      </a:r>
+                    </a:p>
+                  </a:txBody>
+                  <a:tcPr anchor="ctr" marL="45720" marR="45720" marT="18288" marB="18288">
+                    <a:solidFill>
+                      <a:srgbClr val="FFFFFF"/>
+                    </a:solidFill>
+                  </a:tcPr>
+                </a:tc>
+                <a:tc>
+                  <a:txBody>
+                    <a:bodyPr/>
+                    <a:lstStyle/>
+                    <a:p>
+                      <a:pPr algn="ctr"/>
+                      <a:r>
+                        <a:rPr sz="1500" b="0">
+                          <a:solidFill>
+                            <a:srgbClr val="101F37"/>
+                          </a:solidFill>
+                          <a:latin typeface="Arial"/>
+                          <a:ea typeface="Microsoft YaHei"/>
+                        </a:rPr>
+                        <a:t>0.479</a:t>
+                      </a:r>
+                    </a:p>
+                    <a:p>
+                      <a:pPr algn="ctr"/>
+                      <a:r>
+                        <a:rPr sz="1100" b="0">
+                          <a:solidFill>
+                            <a:srgbClr val="6B7A90"/>
+                          </a:solidFill>
+                          <a:latin typeface="Arial"/>
+                          <a:ea typeface="Microsoft YaHei"/>
+                        </a:rPr>
+                        <a:t>0.522</a:t>
+                      </a:r>
+                    </a:p>
+                  </a:txBody>
+                  <a:tcPr anchor="ctr" marL="45720" marR="45720" marT="18288" marB="18288">
+                    <a:solidFill>
+                      <a:srgbClr val="FFFFFF"/>
+                    </a:solidFill>
+                  </a:tcPr>
+                </a:tc>
+                <a:tc>
+                  <a:txBody>
+                    <a:bodyPr/>
+                    <a:lstStyle/>
+                    <a:p>
+                      <a:pPr algn="ctr"/>
+                      <a:r>
+                        <a:rPr sz="1500" b="0">
+                          <a:solidFill>
+                            <a:srgbClr val="101F37"/>
+                          </a:solidFill>
+                          <a:latin typeface="Arial"/>
+                          <a:ea typeface="Microsoft YaHei"/>
+                        </a:rPr>
+                        <a:t>0.0084</a:t>
+                      </a:r>
+                    </a:p>
+                    <a:p>
+                      <a:pPr algn="ctr"/>
+                      <a:r>
+                        <a:rPr sz="1100" b="0">
+                          <a:solidFill>
+                            <a:srgbClr val="6B7A90"/>
+                          </a:solidFill>
+                          <a:latin typeface="Arial"/>
+                          <a:ea typeface="Microsoft YaHei"/>
+                        </a:rPr>
+                        <a:t>0.011</a:t>
+                      </a:r>
+                    </a:p>
+                  </a:txBody>
+                  <a:tcPr anchor="ctr" marL="45720" marR="45720" marT="18288" marB="18288">
+                    <a:solidFill>
+                      <a:srgbClr val="FFFFFF"/>
+                    </a:solidFill>
+                  </a:tcPr>
+                </a:tc>
+              </a:tr>
+              <a:tr h="548640">
+                <a:tc>
+                  <a:txBody>
+                    <a:bodyPr/>
+                    <a:lstStyle/>
+                    <a:p>
+                      <a:pPr algn="ctr"/>
+                      <a:r>
+                        <a:rPr sz="1500" b="1">
+                          <a:solidFill>
+                            <a:srgbClr val="101F37"/>
+                          </a:solidFill>
+                          <a:latin typeface="Arial"/>
+                          <a:ea typeface="Microsoft YaHei"/>
+                        </a:rPr>
+                        <a:t>BokehMe</a:t>
                       </a:r>
                     </a:p>
                   </a:txBody>
@@ -8395,7 +9517,20 @@
                           <a:latin typeface="Arial"/>
                           <a:ea typeface="Microsoft YaHei"/>
                         </a:rPr>
-                        <a:t>0.063</a:t>
+                        <a:t>18.55</a:t>
+                      </a:r>
+                    </a:p>
+                    <a:p>
+                      <a:pPr algn="ctr"/>
+                      <a:r>
+                        <a:rPr sz="1100" b="0">
+                          <a:solidFill>
+                            <a:srgbClr val="6B7A90"/>
+                          </a:solidFill>
+                          <a:latin typeface="Arial"/>
+                          <a:ea typeface="Microsoft YaHei"/>
+                        </a:rPr>
+                        <a:t>39.102</a:t>
                       </a:r>
                     </a:p>
                   </a:txBody>
@@ -8419,7 +9554,20 @@
                           <a:latin typeface="Arial"/>
                           <a:ea typeface="Microsoft YaHei"/>
                         </a:rPr>
-                        <a:t>40.12</a:t>
+                        <a:t>0.540</a:t>
+                      </a:r>
+                    </a:p>
+                    <a:p>
+                      <a:pPr algn="ctr"/>
+                      <a:r>
+                        <a:rPr sz="1100" b="0">
+                          <a:solidFill>
+                            <a:srgbClr val="6B7A90"/>
+                          </a:solidFill>
+                          <a:latin typeface="Arial"/>
+                          <a:ea typeface="Microsoft YaHei"/>
+                        </a:rPr>
+                        <a:t>0.536</a:t>
                       </a:r>
                     </a:p>
                   </a:txBody>
@@ -8443,7 +9591,183 @@
                           <a:latin typeface="Arial"/>
                           <a:ea typeface="Microsoft YaHei"/>
                         </a:rPr>
-                        <a:t>0.583</a:t>
+                        <a:t>0.0074</a:t>
+                      </a:r>
+                    </a:p>
+                    <a:p>
+                      <a:pPr algn="ctr"/>
+                      <a:r>
+                        <a:rPr sz="1100" b="0">
+                          <a:solidFill>
+                            <a:srgbClr val="6B7A90"/>
+                          </a:solidFill>
+                          <a:latin typeface="Arial"/>
+                          <a:ea typeface="Microsoft YaHei"/>
+                        </a:rPr>
+                        <a:t>0.013</a:t>
+                      </a:r>
+                    </a:p>
+                  </a:txBody>
+                  <a:tcPr anchor="ctr" marL="45720" marR="45720" marT="18288" marB="18288">
+                    <a:solidFill>
+                      <a:srgbClr val="EEF5FB"/>
+                    </a:solidFill>
+                  </a:tcPr>
+                </a:tc>
+              </a:tr>
+              <a:tr h="548640">
+                <a:tc>
+                  <a:txBody>
+                    <a:bodyPr/>
+                    <a:lstStyle/>
+                    <a:p>
+                      <a:pPr algn="ctr"/>
+                      <a:r>
+                        <a:rPr sz="1500" b="1">
+                          <a:solidFill>
+                            <a:srgbClr val="101F37"/>
+                          </a:solidFill>
+                          <a:latin typeface="Arial"/>
+                          <a:ea typeface="Microsoft YaHei"/>
+                        </a:rPr>
+                        <a:t>MPIB</a:t>
+                      </a:r>
+                    </a:p>
+                  </a:txBody>
+                  <a:tcPr anchor="ctr" marL="45720" marR="45720" marT="18288" marB="18288">
+                    <a:solidFill>
+                      <a:srgbClr val="FFFFFF"/>
+                    </a:solidFill>
+                  </a:tcPr>
+                </a:tc>
+                <a:tc>
+                  <a:txBody>
+                    <a:bodyPr/>
+                    <a:lstStyle/>
+                    <a:p>
+                      <a:pPr algn="ctr"/>
+                      <a:r>
+                        <a:rPr sz="1500" b="0">
+                          <a:solidFill>
+                            <a:srgbClr val="101F37"/>
+                          </a:solidFill>
+                          <a:latin typeface="Arial"/>
+                          <a:ea typeface="Microsoft YaHei"/>
+                        </a:rPr>
+                        <a:t>24.96</a:t>
+                      </a:r>
+                    </a:p>
+                    <a:p>
+                      <a:pPr algn="ctr"/>
+                      <a:r>
+                        <a:rPr sz="1100" b="0">
+                          <a:solidFill>
+                            <a:srgbClr val="6B7A90"/>
+                          </a:solidFill>
+                          <a:latin typeface="Arial"/>
+                          <a:ea typeface="Microsoft YaHei"/>
+                        </a:rPr>
+                        <a:t>35.766</a:t>
+                      </a:r>
+                    </a:p>
+                  </a:txBody>
+                  <a:tcPr anchor="ctr" marL="45720" marR="45720" marT="18288" marB="18288">
+                    <a:solidFill>
+                      <a:srgbClr val="FFFFFF"/>
+                    </a:solidFill>
+                  </a:tcPr>
+                </a:tc>
+                <a:tc>
+                  <a:txBody>
+                    <a:bodyPr/>
+                    <a:lstStyle/>
+                    <a:p>
+                      <a:pPr algn="ctr"/>
+                      <a:r>
+                        <a:rPr sz="1500" b="0">
+                          <a:solidFill>
+                            <a:srgbClr val="101F37"/>
+                          </a:solidFill>
+                          <a:latin typeface="Arial"/>
+                          <a:ea typeface="Microsoft YaHei"/>
+                        </a:rPr>
+                        <a:t>0.450</a:t>
+                      </a:r>
+                    </a:p>
+                    <a:p>
+                      <a:pPr algn="ctr"/>
+                      <a:r>
+                        <a:rPr sz="1100" b="0">
+                          <a:solidFill>
+                            <a:srgbClr val="6B7A90"/>
+                          </a:solidFill>
+                          <a:latin typeface="Arial"/>
+                          <a:ea typeface="Microsoft YaHei"/>
+                        </a:rPr>
+                        <a:t>0.481</a:t>
+                      </a:r>
+                    </a:p>
+                  </a:txBody>
+                  <a:tcPr anchor="ctr" marL="45720" marR="45720" marT="18288" marB="18288">
+                    <a:solidFill>
+                      <a:srgbClr val="FFFFFF"/>
+                    </a:solidFill>
+                  </a:tcPr>
+                </a:tc>
+                <a:tc>
+                  <a:txBody>
+                    <a:bodyPr/>
+                    <a:lstStyle/>
+                    <a:p>
+                      <a:pPr algn="ctr"/>
+                      <a:r>
+                        <a:rPr sz="1500" b="0">
+                          <a:solidFill>
+                            <a:srgbClr val="101F37"/>
+                          </a:solidFill>
+                          <a:latin typeface="Arial"/>
+                          <a:ea typeface="Microsoft YaHei"/>
+                        </a:rPr>
+                        <a:t>0.0082</a:t>
+                      </a:r>
+                    </a:p>
+                    <a:p>
+                      <a:pPr algn="ctr"/>
+                      <a:r>
+                        <a:rPr sz="1100" b="0">
+                          <a:solidFill>
+                            <a:srgbClr val="6B7A90"/>
+                          </a:solidFill>
+                          <a:latin typeface="Arial"/>
+                          <a:ea typeface="Microsoft YaHei"/>
+                        </a:rPr>
+                        <a:t>0.011</a:t>
+                      </a:r>
+                    </a:p>
+                  </a:txBody>
+                  <a:tcPr anchor="ctr" marL="45720" marR="45720" marT="18288" marB="18288">
+                    <a:solidFill>
+                      <a:srgbClr val="FFFFFF"/>
+                    </a:solidFill>
+                  </a:tcPr>
+                </a:tc>
+              </a:tr>
+              <a:tr h="548640">
+                <a:tc>
+                  <a:txBody>
+                    <a:bodyPr/>
+                    <a:lstStyle/>
+                    <a:p>
+                      <a:pPr algn="ctr"/>
+                      <a:r>
+                        <a:rPr sz="1500" b="1">
+                          <a:solidFill>
+                            <a:srgbClr val="101F37"/>
+                          </a:solidFill>
+                          <a:latin typeface="Arial"/>
+                          <a:ea typeface="Microsoft YaHei"/>
+                        </a:rPr>
+                        <a:t>BokehDiff</a:t>
                       </a:r>
                     </a:p>
                   </a:txBody>
@@ -8467,33 +9791,20 @@
                           <a:latin typeface="Arial"/>
                           <a:ea typeface="Microsoft YaHei"/>
                         </a:rPr>
-                        <a:t>0.0124</a:t>
-                      </a:r>
-                    </a:p>
-                  </a:txBody>
-                  <a:tcPr anchor="ctr" marL="45720" marR="45720" marT="18288" marB="18288">
-                    <a:solidFill>
-                      <a:srgbClr val="EEF5FB"/>
-                    </a:solidFill>
-                  </a:tcPr>
-                </a:tc>
-              </a:tr>
-              <a:tr h="329184">
-                <a:tc vMerge="1">
-                  <a:txBody>
-                    <a:bodyPr/>
-                    <a:lstStyle/>
-                    <a:p>
-                      <a:pPr algn="ctr"/>
-                      <a:r>
-                        <a:rPr sz="1500" b="1">
-                          <a:solidFill>
-                            <a:srgbClr val="101F37"/>
-                          </a:solidFill>
-                          <a:latin typeface="Arial"/>
-                          <a:ea typeface="Microsoft YaHei"/>
-                        </a:rPr>
-                        <a:t/>
+                        <a:t>66.00</a:t>
+                      </a:r>
+                    </a:p>
+                    <a:p>
+                      <a:pPr algn="ctr"/>
+                      <a:r>
+                        <a:rPr sz="1100" b="0">
+                          <a:solidFill>
+                            <a:srgbClr val="6B7A90"/>
+                          </a:solidFill>
+                          <a:latin typeface="Arial"/>
+                          <a:ea typeface="Microsoft YaHei"/>
+                        </a:rPr>
+                        <a:t>65.678</a:t>
                       </a:r>
                     </a:p>
                   </a:txBody>
@@ -8510,14 +9821,27 @@
                     <a:p>
                       <a:pPr algn="ctr"/>
                       <a:r>
-                        <a:rPr sz="1300" b="0">
+                        <a:rPr sz="1500" b="0">
+                          <a:solidFill>
+                            <a:srgbClr val="101F37"/>
+                          </a:solidFill>
+                          <a:latin typeface="Arial"/>
+                          <a:ea typeface="Microsoft YaHei"/>
+                        </a:rPr>
+                        <a:t>0.802</a:t>
+                      </a:r>
+                    </a:p>
+                    <a:p>
+                      <a:pPr algn="ctr"/>
+                      <a:r>
+                        <a:rPr sz="1100" b="0">
                           <a:solidFill>
                             <a:srgbClr val="6B7A90"/>
                           </a:solidFill>
                           <a:latin typeface="Arial"/>
                           <a:ea typeface="Microsoft YaHei"/>
                         </a:rPr>
-                        <a:t>论文</a:t>
+                        <a:t>0.660</a:t>
                       </a:r>
                     </a:p>
                   </a:txBody>
@@ -8534,134 +9858,27 @@
                     <a:p>
                       <a:pPr algn="ctr"/>
                       <a:r>
-                        <a:rPr sz="1300" b="0">
+                        <a:rPr sz="1500" b="0">
+                          <a:solidFill>
+                            <a:srgbClr val="101F37"/>
+                          </a:solidFill>
+                          <a:latin typeface="Arial"/>
+                          <a:ea typeface="Microsoft YaHei"/>
+                        </a:rPr>
+                        <a:t>0.0216</a:t>
+                      </a:r>
+                    </a:p>
+                    <a:p>
+                      <a:pPr algn="ctr"/>
+                      <a:r>
+                        <a:rPr sz="1100" b="0">
                           <a:solidFill>
                             <a:srgbClr val="6B7A90"/>
                           </a:solidFill>
                           <a:latin typeface="Arial"/>
                           <a:ea typeface="Microsoft YaHei"/>
                         </a:rPr>
-                        <a:t>24.574</a:t>
-                      </a:r>
-                    </a:p>
-                  </a:txBody>
-                  <a:tcPr anchor="ctr" marL="45720" marR="45720" marT="18288" marB="18288">
-                    <a:solidFill>
-                      <a:srgbClr val="EEF5FB"/>
-                    </a:solidFill>
-                  </a:tcPr>
-                </a:tc>
-                <a:tc>
-                  <a:txBody>
-                    <a:bodyPr/>
-                    <a:lstStyle/>
-                    <a:p>
-                      <a:pPr algn="ctr"/>
-                      <a:r>
-                        <a:rPr sz="1300" b="0">
-                          <a:solidFill>
-                            <a:srgbClr val="6B7A90"/>
-                          </a:solidFill>
-                          <a:latin typeface="Arial"/>
-                          <a:ea typeface="Microsoft YaHei"/>
-                        </a:rPr>
-                        <a:t>0.819</a:t>
-                      </a:r>
-                    </a:p>
-                  </a:txBody>
-                  <a:tcPr anchor="ctr" marL="45720" marR="45720" marT="18288" marB="18288">
-                    <a:solidFill>
-                      <a:srgbClr val="EEF5FB"/>
-                    </a:solidFill>
-                  </a:tcPr>
-                </a:tc>
-                <a:tc>
-                  <a:txBody>
-                    <a:bodyPr/>
-                    <a:lstStyle/>
-                    <a:p>
-                      <a:pPr algn="ctr"/>
-                      <a:r>
-                        <a:rPr sz="1300" b="0">
-                          <a:solidFill>
-                            <a:srgbClr val="6B7A90"/>
-                          </a:solidFill>
-                          <a:latin typeface="Arial"/>
-                          <a:ea typeface="Microsoft YaHei"/>
-                        </a:rPr>
-                        <a:t>0.183</a:t>
-                      </a:r>
-                    </a:p>
-                  </a:txBody>
-                  <a:tcPr anchor="ctr" marL="45720" marR="45720" marT="18288" marB="18288">
-                    <a:solidFill>
-                      <a:srgbClr val="EEF5FB"/>
-                    </a:solidFill>
-                  </a:tcPr>
-                </a:tc>
-                <a:tc>
-                  <a:txBody>
-                    <a:bodyPr/>
-                    <a:lstStyle/>
-                    <a:p>
-                      <a:pPr algn="ctr"/>
-                      <a:r>
-                        <a:rPr sz="1300" b="0">
-                          <a:solidFill>
-                            <a:srgbClr val="6B7A90"/>
-                          </a:solidFill>
-                          <a:latin typeface="Arial"/>
-                          <a:ea typeface="Microsoft YaHei"/>
-                        </a:rPr>
-                        <a:t>125.338</a:t>
-                      </a:r>
-                    </a:p>
-                  </a:txBody>
-                  <a:tcPr anchor="ctr" marL="45720" marR="45720" marT="18288" marB="18288">
-                    <a:solidFill>
-                      <a:srgbClr val="EEF5FB"/>
-                    </a:solidFill>
-                  </a:tcPr>
-                </a:tc>
-                <a:tc>
-                  <a:txBody>
-                    <a:bodyPr/>
-                    <a:lstStyle/>
-                    <a:p>
-                      <a:pPr algn="ctr"/>
-                      <a:r>
-                        <a:rPr sz="1300" b="0">
-                          <a:solidFill>
-                            <a:srgbClr val="6B7A90"/>
-                          </a:solidFill>
-                          <a:latin typeface="Arial"/>
-                          <a:ea typeface="Microsoft YaHei"/>
-                        </a:rPr>
-                        <a:t>1.162</a:t>
-                      </a:r>
-                    </a:p>
-                  </a:txBody>
-                  <a:tcPr anchor="ctr" marL="45720" marR="45720" marT="18288" marB="18288">
-                    <a:solidFill>
-                      <a:srgbClr val="EEF5FB"/>
-                    </a:solidFill>
-                  </a:tcPr>
-                </a:tc>
-                <a:tc>
-                  <a:txBody>
-                    <a:bodyPr/>
-                    <a:lstStyle/>
-                    <a:p>
-                      <a:pPr algn="ctr"/>
-                      <a:r>
-                        <a:rPr sz="1300" b="0">
-                          <a:solidFill>
-                            <a:srgbClr val="6B7A90"/>
-                          </a:solidFill>
-                          <a:latin typeface="Arial"/>
-                          <a:ea typeface="Microsoft YaHei"/>
-                        </a:rPr>
-                        <a:t>0.030</a:t>
+                        <a:t>0.021</a:t>
                       </a:r>
                     </a:p>
                   </a:txBody>
@@ -8672,8 +9889,8 @@
                   </a:tcPr>
                 </a:tc>
               </a:tr>
-              <a:tr h="329184">
-                <a:tc rowSpan="2">
+              <a:tr h="548640">
+                <a:tc>
                   <a:txBody>
                     <a:bodyPr/>
                     <a:lstStyle/>
@@ -8687,7 +9904,7 @@
                           <a:latin typeface="Arial"/>
                           <a:ea typeface="Microsoft YaHei"/>
                         </a:rPr>
-                        <a:t>Dr.Bokeh</a:t>
+                        <a:t>Any-to-Bokeh</a:t>
                       </a:r>
                     </a:p>
                   </a:txBody>
@@ -8704,14 +9921,27 @@
                     <a:p>
                       <a:pPr algn="ctr"/>
                       <a:r>
-                        <a:rPr sz="1500" b="0">
+                        <a:rPr sz="1500" b="1">
                           <a:solidFill>
                             <a:srgbClr val="101F37"/>
                           </a:solidFill>
                           <a:latin typeface="Arial"/>
                           <a:ea typeface="Microsoft YaHei"/>
                         </a:rPr>
-                        <a:t>本项目</a:t>
+                        <a:t>8.94</a:t>
+                      </a:r>
+                    </a:p>
+                    <a:p>
+                      <a:pPr algn="ctr"/>
+                      <a:r>
+                        <a:rPr sz="1100" b="0">
+                          <a:solidFill>
+                            <a:srgbClr val="6B7A90"/>
+                          </a:solidFill>
+                          <a:latin typeface="Arial"/>
+                          <a:ea typeface="Microsoft YaHei"/>
+                        </a:rPr>
+                        <a:t>9.005</a:t>
                       </a:r>
                     </a:p>
                   </a:txBody>
@@ -8728,14 +9958,27 @@
                     <a:p>
                       <a:pPr algn="ctr"/>
                       <a:r>
-                        <a:rPr sz="1500" b="0">
+                        <a:rPr sz="1500" b="1">
                           <a:solidFill>
                             <a:srgbClr val="101F37"/>
                           </a:solidFill>
                           <a:latin typeface="Arial"/>
                           <a:ea typeface="Microsoft YaHei"/>
                         </a:rPr>
-                        <a:t>31.59</a:t>
+                        <a:t>0.445</a:t>
+                      </a:r>
+                    </a:p>
+                    <a:p>
+                      <a:pPr algn="ctr"/>
+                      <a:r>
+                        <a:rPr sz="1100" b="0">
+                          <a:solidFill>
+                            <a:srgbClr val="6B7A90"/>
+                          </a:solidFill>
+                          <a:latin typeface="Arial"/>
+                          <a:ea typeface="Microsoft YaHei"/>
+                        </a:rPr>
+                        <a:t>0.431</a:t>
                       </a:r>
                     </a:p>
                   </a:txBody>
@@ -8752,1849 +9995,20 @@
                     <a:p>
                       <a:pPr algn="ctr"/>
                       <a:r>
-                        <a:rPr sz="1500" b="0">
+                        <a:rPr sz="1500" b="1">
                           <a:solidFill>
                             <a:srgbClr val="101F37"/>
                           </a:solidFill>
                           <a:latin typeface="Arial"/>
                           <a:ea typeface="Microsoft YaHei"/>
                         </a:rPr>
-                        <a:t>0.973</a:t>
-                      </a:r>
-                    </a:p>
-                  </a:txBody>
-                  <a:tcPr anchor="ctr" marL="45720" marR="45720" marT="18288" marB="18288">
-                    <a:solidFill>
-                      <a:srgbClr val="FFFFFF"/>
-                    </a:solidFill>
-                  </a:tcPr>
-                </a:tc>
-                <a:tc>
-                  <a:txBody>
-                    <a:bodyPr/>
-                    <a:lstStyle/>
-                    <a:p>
-                      <a:pPr algn="ctr"/>
-                      <a:r>
-                        <a:rPr sz="1500" b="0">
-                          <a:solidFill>
-                            <a:srgbClr val="101F37"/>
-                          </a:solidFill>
-                          <a:latin typeface="Arial"/>
-                          <a:ea typeface="Microsoft YaHei"/>
-                        </a:rPr>
-                        <a:t>0.029</a:t>
-                      </a:r>
-                    </a:p>
-                  </a:txBody>
-                  <a:tcPr anchor="ctr" marL="45720" marR="45720" marT="18288" marB="18288">
-                    <a:solidFill>
-                      <a:srgbClr val="FFFFFF"/>
-                    </a:solidFill>
-                  </a:tcPr>
-                </a:tc>
-                <a:tc>
-                  <a:txBody>
-                    <a:bodyPr/>
-                    <a:lstStyle/>
-                    <a:p>
-                      <a:pPr algn="ctr"/>
-                      <a:r>
-                        <a:rPr sz="1500" b="0">
-                          <a:solidFill>
-                            <a:srgbClr val="101F37"/>
-                          </a:solidFill>
-                          <a:latin typeface="Arial"/>
-                          <a:ea typeface="Microsoft YaHei"/>
-                        </a:rPr>
-                        <a:t>25.86</a:t>
-                      </a:r>
-                    </a:p>
-                  </a:txBody>
-                  <a:tcPr anchor="ctr" marL="45720" marR="45720" marT="18288" marB="18288">
-                    <a:solidFill>
-                      <a:srgbClr val="FFFFFF"/>
-                    </a:solidFill>
-                  </a:tcPr>
-                </a:tc>
-                <a:tc>
-                  <a:txBody>
-                    <a:bodyPr/>
-                    <a:lstStyle/>
-                    <a:p>
-                      <a:pPr algn="ctr"/>
-                      <a:r>
-                        <a:rPr sz="1500" b="0">
-                          <a:solidFill>
-                            <a:srgbClr val="101F37"/>
-                          </a:solidFill>
-                          <a:latin typeface="Arial"/>
-                          <a:ea typeface="Microsoft YaHei"/>
-                        </a:rPr>
-                        <a:t>0.479</a:t>
-                      </a:r>
-                    </a:p>
-                  </a:txBody>
-                  <a:tcPr anchor="ctr" marL="45720" marR="45720" marT="18288" marB="18288">
-                    <a:solidFill>
-                      <a:srgbClr val="FFFFFF"/>
-                    </a:solidFill>
-                  </a:tcPr>
-                </a:tc>
-                <a:tc>
-                  <a:txBody>
-                    <a:bodyPr/>
-                    <a:lstStyle/>
-                    <a:p>
-                      <a:pPr algn="ctr"/>
-                      <a:r>
-                        <a:rPr sz="1500" b="0">
-                          <a:solidFill>
-                            <a:srgbClr val="101F37"/>
-                          </a:solidFill>
-                          <a:latin typeface="Arial"/>
-                          <a:ea typeface="Microsoft YaHei"/>
-                        </a:rPr>
-                        <a:t>0.0084</a:t>
-                      </a:r>
-                    </a:p>
-                  </a:txBody>
-                  <a:tcPr anchor="ctr" marL="45720" marR="45720" marT="18288" marB="18288">
-                    <a:solidFill>
-                      <a:srgbClr val="FFFFFF"/>
-                    </a:solidFill>
-                  </a:tcPr>
-                </a:tc>
-              </a:tr>
-              <a:tr h="329184">
-                <a:tc vMerge="1">
-                  <a:txBody>
-                    <a:bodyPr/>
-                    <a:lstStyle/>
-                    <a:p>
-                      <a:pPr algn="ctr"/>
-                      <a:r>
-                        <a:rPr sz="1500" b="1">
-                          <a:solidFill>
-                            <a:srgbClr val="101F37"/>
-                          </a:solidFill>
-                          <a:latin typeface="Arial"/>
-                          <a:ea typeface="Microsoft YaHei"/>
-                        </a:rPr>
-                        <a:t/>
-                      </a:r>
-                    </a:p>
-                  </a:txBody>
-                  <a:tcPr anchor="ctr" marL="45720" marR="45720" marT="18288" marB="18288">
-                    <a:solidFill>
-                      <a:srgbClr val="FFFFFF"/>
-                    </a:solidFill>
-                  </a:tcPr>
-                </a:tc>
-                <a:tc>
-                  <a:txBody>
-                    <a:bodyPr/>
-                    <a:lstStyle/>
-                    <a:p>
-                      <a:pPr algn="ctr"/>
-                      <a:r>
-                        <a:rPr sz="1300" b="0">
-                          <a:solidFill>
-                            <a:srgbClr val="6B7A90"/>
-                          </a:solidFill>
-                          <a:latin typeface="Arial"/>
-                          <a:ea typeface="Microsoft YaHei"/>
-                        </a:rPr>
-                        <a:t>论文</a:t>
-                      </a:r>
-                    </a:p>
-                  </a:txBody>
-                  <a:tcPr anchor="ctr" marL="45720" marR="45720" marT="18288" marB="18288">
-                    <a:solidFill>
-                      <a:srgbClr val="FFFFFF"/>
-                    </a:solidFill>
-                  </a:tcPr>
-                </a:tc>
-                <a:tc>
-                  <a:txBody>
-                    <a:bodyPr/>
-                    <a:lstStyle/>
-                    <a:p>
-                      <a:pPr algn="ctr"/>
-                      <a:r>
-                        <a:rPr sz="1300" b="0">
-                          <a:solidFill>
-                            <a:srgbClr val="6B7A90"/>
-                          </a:solidFill>
-                          <a:latin typeface="Arial"/>
-                          <a:ea typeface="Microsoft YaHei"/>
-                        </a:rPr>
-                        <a:t>31.273</a:t>
-                      </a:r>
-                    </a:p>
-                  </a:txBody>
-                  <a:tcPr anchor="ctr" marL="45720" marR="45720" marT="18288" marB="18288">
-                    <a:solidFill>
-                      <a:srgbClr val="FFFFFF"/>
-                    </a:solidFill>
-                  </a:tcPr>
-                </a:tc>
-                <a:tc>
-                  <a:txBody>
-                    <a:bodyPr/>
-                    <a:lstStyle/>
-                    <a:p>
-                      <a:pPr algn="ctr"/>
-                      <a:r>
-                        <a:rPr sz="1300" b="0">
-                          <a:solidFill>
-                            <a:srgbClr val="6B7A90"/>
-                          </a:solidFill>
-                          <a:latin typeface="Arial"/>
-                          <a:ea typeface="Microsoft YaHei"/>
-                        </a:rPr>
-                        <a:t>0.950</a:t>
-                      </a:r>
-                    </a:p>
-                  </a:txBody>
-                  <a:tcPr anchor="ctr" marL="45720" marR="45720" marT="18288" marB="18288">
-                    <a:solidFill>
-                      <a:srgbClr val="FFFFFF"/>
-                    </a:solidFill>
-                  </a:tcPr>
-                </a:tc>
-                <a:tc>
-                  <a:txBody>
-                    <a:bodyPr/>
-                    <a:lstStyle/>
-                    <a:p>
-                      <a:pPr algn="ctr"/>
-                      <a:r>
-                        <a:rPr sz="1300" b="0">
-                          <a:solidFill>
-                            <a:srgbClr val="6B7A90"/>
-                          </a:solidFill>
-                          <a:latin typeface="Arial"/>
-                          <a:ea typeface="Microsoft YaHei"/>
-                        </a:rPr>
-                        <a:t>0.046</a:t>
-                      </a:r>
-                    </a:p>
-                  </a:txBody>
-                  <a:tcPr anchor="ctr" marL="45720" marR="45720" marT="18288" marB="18288">
-                    <a:solidFill>
-                      <a:srgbClr val="FFFFFF"/>
-                    </a:solidFill>
-                  </a:tcPr>
-                </a:tc>
-                <a:tc>
-                  <a:txBody>
-                    <a:bodyPr/>
-                    <a:lstStyle/>
-                    <a:p>
-                      <a:pPr algn="ctr"/>
-                      <a:r>
-                        <a:rPr sz="1300" b="0">
-                          <a:solidFill>
-                            <a:srgbClr val="6B7A90"/>
-                          </a:solidFill>
-                          <a:latin typeface="Arial"/>
-                          <a:ea typeface="Microsoft YaHei"/>
-                        </a:rPr>
-                        <a:t>32.710</a:t>
-                      </a:r>
-                    </a:p>
-                  </a:txBody>
-                  <a:tcPr anchor="ctr" marL="45720" marR="45720" marT="18288" marB="18288">
-                    <a:solidFill>
-                      <a:srgbClr val="FFFFFF"/>
-                    </a:solidFill>
-                  </a:tcPr>
-                </a:tc>
-                <a:tc>
-                  <a:txBody>
-                    <a:bodyPr/>
-                    <a:lstStyle/>
-                    <a:p>
-                      <a:pPr algn="ctr"/>
-                      <a:r>
-                        <a:rPr sz="1300" b="0">
-                          <a:solidFill>
-                            <a:srgbClr val="6B7A90"/>
-                          </a:solidFill>
-                          <a:latin typeface="Arial"/>
-                          <a:ea typeface="Microsoft YaHei"/>
-                        </a:rPr>
-                        <a:t>0.522</a:t>
-                      </a:r>
-                    </a:p>
-                  </a:txBody>
-                  <a:tcPr anchor="ctr" marL="45720" marR="45720" marT="18288" marB="18288">
-                    <a:solidFill>
-                      <a:srgbClr val="FFFFFF"/>
-                    </a:solidFill>
-                  </a:tcPr>
-                </a:tc>
-                <a:tc>
-                  <a:txBody>
-                    <a:bodyPr/>
-                    <a:lstStyle/>
-                    <a:p>
-                      <a:pPr algn="ctr"/>
-                      <a:r>
-                        <a:rPr sz="1300" b="0">
-                          <a:solidFill>
-                            <a:srgbClr val="6B7A90"/>
-                          </a:solidFill>
-                          <a:latin typeface="Arial"/>
-                          <a:ea typeface="Microsoft YaHei"/>
-                        </a:rPr>
-                        <a:t>0.011</a:t>
-                      </a:r>
-                    </a:p>
-                  </a:txBody>
-                  <a:tcPr anchor="ctr" marL="45720" marR="45720" marT="18288" marB="18288">
-                    <a:solidFill>
-                      <a:srgbClr val="FFFFFF"/>
-                    </a:solidFill>
-                  </a:tcPr>
-                </a:tc>
-              </a:tr>
-              <a:tr h="329184">
-                <a:tc rowSpan="2">
-                  <a:txBody>
-                    <a:bodyPr/>
-                    <a:lstStyle/>
-                    <a:p>
-                      <a:pPr algn="ctr"/>
-                      <a:r>
-                        <a:rPr sz="1500" b="1">
-                          <a:solidFill>
-                            <a:srgbClr val="101F37"/>
-                          </a:solidFill>
-                          <a:latin typeface="Arial"/>
-                          <a:ea typeface="Microsoft YaHei"/>
-                        </a:rPr>
-                        <a:t>BokehMe</a:t>
-                      </a:r>
-                    </a:p>
-                  </a:txBody>
-                  <a:tcPr anchor="ctr" marL="45720" marR="45720" marT="18288" marB="18288">
-                    <a:solidFill>
-                      <a:srgbClr val="EEF5FB"/>
-                    </a:solidFill>
-                  </a:tcPr>
-                </a:tc>
-                <a:tc>
-                  <a:txBody>
-                    <a:bodyPr/>
-                    <a:lstStyle/>
-                    <a:p>
-                      <a:pPr algn="ctr"/>
-                      <a:r>
-                        <a:rPr sz="1500" b="0">
-                          <a:solidFill>
-                            <a:srgbClr val="101F37"/>
-                          </a:solidFill>
-                          <a:latin typeface="Arial"/>
-                          <a:ea typeface="Microsoft YaHei"/>
-                        </a:rPr>
-                        <a:t>本项目</a:t>
-                      </a:r>
-                    </a:p>
-                  </a:txBody>
-                  <a:tcPr anchor="ctr" marL="45720" marR="45720" marT="18288" marB="18288">
-                    <a:solidFill>
-                      <a:srgbClr val="EEF5FB"/>
-                    </a:solidFill>
-                  </a:tcPr>
-                </a:tc>
-                <a:tc>
-                  <a:txBody>
-                    <a:bodyPr/>
-                    <a:lstStyle/>
-                    <a:p>
-                      <a:pPr algn="ctr"/>
-                      <a:r>
-                        <a:rPr sz="1500" b="0">
-                          <a:solidFill>
-                            <a:srgbClr val="101F37"/>
-                          </a:solidFill>
-                          <a:latin typeface="Arial"/>
-                          <a:ea typeface="Microsoft YaHei"/>
-                        </a:rPr>
-                        <a:t>33.33</a:t>
-                      </a:r>
-                    </a:p>
-                  </a:txBody>
-                  <a:tcPr anchor="ctr" marL="45720" marR="45720" marT="18288" marB="18288">
-                    <a:solidFill>
-                      <a:srgbClr val="EEF5FB"/>
-                    </a:solidFill>
-                  </a:tcPr>
-                </a:tc>
-                <a:tc>
-                  <a:txBody>
-                    <a:bodyPr/>
-                    <a:lstStyle/>
-                    <a:p>
-                      <a:pPr algn="ctr"/>
-                      <a:r>
-                        <a:rPr sz="1500" b="0">
-                          <a:solidFill>
-                            <a:srgbClr val="101F37"/>
-                          </a:solidFill>
-                          <a:latin typeface="Arial"/>
-                          <a:ea typeface="Microsoft YaHei"/>
-                        </a:rPr>
-                        <a:t>0.979</a:t>
-                      </a:r>
-                    </a:p>
-                  </a:txBody>
-                  <a:tcPr anchor="ctr" marL="45720" marR="45720" marT="18288" marB="18288">
-                    <a:solidFill>
-                      <a:srgbClr val="EEF5FB"/>
-                    </a:solidFill>
-                  </a:tcPr>
-                </a:tc>
-                <a:tc>
-                  <a:txBody>
-                    <a:bodyPr/>
-                    <a:lstStyle/>
-                    <a:p>
-                      <a:pPr algn="ctr"/>
-                      <a:r>
-                        <a:rPr sz="1500" b="0">
-                          <a:solidFill>
-                            <a:srgbClr val="101F37"/>
-                          </a:solidFill>
-                          <a:latin typeface="Arial"/>
-                          <a:ea typeface="Microsoft YaHei"/>
-                        </a:rPr>
-                        <a:t>0.025</a:t>
-                      </a:r>
-                    </a:p>
-                  </a:txBody>
-                  <a:tcPr anchor="ctr" marL="45720" marR="45720" marT="18288" marB="18288">
-                    <a:solidFill>
-                      <a:srgbClr val="EEF5FB"/>
-                    </a:solidFill>
-                  </a:tcPr>
-                </a:tc>
-                <a:tc>
-                  <a:txBody>
-                    <a:bodyPr/>
-                    <a:lstStyle/>
-                    <a:p>
-                      <a:pPr algn="ctr"/>
-                      <a:r>
-                        <a:rPr sz="1500" b="0">
-                          <a:solidFill>
-                            <a:srgbClr val="101F37"/>
-                          </a:solidFill>
-                          <a:latin typeface="Arial"/>
-                          <a:ea typeface="Microsoft YaHei"/>
-                        </a:rPr>
-                        <a:t>18.55</a:t>
-                      </a:r>
-                    </a:p>
-                  </a:txBody>
-                  <a:tcPr anchor="ctr" marL="45720" marR="45720" marT="18288" marB="18288">
-                    <a:solidFill>
-                      <a:srgbClr val="EEF5FB"/>
-                    </a:solidFill>
-                  </a:tcPr>
-                </a:tc>
-                <a:tc>
-                  <a:txBody>
-                    <a:bodyPr/>
-                    <a:lstStyle/>
-                    <a:p>
-                      <a:pPr algn="ctr"/>
-                      <a:r>
-                        <a:rPr sz="1500" b="0">
-                          <a:solidFill>
-                            <a:srgbClr val="101F37"/>
-                          </a:solidFill>
-                          <a:latin typeface="Arial"/>
-                          <a:ea typeface="Microsoft YaHei"/>
-                        </a:rPr>
-                        <a:t>0.540</a:t>
-                      </a:r>
-                    </a:p>
-                  </a:txBody>
-                  <a:tcPr anchor="ctr" marL="45720" marR="45720" marT="18288" marB="18288">
-                    <a:solidFill>
-                      <a:srgbClr val="EEF5FB"/>
-                    </a:solidFill>
-                  </a:tcPr>
-                </a:tc>
-                <a:tc>
-                  <a:txBody>
-                    <a:bodyPr/>
-                    <a:lstStyle/>
-                    <a:p>
-                      <a:pPr algn="ctr"/>
-                      <a:r>
-                        <a:rPr sz="1500" b="0">
-                          <a:solidFill>
-                            <a:srgbClr val="101F37"/>
-                          </a:solidFill>
-                          <a:latin typeface="Arial"/>
-                          <a:ea typeface="Microsoft YaHei"/>
-                        </a:rPr>
-                        <a:t>0.0074</a:t>
-                      </a:r>
-                    </a:p>
-                  </a:txBody>
-                  <a:tcPr anchor="ctr" marL="45720" marR="45720" marT="18288" marB="18288">
-                    <a:solidFill>
-                      <a:srgbClr val="EEF5FB"/>
-                    </a:solidFill>
-                  </a:tcPr>
-                </a:tc>
-              </a:tr>
-              <a:tr h="329184">
-                <a:tc vMerge="1">
-                  <a:txBody>
-                    <a:bodyPr/>
-                    <a:lstStyle/>
-                    <a:p>
-                      <a:pPr algn="ctr"/>
-                      <a:r>
-                        <a:rPr sz="1500" b="1">
-                          <a:solidFill>
-                            <a:srgbClr val="101F37"/>
-                          </a:solidFill>
-                          <a:latin typeface="Arial"/>
-                          <a:ea typeface="Microsoft YaHei"/>
-                        </a:rPr>
-                        <a:t/>
-                      </a:r>
-                    </a:p>
-                  </a:txBody>
-                  <a:tcPr anchor="ctr" marL="45720" marR="45720" marT="18288" marB="18288">
-                    <a:solidFill>
-                      <a:srgbClr val="EEF5FB"/>
-                    </a:solidFill>
-                  </a:tcPr>
-                </a:tc>
-                <a:tc>
-                  <a:txBody>
-                    <a:bodyPr/>
-                    <a:lstStyle/>
-                    <a:p>
-                      <a:pPr algn="ctr"/>
-                      <a:r>
-                        <a:rPr sz="1300" b="0">
-                          <a:solidFill>
-                            <a:srgbClr val="6B7A90"/>
-                          </a:solidFill>
-                          <a:latin typeface="Arial"/>
-                          <a:ea typeface="Microsoft YaHei"/>
-                        </a:rPr>
-                        <a:t>论文</a:t>
-                      </a:r>
-                    </a:p>
-                  </a:txBody>
-                  <a:tcPr anchor="ctr" marL="45720" marR="45720" marT="18288" marB="18288">
-                    <a:solidFill>
-                      <a:srgbClr val="EEF5FB"/>
-                    </a:solidFill>
-                  </a:tcPr>
-                </a:tc>
-                <a:tc>
-                  <a:txBody>
-                    <a:bodyPr/>
-                    <a:lstStyle/>
-                    <a:p>
-                      <a:pPr algn="ctr"/>
-                      <a:r>
-                        <a:rPr sz="1300" b="0">
-                          <a:solidFill>
-                            <a:srgbClr val="6B7A90"/>
-                          </a:solidFill>
-                          <a:latin typeface="Arial"/>
-                          <a:ea typeface="Microsoft YaHei"/>
-                        </a:rPr>
-                        <a:t>27.992</a:t>
-                      </a:r>
-                    </a:p>
-                  </a:txBody>
-                  <a:tcPr anchor="ctr" marL="45720" marR="45720" marT="18288" marB="18288">
-                    <a:solidFill>
-                      <a:srgbClr val="EEF5FB"/>
-                    </a:solidFill>
-                  </a:tcPr>
-                </a:tc>
-                <a:tc>
-                  <a:txBody>
-                    <a:bodyPr/>
-                    <a:lstStyle/>
-                    <a:p>
-                      <a:pPr algn="ctr"/>
-                      <a:r>
-                        <a:rPr sz="1300" b="0">
-                          <a:solidFill>
-                            <a:srgbClr val="6B7A90"/>
-                          </a:solidFill>
-                          <a:latin typeface="Arial"/>
-                          <a:ea typeface="Microsoft YaHei"/>
-                        </a:rPr>
-                        <a:t>0.936</a:t>
-                      </a:r>
-                    </a:p>
-                  </a:txBody>
-                  <a:tcPr anchor="ctr" marL="45720" marR="45720" marT="18288" marB="18288">
-                    <a:solidFill>
-                      <a:srgbClr val="EEF5FB"/>
-                    </a:solidFill>
-                  </a:tcPr>
-                </a:tc>
-                <a:tc>
-                  <a:txBody>
-                    <a:bodyPr/>
-                    <a:lstStyle/>
-                    <a:p>
-                      <a:pPr algn="ctr"/>
-                      <a:r>
-                        <a:rPr sz="1300" b="0">
-                          <a:solidFill>
-                            <a:srgbClr val="6B7A90"/>
-                          </a:solidFill>
-                          <a:latin typeface="Arial"/>
-                          <a:ea typeface="Microsoft YaHei"/>
-                        </a:rPr>
-                        <a:t>0.060</a:t>
-                      </a:r>
-                    </a:p>
-                  </a:txBody>
-                  <a:tcPr anchor="ctr" marL="45720" marR="45720" marT="18288" marB="18288">
-                    <a:solidFill>
-                      <a:srgbClr val="EEF5FB"/>
-                    </a:solidFill>
-                  </a:tcPr>
-                </a:tc>
-                <a:tc>
-                  <a:txBody>
-                    <a:bodyPr/>
-                    <a:lstStyle/>
-                    <a:p>
-                      <a:pPr algn="ctr"/>
-                      <a:r>
-                        <a:rPr sz="1300" b="0">
-                          <a:solidFill>
-                            <a:srgbClr val="6B7A90"/>
-                          </a:solidFill>
-                          <a:latin typeface="Arial"/>
-                          <a:ea typeface="Microsoft YaHei"/>
-                        </a:rPr>
-                        <a:t>39.102</a:t>
-                      </a:r>
-                    </a:p>
-                  </a:txBody>
-                  <a:tcPr anchor="ctr" marL="45720" marR="45720" marT="18288" marB="18288">
-                    <a:solidFill>
-                      <a:srgbClr val="EEF5FB"/>
-                    </a:solidFill>
-                  </a:tcPr>
-                </a:tc>
-                <a:tc>
-                  <a:txBody>
-                    <a:bodyPr/>
-                    <a:lstStyle/>
-                    <a:p>
-                      <a:pPr algn="ctr"/>
-                      <a:r>
-                        <a:rPr sz="1300" b="0">
-                          <a:solidFill>
-                            <a:srgbClr val="6B7A90"/>
-                          </a:solidFill>
-                          <a:latin typeface="Arial"/>
-                          <a:ea typeface="Microsoft YaHei"/>
-                        </a:rPr>
-                        <a:t>0.536</a:t>
-                      </a:r>
-                    </a:p>
-                  </a:txBody>
-                  <a:tcPr anchor="ctr" marL="45720" marR="45720" marT="18288" marB="18288">
-                    <a:solidFill>
-                      <a:srgbClr val="EEF5FB"/>
-                    </a:solidFill>
-                  </a:tcPr>
-                </a:tc>
-                <a:tc>
-                  <a:txBody>
-                    <a:bodyPr/>
-                    <a:lstStyle/>
-                    <a:p>
-                      <a:pPr algn="ctr"/>
-                      <a:r>
-                        <a:rPr sz="1300" b="0">
-                          <a:solidFill>
-                            <a:srgbClr val="6B7A90"/>
-                          </a:solidFill>
-                          <a:latin typeface="Arial"/>
-                          <a:ea typeface="Microsoft YaHei"/>
-                        </a:rPr>
-                        <a:t>0.013</a:t>
-                      </a:r>
-                    </a:p>
-                  </a:txBody>
-                  <a:tcPr anchor="ctr" marL="45720" marR="45720" marT="18288" marB="18288">
-                    <a:solidFill>
-                      <a:srgbClr val="EEF5FB"/>
-                    </a:solidFill>
-                  </a:tcPr>
-                </a:tc>
-              </a:tr>
-              <a:tr h="329184">
-                <a:tc rowSpan="2">
-                  <a:txBody>
-                    <a:bodyPr/>
-                    <a:lstStyle/>
-                    <a:p>
-                      <a:pPr algn="ctr"/>
-                      <a:r>
-                        <a:rPr sz="1500" b="1">
-                          <a:solidFill>
-                            <a:srgbClr val="101F37"/>
-                          </a:solidFill>
-                          <a:latin typeface="Arial"/>
-                          <a:ea typeface="Microsoft YaHei"/>
-                        </a:rPr>
-                        <a:t>MPIB</a:t>
-                      </a:r>
-                    </a:p>
-                  </a:txBody>
-                  <a:tcPr anchor="ctr" marL="45720" marR="45720" marT="18288" marB="18288">
-                    <a:solidFill>
-                      <a:srgbClr val="FFFFFF"/>
-                    </a:solidFill>
-                  </a:tcPr>
-                </a:tc>
-                <a:tc>
-                  <a:txBody>
-                    <a:bodyPr/>
-                    <a:lstStyle/>
-                    <a:p>
-                      <a:pPr algn="ctr"/>
-                      <a:r>
-                        <a:rPr sz="1500" b="0">
-                          <a:solidFill>
-                            <a:srgbClr val="101F37"/>
-                          </a:solidFill>
-                          <a:latin typeface="Arial"/>
-                          <a:ea typeface="Microsoft YaHei"/>
-                        </a:rPr>
-                        <a:t>本项目</a:t>
-                      </a:r>
-                    </a:p>
-                  </a:txBody>
-                  <a:tcPr anchor="ctr" marL="45720" marR="45720" marT="18288" marB="18288">
-                    <a:solidFill>
-                      <a:srgbClr val="FFFFFF"/>
-                    </a:solidFill>
-                  </a:tcPr>
-                </a:tc>
-                <a:tc>
-                  <a:txBody>
-                    <a:bodyPr/>
-                    <a:lstStyle/>
-                    <a:p>
-                      <a:pPr algn="ctr"/>
-                      <a:r>
-                        <a:rPr sz="1500" b="0">
-                          <a:solidFill>
-                            <a:srgbClr val="101F37"/>
-                          </a:solidFill>
-                          <a:latin typeface="Arial"/>
-                          <a:ea typeface="Microsoft YaHei"/>
-                        </a:rPr>
-                        <a:t>31.62</a:t>
-                      </a:r>
-                    </a:p>
-                  </a:txBody>
-                  <a:tcPr anchor="ctr" marL="45720" marR="45720" marT="18288" marB="18288">
-                    <a:solidFill>
-                      <a:srgbClr val="FFFFFF"/>
-                    </a:solidFill>
-                  </a:tcPr>
-                </a:tc>
-                <a:tc>
-                  <a:txBody>
-                    <a:bodyPr/>
-                    <a:lstStyle/>
-                    <a:p>
-                      <a:pPr algn="ctr"/>
-                      <a:r>
-                        <a:rPr sz="1500" b="0">
-                          <a:solidFill>
-                            <a:srgbClr val="101F37"/>
-                          </a:solidFill>
-                          <a:latin typeface="Arial"/>
-                          <a:ea typeface="Microsoft YaHei"/>
-                        </a:rPr>
-                        <a:t>0.974</a:t>
-                      </a:r>
-                    </a:p>
-                  </a:txBody>
-                  <a:tcPr anchor="ctr" marL="45720" marR="45720" marT="18288" marB="18288">
-                    <a:solidFill>
-                      <a:srgbClr val="FFFFFF"/>
-                    </a:solidFill>
-                  </a:tcPr>
-                </a:tc>
-                <a:tc>
-                  <a:txBody>
-                    <a:bodyPr/>
-                    <a:lstStyle/>
-                    <a:p>
-                      <a:pPr algn="ctr"/>
-                      <a:r>
-                        <a:rPr sz="1500" b="0">
-                          <a:solidFill>
-                            <a:srgbClr val="101F37"/>
-                          </a:solidFill>
-                          <a:latin typeface="Arial"/>
-                          <a:ea typeface="Microsoft YaHei"/>
-                        </a:rPr>
-                        <a:t>0.028</a:t>
-                      </a:r>
-                    </a:p>
-                  </a:txBody>
-                  <a:tcPr anchor="ctr" marL="45720" marR="45720" marT="18288" marB="18288">
-                    <a:solidFill>
-                      <a:srgbClr val="FFFFFF"/>
-                    </a:solidFill>
-                  </a:tcPr>
-                </a:tc>
-                <a:tc>
-                  <a:txBody>
-                    <a:bodyPr/>
-                    <a:lstStyle/>
-                    <a:p>
-                      <a:pPr algn="ctr"/>
-                      <a:r>
-                        <a:rPr sz="1500" b="0">
-                          <a:solidFill>
-                            <a:srgbClr val="101F37"/>
-                          </a:solidFill>
-                          <a:latin typeface="Arial"/>
-                          <a:ea typeface="Microsoft YaHei"/>
-                        </a:rPr>
-                        <a:t>24.96</a:t>
-                      </a:r>
-                    </a:p>
-                  </a:txBody>
-                  <a:tcPr anchor="ctr" marL="45720" marR="45720" marT="18288" marB="18288">
-                    <a:solidFill>
-                      <a:srgbClr val="FFFFFF"/>
-                    </a:solidFill>
-                  </a:tcPr>
-                </a:tc>
-                <a:tc>
-                  <a:txBody>
-                    <a:bodyPr/>
-                    <a:lstStyle/>
-                    <a:p>
-                      <a:pPr algn="ctr"/>
-                      <a:r>
-                        <a:rPr sz="1500" b="0">
-                          <a:solidFill>
-                            <a:srgbClr val="101F37"/>
-                          </a:solidFill>
-                          <a:latin typeface="Arial"/>
-                          <a:ea typeface="Microsoft YaHei"/>
-                        </a:rPr>
-                        <a:t>0.450</a:t>
-                      </a:r>
-                    </a:p>
-                  </a:txBody>
-                  <a:tcPr anchor="ctr" marL="45720" marR="45720" marT="18288" marB="18288">
-                    <a:solidFill>
-                      <a:srgbClr val="FFFFFF"/>
-                    </a:solidFill>
-                  </a:tcPr>
-                </a:tc>
-                <a:tc>
-                  <a:txBody>
-                    <a:bodyPr/>
-                    <a:lstStyle/>
-                    <a:p>
-                      <a:pPr algn="ctr"/>
-                      <a:r>
-                        <a:rPr sz="1500" b="0">
-                          <a:solidFill>
-                            <a:srgbClr val="101F37"/>
-                          </a:solidFill>
-                          <a:latin typeface="Arial"/>
-                          <a:ea typeface="Microsoft YaHei"/>
-                        </a:rPr>
-                        <a:t>0.0082</a:t>
-                      </a:r>
-                    </a:p>
-                  </a:txBody>
-                  <a:tcPr anchor="ctr" marL="45720" marR="45720" marT="18288" marB="18288">
-                    <a:solidFill>
-                      <a:srgbClr val="FFFFFF"/>
-                    </a:solidFill>
-                  </a:tcPr>
-                </a:tc>
-              </a:tr>
-              <a:tr h="329184">
-                <a:tc vMerge="1">
-                  <a:txBody>
-                    <a:bodyPr/>
-                    <a:lstStyle/>
-                    <a:p>
-                      <a:pPr algn="ctr"/>
-                      <a:r>
-                        <a:rPr sz="1500" b="1">
-                          <a:solidFill>
-                            <a:srgbClr val="101F37"/>
-                          </a:solidFill>
-                          <a:latin typeface="Arial"/>
-                          <a:ea typeface="Microsoft YaHei"/>
-                        </a:rPr>
-                        <a:t/>
-                      </a:r>
-                    </a:p>
-                  </a:txBody>
-                  <a:tcPr anchor="ctr" marL="45720" marR="45720" marT="18288" marB="18288">
-                    <a:solidFill>
-                      <a:srgbClr val="FFFFFF"/>
-                    </a:solidFill>
-                  </a:tcPr>
-                </a:tc>
-                <a:tc>
-                  <a:txBody>
-                    <a:bodyPr/>
-                    <a:lstStyle/>
-                    <a:p>
-                      <a:pPr algn="ctr"/>
-                      <a:r>
-                        <a:rPr sz="1300" b="0">
-                          <a:solidFill>
-                            <a:srgbClr val="6B7A90"/>
-                          </a:solidFill>
-                          <a:latin typeface="Arial"/>
-                          <a:ea typeface="Microsoft YaHei"/>
-                        </a:rPr>
-                        <a:t>论文</a:t>
-                      </a:r>
-                    </a:p>
-                  </a:txBody>
-                  <a:tcPr anchor="ctr" marL="45720" marR="45720" marT="18288" marB="18288">
-                    <a:solidFill>
-                      <a:srgbClr val="FFFFFF"/>
-                    </a:solidFill>
-                  </a:tcPr>
-                </a:tc>
-                <a:tc>
-                  <a:txBody>
-                    <a:bodyPr/>
-                    <a:lstStyle/>
-                    <a:p>
-                      <a:pPr algn="ctr"/>
-                      <a:r>
-                        <a:rPr sz="1300" b="0">
-                          <a:solidFill>
-                            <a:srgbClr val="6B7A90"/>
-                          </a:solidFill>
-                          <a:latin typeface="Arial"/>
-                          <a:ea typeface="Microsoft YaHei"/>
-                        </a:rPr>
-                        <a:t>31.390</a:t>
-                      </a:r>
-                    </a:p>
-                  </a:txBody>
-                  <a:tcPr anchor="ctr" marL="45720" marR="45720" marT="18288" marB="18288">
-                    <a:solidFill>
-                      <a:srgbClr val="FFFFFF"/>
-                    </a:solidFill>
-                  </a:tcPr>
-                </a:tc>
-                <a:tc>
-                  <a:txBody>
-                    <a:bodyPr/>
-                    <a:lstStyle/>
-                    <a:p>
-                      <a:pPr algn="ctr"/>
-                      <a:r>
-                        <a:rPr sz="1300" b="0">
-                          <a:solidFill>
-                            <a:srgbClr val="6B7A90"/>
-                          </a:solidFill>
-                          <a:latin typeface="Arial"/>
-                          <a:ea typeface="Microsoft YaHei"/>
-                        </a:rPr>
-                        <a:t>0.950</a:t>
-                      </a:r>
-                    </a:p>
-                  </a:txBody>
-                  <a:tcPr anchor="ctr" marL="45720" marR="45720" marT="18288" marB="18288">
-                    <a:solidFill>
-                      <a:srgbClr val="FFFFFF"/>
-                    </a:solidFill>
-                  </a:tcPr>
-                </a:tc>
-                <a:tc>
-                  <a:txBody>
-                    <a:bodyPr/>
-                    <a:lstStyle/>
-                    <a:p>
-                      <a:pPr algn="ctr"/>
-                      <a:r>
-                        <a:rPr sz="1300" b="0">
-                          <a:solidFill>
-                            <a:srgbClr val="6B7A90"/>
-                          </a:solidFill>
-                          <a:latin typeface="Arial"/>
-                          <a:ea typeface="Microsoft YaHei"/>
-                        </a:rPr>
-                        <a:t>0.040</a:t>
-                      </a:r>
-                    </a:p>
-                  </a:txBody>
-                  <a:tcPr anchor="ctr" marL="45720" marR="45720" marT="18288" marB="18288">
-                    <a:solidFill>
-                      <a:srgbClr val="FFFFFF"/>
-                    </a:solidFill>
-                  </a:tcPr>
-                </a:tc>
-                <a:tc>
-                  <a:txBody>
-                    <a:bodyPr/>
-                    <a:lstStyle/>
-                    <a:p>
-                      <a:pPr algn="ctr"/>
-                      <a:r>
-                        <a:rPr sz="1300" b="0">
-                          <a:solidFill>
-                            <a:srgbClr val="6B7A90"/>
-                          </a:solidFill>
-                          <a:latin typeface="Arial"/>
-                          <a:ea typeface="Microsoft YaHei"/>
-                        </a:rPr>
-                        <a:t>35.766</a:t>
-                      </a:r>
-                    </a:p>
-                  </a:txBody>
-                  <a:tcPr anchor="ctr" marL="45720" marR="45720" marT="18288" marB="18288">
-                    <a:solidFill>
-                      <a:srgbClr val="FFFFFF"/>
-                    </a:solidFill>
-                  </a:tcPr>
-                </a:tc>
-                <a:tc>
-                  <a:txBody>
-                    <a:bodyPr/>
-                    <a:lstStyle/>
-                    <a:p>
-                      <a:pPr algn="ctr"/>
-                      <a:r>
-                        <a:rPr sz="1300" b="0">
-                          <a:solidFill>
-                            <a:srgbClr val="6B7A90"/>
-                          </a:solidFill>
-                          <a:latin typeface="Arial"/>
-                          <a:ea typeface="Microsoft YaHei"/>
-                        </a:rPr>
-                        <a:t>0.481</a:t>
-                      </a:r>
-                    </a:p>
-                  </a:txBody>
-                  <a:tcPr anchor="ctr" marL="45720" marR="45720" marT="18288" marB="18288">
-                    <a:solidFill>
-                      <a:srgbClr val="FFFFFF"/>
-                    </a:solidFill>
-                  </a:tcPr>
-                </a:tc>
-                <a:tc>
-                  <a:txBody>
-                    <a:bodyPr/>
-                    <a:lstStyle/>
-                    <a:p>
-                      <a:pPr algn="ctr"/>
-                      <a:r>
-                        <a:rPr sz="1300" b="0">
-                          <a:solidFill>
-                            <a:srgbClr val="6B7A90"/>
-                          </a:solidFill>
-                          <a:latin typeface="Arial"/>
-                          <a:ea typeface="Microsoft YaHei"/>
-                        </a:rPr>
-                        <a:t>0.011</a:t>
-                      </a:r>
-                    </a:p>
-                  </a:txBody>
-                  <a:tcPr anchor="ctr" marL="45720" marR="45720" marT="18288" marB="18288">
-                    <a:solidFill>
-                      <a:srgbClr val="FFFFFF"/>
-                    </a:solidFill>
-                  </a:tcPr>
-                </a:tc>
-              </a:tr>
-              <a:tr h="329184">
-                <a:tc rowSpan="2">
-                  <a:txBody>
-                    <a:bodyPr/>
-                    <a:lstStyle/>
-                    <a:p>
-                      <a:pPr algn="ctr"/>
-                      <a:r>
-                        <a:rPr sz="1500" b="1">
-                          <a:solidFill>
-                            <a:srgbClr val="101F37"/>
-                          </a:solidFill>
-                          <a:latin typeface="Arial"/>
-                          <a:ea typeface="Microsoft YaHei"/>
-                        </a:rPr>
-                        <a:t>BokehDiff</a:t>
-                      </a:r>
-                    </a:p>
-                  </a:txBody>
-                  <a:tcPr anchor="ctr" marL="45720" marR="45720" marT="18288" marB="18288">
-                    <a:solidFill>
-                      <a:srgbClr val="EEF5FB"/>
-                    </a:solidFill>
-                  </a:tcPr>
-                </a:tc>
-                <a:tc>
-                  <a:txBody>
-                    <a:bodyPr/>
-                    <a:lstStyle/>
-                    <a:p>
-                      <a:pPr algn="ctr"/>
-                      <a:r>
-                        <a:rPr sz="1500" b="0">
-                          <a:solidFill>
-                            <a:srgbClr val="101F37"/>
-                          </a:solidFill>
-                          <a:latin typeface="Arial"/>
-                          <a:ea typeface="Microsoft YaHei"/>
-                        </a:rPr>
-                        <a:t>本项目</a:t>
-                      </a:r>
-                    </a:p>
-                  </a:txBody>
-                  <a:tcPr anchor="ctr" marL="45720" marR="45720" marT="18288" marB="18288">
-                    <a:solidFill>
-                      <a:srgbClr val="EEF5FB"/>
-                    </a:solidFill>
-                  </a:tcPr>
-                </a:tc>
-                <a:tc>
-                  <a:txBody>
-                    <a:bodyPr/>
-                    <a:lstStyle/>
-                    <a:p>
-                      <a:pPr algn="ctr"/>
-                      <a:r>
-                        <a:rPr sz="1500" b="0">
-                          <a:solidFill>
-                            <a:srgbClr val="101F37"/>
-                          </a:solidFill>
-                          <a:latin typeface="Arial"/>
-                          <a:ea typeface="Microsoft YaHei"/>
-                        </a:rPr>
-                        <a:t>27.06</a:t>
-                      </a:r>
-                    </a:p>
-                  </a:txBody>
-                  <a:tcPr anchor="ctr" marL="45720" marR="45720" marT="18288" marB="18288">
-                    <a:solidFill>
-                      <a:srgbClr val="EEF5FB"/>
-                    </a:solidFill>
-                  </a:tcPr>
-                </a:tc>
-                <a:tc>
-                  <a:txBody>
-                    <a:bodyPr/>
-                    <a:lstStyle/>
-                    <a:p>
-                      <a:pPr algn="ctr"/>
-                      <a:r>
-                        <a:rPr sz="1500" b="0">
-                          <a:solidFill>
-                            <a:srgbClr val="101F37"/>
-                          </a:solidFill>
-                          <a:latin typeface="Arial"/>
-                          <a:ea typeface="Microsoft YaHei"/>
-                        </a:rPr>
-                        <a:t>0.844</a:t>
-                      </a:r>
-                    </a:p>
-                  </a:txBody>
-                  <a:tcPr anchor="ctr" marL="45720" marR="45720" marT="18288" marB="18288">
-                    <a:solidFill>
-                      <a:srgbClr val="EEF5FB"/>
-                    </a:solidFill>
-                  </a:tcPr>
-                </a:tc>
-                <a:tc>
-                  <a:txBody>
-                    <a:bodyPr/>
-                    <a:lstStyle/>
-                    <a:p>
-                      <a:pPr algn="ctr"/>
-                      <a:r>
-                        <a:rPr sz="1500" b="0">
-                          <a:solidFill>
-                            <a:srgbClr val="101F37"/>
-                          </a:solidFill>
-                          <a:latin typeface="Arial"/>
-                          <a:ea typeface="Microsoft YaHei"/>
-                        </a:rPr>
-                        <a:t>0.132</a:t>
-                      </a:r>
-                    </a:p>
-                  </a:txBody>
-                  <a:tcPr anchor="ctr" marL="45720" marR="45720" marT="18288" marB="18288">
-                    <a:solidFill>
-                      <a:srgbClr val="EEF5FB"/>
-                    </a:solidFill>
-                  </a:tcPr>
-                </a:tc>
-                <a:tc>
-                  <a:txBody>
-                    <a:bodyPr/>
-                    <a:lstStyle/>
-                    <a:p>
-                      <a:pPr algn="ctr"/>
-                      <a:r>
-                        <a:rPr sz="1500" b="0">
-                          <a:solidFill>
-                            <a:srgbClr val="101F37"/>
-                          </a:solidFill>
-                          <a:latin typeface="Arial"/>
-                          <a:ea typeface="Microsoft YaHei"/>
-                        </a:rPr>
-                        <a:t>66.00</a:t>
-                      </a:r>
-                    </a:p>
-                  </a:txBody>
-                  <a:tcPr anchor="ctr" marL="45720" marR="45720" marT="18288" marB="18288">
-                    <a:solidFill>
-                      <a:srgbClr val="EEF5FB"/>
-                    </a:solidFill>
-                  </a:tcPr>
-                </a:tc>
-                <a:tc>
-                  <a:txBody>
-                    <a:bodyPr/>
-                    <a:lstStyle/>
-                    <a:p>
-                      <a:pPr algn="ctr"/>
-                      <a:r>
-                        <a:rPr sz="1500" b="0">
-                          <a:solidFill>
-                            <a:srgbClr val="101F37"/>
-                          </a:solidFill>
-                          <a:latin typeface="Arial"/>
-                          <a:ea typeface="Microsoft YaHei"/>
-                        </a:rPr>
-                        <a:t>0.802</a:t>
-                      </a:r>
-                    </a:p>
-                  </a:txBody>
-                  <a:tcPr anchor="ctr" marL="45720" marR="45720" marT="18288" marB="18288">
-                    <a:solidFill>
-                      <a:srgbClr val="EEF5FB"/>
-                    </a:solidFill>
-                  </a:tcPr>
-                </a:tc>
-                <a:tc>
-                  <a:txBody>
-                    <a:bodyPr/>
-                    <a:lstStyle/>
-                    <a:p>
-                      <a:pPr algn="ctr"/>
-                      <a:r>
-                        <a:rPr sz="1500" b="0">
-                          <a:solidFill>
-                            <a:srgbClr val="101F37"/>
-                          </a:solidFill>
-                          <a:latin typeface="Arial"/>
-                          <a:ea typeface="Microsoft YaHei"/>
-                        </a:rPr>
-                        <a:t>0.0216</a:t>
-                      </a:r>
-                    </a:p>
-                  </a:txBody>
-                  <a:tcPr anchor="ctr" marL="45720" marR="45720" marT="18288" marB="18288">
-                    <a:solidFill>
-                      <a:srgbClr val="EEF5FB"/>
-                    </a:solidFill>
-                  </a:tcPr>
-                </a:tc>
-              </a:tr>
-              <a:tr h="329184">
-                <a:tc vMerge="1">
-                  <a:txBody>
-                    <a:bodyPr/>
-                    <a:lstStyle/>
-                    <a:p>
-                      <a:pPr algn="ctr"/>
-                      <a:r>
-                        <a:rPr sz="1500" b="1">
-                          <a:solidFill>
-                            <a:srgbClr val="101F37"/>
-                          </a:solidFill>
-                          <a:latin typeface="Arial"/>
-                          <a:ea typeface="Microsoft YaHei"/>
-                        </a:rPr>
-                        <a:t/>
-                      </a:r>
-                    </a:p>
-                  </a:txBody>
-                  <a:tcPr anchor="ctr" marL="45720" marR="45720" marT="18288" marB="18288">
-                    <a:solidFill>
-                      <a:srgbClr val="EEF5FB"/>
-                    </a:solidFill>
-                  </a:tcPr>
-                </a:tc>
-                <a:tc>
-                  <a:txBody>
-                    <a:bodyPr/>
-                    <a:lstStyle/>
-                    <a:p>
-                      <a:pPr algn="ctr"/>
-                      <a:r>
-                        <a:rPr sz="1300" b="0">
-                          <a:solidFill>
-                            <a:srgbClr val="6B7A90"/>
-                          </a:solidFill>
-                          <a:latin typeface="Arial"/>
-                          <a:ea typeface="Microsoft YaHei"/>
-                        </a:rPr>
-                        <a:t>论文</a:t>
-                      </a:r>
-                    </a:p>
-                  </a:txBody>
-                  <a:tcPr anchor="ctr" marL="45720" marR="45720" marT="18288" marB="18288">
-                    <a:solidFill>
-                      <a:srgbClr val="EEF5FB"/>
-                    </a:solidFill>
-                  </a:tcPr>
-                </a:tc>
-                <a:tc>
-                  <a:txBody>
-                    <a:bodyPr/>
-                    <a:lstStyle/>
-                    <a:p>
-                      <a:pPr algn="ctr"/>
-                      <a:r>
-                        <a:rPr sz="1300" b="0">
-                          <a:solidFill>
-                            <a:srgbClr val="6B7A90"/>
-                          </a:solidFill>
-                          <a:latin typeface="Arial"/>
-                          <a:ea typeface="Microsoft YaHei"/>
-                        </a:rPr>
-                        <a:t>27.525</a:t>
-                      </a:r>
-                    </a:p>
-                  </a:txBody>
-                  <a:tcPr anchor="ctr" marL="45720" marR="45720" marT="18288" marB="18288">
-                    <a:solidFill>
-                      <a:srgbClr val="EEF5FB"/>
-                    </a:solidFill>
-                  </a:tcPr>
-                </a:tc>
-                <a:tc>
-                  <a:txBody>
-                    <a:bodyPr/>
-                    <a:lstStyle/>
-                    <a:p>
-                      <a:pPr algn="ctr"/>
-                      <a:r>
-                        <a:rPr sz="1300" b="0">
-                          <a:solidFill>
-                            <a:srgbClr val="6B7A90"/>
-                          </a:solidFill>
-                          <a:latin typeface="Arial"/>
-                          <a:ea typeface="Microsoft YaHei"/>
-                        </a:rPr>
-                        <a:t>0.834</a:t>
-                      </a:r>
-                    </a:p>
-                  </a:txBody>
-                  <a:tcPr anchor="ctr" marL="45720" marR="45720" marT="18288" marB="18288">
-                    <a:solidFill>
-                      <a:srgbClr val="EEF5FB"/>
-                    </a:solidFill>
-                  </a:tcPr>
-                </a:tc>
-                <a:tc>
-                  <a:txBody>
-                    <a:bodyPr/>
-                    <a:lstStyle/>
-                    <a:p>
-                      <a:pPr algn="ctr"/>
-                      <a:r>
-                        <a:rPr sz="1300" b="0">
-                          <a:solidFill>
-                            <a:srgbClr val="6B7A90"/>
-                          </a:solidFill>
-                          <a:latin typeface="Arial"/>
-                          <a:ea typeface="Microsoft YaHei"/>
-                        </a:rPr>
-                        <a:t>0.127</a:t>
-                      </a:r>
-                    </a:p>
-                  </a:txBody>
-                  <a:tcPr anchor="ctr" marL="45720" marR="45720" marT="18288" marB="18288">
-                    <a:solidFill>
-                      <a:srgbClr val="EEF5FB"/>
-                    </a:solidFill>
-                  </a:tcPr>
-                </a:tc>
-                <a:tc>
-                  <a:txBody>
-                    <a:bodyPr/>
-                    <a:lstStyle/>
-                    <a:p>
-                      <a:pPr algn="ctr"/>
-                      <a:r>
-                        <a:rPr sz="1300" b="0">
-                          <a:solidFill>
-                            <a:srgbClr val="6B7A90"/>
-                          </a:solidFill>
-                          <a:latin typeface="Arial"/>
-                          <a:ea typeface="Microsoft YaHei"/>
-                        </a:rPr>
-                        <a:t>65.678</a:t>
-                      </a:r>
-                    </a:p>
-                  </a:txBody>
-                  <a:tcPr anchor="ctr" marL="45720" marR="45720" marT="18288" marB="18288">
-                    <a:solidFill>
-                      <a:srgbClr val="EEF5FB"/>
-                    </a:solidFill>
-                  </a:tcPr>
-                </a:tc>
-                <a:tc>
-                  <a:txBody>
-                    <a:bodyPr/>
-                    <a:lstStyle/>
-                    <a:p>
-                      <a:pPr algn="ctr"/>
-                      <a:r>
-                        <a:rPr sz="1300" b="0">
-                          <a:solidFill>
-                            <a:srgbClr val="6B7A90"/>
-                          </a:solidFill>
-                          <a:latin typeface="Arial"/>
-                          <a:ea typeface="Microsoft YaHei"/>
-                        </a:rPr>
-                        <a:t>0.660</a:t>
-                      </a:r>
-                    </a:p>
-                  </a:txBody>
-                  <a:tcPr anchor="ctr" marL="45720" marR="45720" marT="18288" marB="18288">
-                    <a:solidFill>
-                      <a:srgbClr val="EEF5FB"/>
-                    </a:solidFill>
-                  </a:tcPr>
-                </a:tc>
-                <a:tc>
-                  <a:txBody>
-                    <a:bodyPr/>
-                    <a:lstStyle/>
-                    <a:p>
-                      <a:pPr algn="ctr"/>
-                      <a:r>
-                        <a:rPr sz="1300" b="0">
-                          <a:solidFill>
-                            <a:srgbClr val="6B7A90"/>
-                          </a:solidFill>
-                          <a:latin typeface="Arial"/>
-                          <a:ea typeface="Microsoft YaHei"/>
-                        </a:rPr>
-                        <a:t>0.021</a:t>
-                      </a:r>
-                    </a:p>
-                  </a:txBody>
-                  <a:tcPr anchor="ctr" marL="45720" marR="45720" marT="18288" marB="18288">
-                    <a:solidFill>
-                      <a:srgbClr val="EEF5FB"/>
-                    </a:solidFill>
-                  </a:tcPr>
-                </a:tc>
-              </a:tr>
-              <a:tr h="329184">
-                <a:tc rowSpan="2">
-                  <a:txBody>
-                    <a:bodyPr/>
-                    <a:lstStyle/>
-                    <a:p>
-                      <a:pPr algn="ctr"/>
-                      <a:r>
-                        <a:rPr sz="1500" b="1">
-                          <a:solidFill>
-                            <a:srgbClr val="101F37"/>
-                          </a:solidFill>
-                          <a:latin typeface="Arial"/>
-                          <a:ea typeface="Microsoft YaHei"/>
-                        </a:rPr>
-                        <a:t>Any-to-Bokeh</a:t>
-                      </a:r>
-                    </a:p>
-                  </a:txBody>
-                  <a:tcPr anchor="ctr" marL="45720" marR="45720" marT="18288" marB="18288">
-                    <a:solidFill>
-                      <a:srgbClr val="FFFFFF"/>
-                    </a:solidFill>
-                  </a:tcPr>
-                </a:tc>
-                <a:tc>
-                  <a:txBody>
-                    <a:bodyPr/>
-                    <a:lstStyle/>
-                    <a:p>
-                      <a:pPr algn="ctr"/>
-                      <a:r>
-                        <a:rPr sz="1500" b="0">
-                          <a:solidFill>
-                            <a:srgbClr val="101F37"/>
-                          </a:solidFill>
-                          <a:latin typeface="Arial"/>
-                          <a:ea typeface="Microsoft YaHei"/>
-                        </a:rPr>
-                        <a:t>本项目</a:t>
-                      </a:r>
-                    </a:p>
-                  </a:txBody>
-                  <a:tcPr anchor="ctr" marL="45720" marR="45720" marT="18288" marB="18288">
-                    <a:solidFill>
-                      <a:srgbClr val="FFFFFF"/>
-                    </a:solidFill>
-                  </a:tcPr>
-                </a:tc>
-                <a:tc>
-                  <a:txBody>
-                    <a:bodyPr/>
-                    <a:lstStyle/>
-                    <a:p>
-                      <a:pPr algn="ctr"/>
-                      <a:r>
-                        <a:rPr sz="1500" b="1">
-                          <a:solidFill>
-                            <a:srgbClr val="101F37"/>
-                          </a:solidFill>
-                          <a:latin typeface="Arial"/>
-                          <a:ea typeface="Microsoft YaHei"/>
-                        </a:rPr>
-                        <a:t>39.71</a:t>
-                      </a:r>
-                    </a:p>
-                  </a:txBody>
-                  <a:tcPr anchor="ctr" marL="45720" marR="45720" marT="18288" marB="18288">
-                    <a:solidFill>
-                      <a:srgbClr val="FFFFFF"/>
-                    </a:solidFill>
-                  </a:tcPr>
-                </a:tc>
-                <a:tc>
-                  <a:txBody>
-                    <a:bodyPr/>
-                    <a:lstStyle/>
-                    <a:p>
-                      <a:pPr algn="ctr"/>
-                      <a:r>
-                        <a:rPr sz="1500" b="1">
-                          <a:solidFill>
-                            <a:srgbClr val="101F37"/>
-                          </a:solidFill>
-                          <a:latin typeface="Arial"/>
-                          <a:ea typeface="Microsoft YaHei"/>
-                        </a:rPr>
-                        <a:t>0.986</a:t>
-                      </a:r>
-                    </a:p>
-                  </a:txBody>
-                  <a:tcPr anchor="ctr" marL="45720" marR="45720" marT="18288" marB="18288">
-                    <a:solidFill>
-                      <a:srgbClr val="FFFFFF"/>
-                    </a:solidFill>
-                  </a:tcPr>
-                </a:tc>
-                <a:tc>
-                  <a:txBody>
-                    <a:bodyPr/>
-                    <a:lstStyle/>
-                    <a:p>
-                      <a:pPr algn="ctr"/>
-                      <a:r>
-                        <a:rPr sz="1500" b="1">
-                          <a:solidFill>
-                            <a:srgbClr val="101F37"/>
-                          </a:solidFill>
-                          <a:latin typeface="Arial"/>
-                          <a:ea typeface="Microsoft YaHei"/>
-                        </a:rPr>
-                        <a:t>0.015</a:t>
-                      </a:r>
-                    </a:p>
-                  </a:txBody>
-                  <a:tcPr anchor="ctr" marL="45720" marR="45720" marT="18288" marB="18288">
-                    <a:solidFill>
-                      <a:srgbClr val="FFFFFF"/>
-                    </a:solidFill>
-                  </a:tcPr>
-                </a:tc>
-                <a:tc>
-                  <a:txBody>
-                    <a:bodyPr/>
-                    <a:lstStyle/>
-                    <a:p>
-                      <a:pPr algn="ctr"/>
-                      <a:r>
-                        <a:rPr sz="1500" b="1">
-                          <a:solidFill>
-                            <a:srgbClr val="101F37"/>
-                          </a:solidFill>
-                          <a:latin typeface="Arial"/>
-                          <a:ea typeface="Microsoft YaHei"/>
-                        </a:rPr>
-                        <a:t>8.94</a:t>
-                      </a:r>
-                    </a:p>
-                  </a:txBody>
-                  <a:tcPr anchor="ctr" marL="45720" marR="45720" marT="18288" marB="18288">
-                    <a:solidFill>
-                      <a:srgbClr val="FFFFFF"/>
-                    </a:solidFill>
-                  </a:tcPr>
-                </a:tc>
-                <a:tc>
-                  <a:txBody>
-                    <a:bodyPr/>
-                    <a:lstStyle/>
-                    <a:p>
-                      <a:pPr algn="ctr"/>
-                      <a:r>
-                        <a:rPr sz="1500" b="1">
-                          <a:solidFill>
-                            <a:srgbClr val="101F37"/>
-                          </a:solidFill>
-                          <a:latin typeface="Arial"/>
-                          <a:ea typeface="Microsoft YaHei"/>
-                        </a:rPr>
-                        <a:t>0.445</a:t>
-                      </a:r>
-                    </a:p>
-                  </a:txBody>
-                  <a:tcPr anchor="ctr" marL="45720" marR="45720" marT="18288" marB="18288">
-                    <a:solidFill>
-                      <a:srgbClr val="FFFFFF"/>
-                    </a:solidFill>
-                  </a:tcPr>
-                </a:tc>
-                <a:tc>
-                  <a:txBody>
-                    <a:bodyPr/>
-                    <a:lstStyle/>
-                    <a:p>
-                      <a:pPr algn="ctr"/>
-                      <a:r>
-                        <a:rPr sz="1500" b="1">
-                          <a:solidFill>
-                            <a:srgbClr val="101F37"/>
-                          </a:solidFill>
-                          <a:latin typeface="Arial"/>
-                          <a:ea typeface="Microsoft YaHei"/>
-                        </a:rPr>
                         <a:t>0.0056</a:t>
                       </a:r>
                     </a:p>
-                  </a:txBody>
-                  <a:tcPr anchor="ctr" marL="45720" marR="45720" marT="18288" marB="18288">
-                    <a:solidFill>
-                      <a:srgbClr val="FFFFFF"/>
-                    </a:solidFill>
-                  </a:tcPr>
-                </a:tc>
-              </a:tr>
-              <a:tr h="329184">
-                <a:tc vMerge="1">
-                  <a:txBody>
-                    <a:bodyPr/>
-                    <a:lstStyle/>
-                    <a:p>
-                      <a:pPr algn="ctr"/>
-                      <a:r>
-                        <a:rPr sz="1500" b="1">
-                          <a:solidFill>
-                            <a:srgbClr val="101F37"/>
-                          </a:solidFill>
-                          <a:latin typeface="Arial"/>
-                          <a:ea typeface="Microsoft YaHei"/>
-                        </a:rPr>
-                        <a:t/>
-                      </a:r>
-                    </a:p>
-                  </a:txBody>
-                  <a:tcPr anchor="ctr" marL="45720" marR="45720" marT="18288" marB="18288">
-                    <a:solidFill>
-                      <a:srgbClr val="FFFFFF"/>
-                    </a:solidFill>
-                  </a:tcPr>
-                </a:tc>
-                <a:tc>
-                  <a:txBody>
-                    <a:bodyPr/>
-                    <a:lstStyle/>
-                    <a:p>
-                      <a:pPr algn="ctr"/>
-                      <a:r>
-                        <a:rPr sz="1300" b="0">
-                          <a:solidFill>
-                            <a:srgbClr val="6B7A90"/>
-                          </a:solidFill>
-                          <a:latin typeface="Arial"/>
-                          <a:ea typeface="Microsoft YaHei"/>
-                        </a:rPr>
-                        <a:t>论文</a:t>
-                      </a:r>
-                    </a:p>
-                  </a:txBody>
-                  <a:tcPr anchor="ctr" marL="45720" marR="45720" marT="18288" marB="18288">
-                    <a:solidFill>
-                      <a:srgbClr val="FFFFFF"/>
-                    </a:solidFill>
-                  </a:tcPr>
-                </a:tc>
-                <a:tc>
-                  <a:txBody>
-                    <a:bodyPr/>
-                    <a:lstStyle/>
-                    <a:p>
-                      <a:pPr algn="ctr"/>
-                      <a:r>
-                        <a:rPr sz="1300" b="0">
-                          <a:solidFill>
-                            <a:srgbClr val="6B7A90"/>
-                          </a:solidFill>
-                          <a:latin typeface="Arial"/>
-                          <a:ea typeface="Microsoft YaHei"/>
-                        </a:rPr>
-                        <a:t>38.899</a:t>
-                      </a:r>
-                    </a:p>
-                  </a:txBody>
-                  <a:tcPr anchor="ctr" marL="45720" marR="45720" marT="18288" marB="18288">
-                    <a:solidFill>
-                      <a:srgbClr val="FFFFFF"/>
-                    </a:solidFill>
-                  </a:tcPr>
-                </a:tc>
-                <a:tc>
-                  <a:txBody>
-                    <a:bodyPr/>
-                    <a:lstStyle/>
-                    <a:p>
-                      <a:pPr algn="ctr"/>
-                      <a:r>
-                        <a:rPr sz="1300" b="0">
-                          <a:solidFill>
-                            <a:srgbClr val="6B7A90"/>
-                          </a:solidFill>
-                          <a:latin typeface="Arial"/>
-                          <a:ea typeface="Microsoft YaHei"/>
-                        </a:rPr>
-                        <a:t>0.974</a:t>
-                      </a:r>
-                    </a:p>
-                  </a:txBody>
-                  <a:tcPr anchor="ctr" marL="45720" marR="45720" marT="18288" marB="18288">
-                    <a:solidFill>
-                      <a:srgbClr val="FFFFFF"/>
-                    </a:solidFill>
-                  </a:tcPr>
-                </a:tc>
-                <a:tc>
-                  <a:txBody>
-                    <a:bodyPr/>
-                    <a:lstStyle/>
-                    <a:p>
-                      <a:pPr algn="ctr"/>
-                      <a:r>
-                        <a:rPr sz="1300" b="0">
-                          <a:solidFill>
-                            <a:srgbClr val="6B7A90"/>
-                          </a:solidFill>
-                          <a:latin typeface="Arial"/>
-                          <a:ea typeface="Microsoft YaHei"/>
-                        </a:rPr>
-                        <a:t>0.019</a:t>
-                      </a:r>
-                    </a:p>
-                  </a:txBody>
-                  <a:tcPr anchor="ctr" marL="45720" marR="45720" marT="18288" marB="18288">
-                    <a:solidFill>
-                      <a:srgbClr val="FFFFFF"/>
-                    </a:solidFill>
-                  </a:tcPr>
-                </a:tc>
-                <a:tc>
-                  <a:txBody>
-                    <a:bodyPr/>
-                    <a:lstStyle/>
-                    <a:p>
-                      <a:pPr algn="ctr"/>
-                      <a:r>
-                        <a:rPr sz="1300" b="0">
-                          <a:solidFill>
-                            <a:srgbClr val="6B7A90"/>
-                          </a:solidFill>
-                          <a:latin typeface="Arial"/>
-                          <a:ea typeface="Microsoft YaHei"/>
-                        </a:rPr>
-                        <a:t>9.005</a:t>
-                      </a:r>
-                    </a:p>
-                  </a:txBody>
-                  <a:tcPr anchor="ctr" marL="45720" marR="45720" marT="18288" marB="18288">
-                    <a:solidFill>
-                      <a:srgbClr val="FFFFFF"/>
-                    </a:solidFill>
-                  </a:tcPr>
-                </a:tc>
-                <a:tc>
-                  <a:txBody>
-                    <a:bodyPr/>
-                    <a:lstStyle/>
-                    <a:p>
-                      <a:pPr algn="ctr"/>
-                      <a:r>
-                        <a:rPr sz="1300" b="0">
-                          <a:solidFill>
-                            <a:srgbClr val="6B7A90"/>
-                          </a:solidFill>
-                          <a:latin typeface="Arial"/>
-                          <a:ea typeface="Microsoft YaHei"/>
-                        </a:rPr>
-                        <a:t>0.431</a:t>
-                      </a:r>
-                    </a:p>
-                  </a:txBody>
-                  <a:tcPr anchor="ctr" marL="45720" marR="45720" marT="18288" marB="18288">
-                    <a:solidFill>
-                      <a:srgbClr val="FFFFFF"/>
-                    </a:solidFill>
-                  </a:tcPr>
-                </a:tc>
-                <a:tc>
-                  <a:txBody>
-                    <a:bodyPr/>
-                    <a:lstStyle/>
-                    <a:p>
-                      <a:pPr algn="ctr"/>
-                      <a:r>
-                        <a:rPr sz="1300" b="0">
+                    <a:p>
+                      <a:pPr algn="ctr"/>
+                      <a:r>
+                        <a:rPr sz="1100" b="0">
                           <a:solidFill>
                             <a:srgbClr val="6B7A90"/>
                           </a:solidFill>
@@ -12575,7 +11989,7 @@
                           <a:latin typeface="Arial"/>
                           <a:ea typeface="Microsoft YaHei"/>
                         </a:rPr>
-                        <a:t/>
+                        <a:t>26.45</a:t>
                       </a:r>
                     </a:p>
                   </a:txBody>
@@ -12599,7 +12013,7 @@
                           <a:latin typeface="Arial"/>
                           <a:ea typeface="Microsoft YaHei"/>
                         </a:rPr>
-                        <a:t/>
+                        <a:t>0.95</a:t>
                       </a:r>
                     </a:p>
                   </a:txBody>
@@ -12623,7 +12037,7 @@
                           <a:latin typeface="Arial"/>
                           <a:ea typeface="Microsoft YaHei"/>
                         </a:rPr>
-                        <a:t/>
+                        <a:t>1.36</a:t>
                       </a:r>
                     </a:p>
                   </a:txBody>
@@ -12697,7 +12111,7 @@
                           <a:latin typeface="Arial"/>
                           <a:ea typeface="Microsoft YaHei"/>
                         </a:rPr>
-                        <a:t/>
+                        <a:t>20.62</a:t>
                       </a:r>
                     </a:p>
                   </a:txBody>
@@ -12721,7 +12135,7 @@
                           <a:latin typeface="Arial"/>
                           <a:ea typeface="Microsoft YaHei"/>
                         </a:rPr>
-                        <a:t/>
+                        <a:t>1.21</a:t>
                       </a:r>
                     </a:p>
                   </a:txBody>
@@ -12745,7 +12159,7 @@
                           <a:latin typeface="Arial"/>
                           <a:ea typeface="Microsoft YaHei"/>
                         </a:rPr>
-                        <a:t/>
+                        <a:t>2.88</a:t>
                       </a:r>
                     </a:p>
                   </a:txBody>
@@ -12812,14 +12226,14 @@
                     <a:p>
                       <a:pPr algn="ctr"/>
                       <a:r>
-                        <a:rPr sz="1800" b="0">
+                        <a:rPr sz="1800" b="1">
                           <a:solidFill>
                             <a:srgbClr val="101F37"/>
                           </a:solidFill>
                           <a:latin typeface="Arial"/>
                           <a:ea typeface="Microsoft YaHei"/>
                         </a:rPr>
-                        <a:t/>
+                        <a:t>1.19</a:t>
                       </a:r>
                     </a:p>
                   </a:txBody>
@@ -12836,14 +12250,14 @@
                     <a:p>
                       <a:pPr algn="ctr"/>
                       <a:r>
-                        <a:rPr sz="1800" b="0">
+                        <a:rPr sz="1800" b="1">
                           <a:solidFill>
                             <a:srgbClr val="101F37"/>
                           </a:solidFill>
                           <a:latin typeface="Arial"/>
                           <a:ea typeface="Microsoft YaHei"/>
                         </a:rPr>
-                        <a:t/>
+                        <a:t>21.08</a:t>
                       </a:r>
                     </a:p>
                   </a:txBody>
@@ -12860,14 +12274,14 @@
                     <a:p>
                       <a:pPr algn="ctr"/>
                       <a:r>
-                        <a:rPr sz="1800" b="0">
+                        <a:rPr sz="1800" b="1">
                           <a:solidFill>
                             <a:srgbClr val="101F37"/>
                           </a:solidFill>
                           <a:latin typeface="Arial"/>
                           <a:ea typeface="Microsoft YaHei"/>
                         </a:rPr>
-                        <a:t/>
+                        <a:t>1.01</a:t>
                       </a:r>
                     </a:p>
                   </a:txBody>
@@ -12941,7 +12355,7 @@
                           <a:latin typeface="Arial"/>
                           <a:ea typeface="Microsoft YaHei"/>
                         </a:rPr>
-                        <a:t/>
+                        <a:t>7.68</a:t>
                       </a:r>
                     </a:p>
                   </a:txBody>
@@ -12965,7 +12379,7 @@
                           <a:latin typeface="Arial"/>
                           <a:ea typeface="Microsoft YaHei"/>
                         </a:rPr>
-                        <a:t/>
+                        <a:t>3.25</a:t>
                       </a:r>
                     </a:p>
                   </a:txBody>
@@ -12989,7 +12403,7 @@
                           <a:latin typeface="Arial"/>
                           <a:ea typeface="Microsoft YaHei"/>
                         </a:rPr>
-                        <a:t/>
+                        <a:t>2.43</a:t>
                       </a:r>
                     </a:p>
                   </a:txBody>
@@ -13063,7 +12477,7 @@
                           <a:latin typeface="Arial"/>
                           <a:ea typeface="Microsoft YaHei"/>
                         </a:rPr>
-                        <a:t/>
+                        <a:t>28.17</a:t>
                       </a:r>
                     </a:p>
                   </a:txBody>
@@ -13087,7 +12501,7 @@
                           <a:latin typeface="Arial"/>
                           <a:ea typeface="Microsoft YaHei"/>
                         </a:rPr>
-                        <a:t/>
+                        <a:t>0.89</a:t>
                       </a:r>
                     </a:p>
                   </a:txBody>
@@ -13111,7 +12525,7 @@
                           <a:latin typeface="Arial"/>
                           <a:ea typeface="Microsoft YaHei"/>
                         </a:rPr>
-                        <a:t/>
+                        <a:t>18.34</a:t>
                       </a:r>
                     </a:p>
                   </a:txBody>
@@ -13185,7 +12599,7 @@
                           <a:latin typeface="Arial"/>
                           <a:ea typeface="Microsoft YaHei"/>
                         </a:rPr>
-                        <a:t/>
+                        <a:t>14.08</a:t>
                       </a:r>
                     </a:p>
                   </a:txBody>
@@ -13209,7 +12623,7 @@
                           <a:latin typeface="Arial"/>
                           <a:ea typeface="Microsoft YaHei"/>
                         </a:rPr>
-                        <a:t/>
+                        <a:t>1.78</a:t>
                       </a:r>
                     </a:p>
                   </a:txBody>
@@ -13233,7 +12647,7 @@
                           <a:latin typeface="Arial"/>
                           <a:ea typeface="Microsoft YaHei"/>
                         </a:rPr>
-                        <a:t/>
+                        <a:t>38.47</a:t>
                       </a:r>
                     </a:p>
                   </a:txBody>
@@ -13424,8 +12838,8 @@
         </p:nvSpPr>
         <p:spPr>
           <a:xfrm>
-            <a:off x="781050" y="1381125"/>
-            <a:ext cx="1809750" cy="571500"/>
+            <a:off x="777240" y="1325880"/>
+            <a:ext cx="1809750" cy="914400"/>
           </a:xfrm>
           <a:prstGeom prst="rect">
             <a:avLst/>
@@ -13481,8 +12895,8 @@
         </p:nvSpPr>
         <p:spPr>
           <a:xfrm>
-            <a:off x="2724150" y="1381125"/>
-            <a:ext cx="8382000" cy="619125"/>
+            <a:off x="2926080" y="1325880"/>
+            <a:ext cx="8321040" cy="914400"/>
           </a:xfrm>
           <a:prstGeom prst="rect">
             <a:avLst/>
@@ -13499,6 +12913,9 @@
           <a:lstStyle/>
           <a:p>
             <a:pPr algn="l">
+              <a:spcAft>
+                <a:spcPts val="600"/>
+              </a:spcAft>
               <a:defRPr sz="2025" b="0">
                 <a:solidFill>
                   <a:srgbClr val="101F37"/>
@@ -13517,17 +12934,78 @@
                 <a:ea typeface="Microsoft YaHei"/>
                 <a:cs typeface="Microsoft YaHei"/>
               </a:rPr>
-              <a:t>深度降到 15/10/5/2 fps，统一补齐缺失帧后比较六种方法</a:t>
+              <a:t>深度帧率降到 15 / 10 / 5 / 2 fps，缺失帧用统一的简单方法补齐</a:t>
+            </a:r>
+          </a:p>
+          <a:p>
+            <a:pPr algn="l">
+              <a:spcAft>
+                <a:spcPts val="600"/>
+              </a:spcAft>
+              <a:defRPr sz="2025" b="0">
+                <a:solidFill>
+                  <a:srgbClr val="101F37"/>
+                </a:solidFill>
+                <a:latin typeface="Microsoft YaHei"/>
+                <a:ea typeface="Microsoft YaHei"/>
+                <a:cs typeface="Microsoft YaHei"/>
+              </a:defRPr>
+            </a:pPr>
+            <a:r>
+              <a:rPr sz="2025" b="0">
+                <a:solidFill>
+                  <a:srgbClr val="101F37"/>
+                </a:solidFill>
+                <a:latin typeface="Microsoft YaHei"/>
+                <a:ea typeface="Microsoft YaHei"/>
+                <a:cs typeface="Microsoft YaHei"/>
+              </a:rPr>
+              <a:t>比较六种方法随深度帧率下降的变化</a:t>
             </a:r>
           </a:p>
         </p:txBody>
       </p:sp>
+      <p:cxnSp>
+        <p:nvCxnSpPr>
+          <p:cNvPr id="23" name="Connector 22"/>
+          <p:cNvCxnSpPr/>
+          <p:nvPr/>
+        </p:nvCxnSpPr>
+        <p:spPr>
+          <a:xfrm>
+            <a:off x="777240" y="2532888"/>
+            <a:ext cx="10469880" cy="0"/>
+          </a:xfrm>
+          <a:prstGeom prst="line">
+            <a:avLst/>
+          </a:prstGeom>
+          <a:ln w="9525">
+            <a:solidFill>
+              <a:srgbClr val="22C7E2"/>
+            </a:solidFill>
+          </a:ln>
+        </p:spPr>
+        <p:style>
+          <a:lnRef idx="2">
+            <a:schemeClr val="accent1"/>
+          </a:lnRef>
+          <a:fillRef idx="0">
+            <a:schemeClr val="accent1"/>
+          </a:fillRef>
+          <a:effectRef idx="1">
+            <a:schemeClr val="accent1"/>
+          </a:effectRef>
+          <a:fontRef idx="minor">
+            <a:schemeClr val="tx1"/>
+          </a:fontRef>
+        </p:style>
+      </p:cxnSp>
       <p:sp>
         <p:nvSpPr>
-          <p:cNvPr id="16" name="矩形 15">
+          <p:cNvPr id="9" name="矩形 8">
             <a:extLst>
               <a:ext uri="{FF2B5EF4-FFF2-40B4-BE49-F238E27FC236}">
-                <a16:creationId xmlns:a16="http://schemas.microsoft.com/office/drawing/2014/main" id="{0A7E796C-4C77-5D44-04E9-AD4AD9FFD0A4}"/>
+                <a16:creationId xmlns:a16="http://schemas.microsoft.com/office/drawing/2014/main" id="{A0DB1E63-8F98-56F0-5AD9-E321506A6914}"/>
               </a:ext>
             </a:extLst>
           </p:cNvPr>
@@ -13538,8 +13016,8 @@
         </p:nvSpPr>
         <p:spPr>
           <a:xfrm>
-            <a:off x="781050" y="2447925"/>
-            <a:ext cx="1809750" cy="571500"/>
+            <a:off x="777240" y="2834639"/>
+            <a:ext cx="1809750" cy="914400"/>
           </a:xfrm>
           <a:prstGeom prst="rect">
             <a:avLst/>
@@ -13574,17 +13052,17 @@
                 <a:ea typeface="Microsoft YaHei"/>
                 <a:cs typeface="Microsoft YaHei"/>
               </a:rPr>
-              <a:t>固定基线</a:t>
+              <a:t>自研方法</a:t>
             </a:r>
           </a:p>
         </p:txBody>
       </p:sp>
       <p:sp>
         <p:nvSpPr>
-          <p:cNvPr id="17" name="矩形 16">
+          <p:cNvPr id="10" name="矩形 9">
             <a:extLst>
               <a:ext uri="{FF2B5EF4-FFF2-40B4-BE49-F238E27FC236}">
-                <a16:creationId xmlns:a16="http://schemas.microsoft.com/office/drawing/2014/main" id="{6798B5B8-0BDB-E4E0-0F4A-05068F4E7B8F}"/>
+                <a16:creationId xmlns:a16="http://schemas.microsoft.com/office/drawing/2014/main" id="{50248E8E-737C-9BE3-5CB0-2F225DFAD313}"/>
               </a:ext>
             </a:extLst>
           </p:cNvPr>
@@ -13595,8 +13073,8 @@
         </p:nvSpPr>
         <p:spPr>
           <a:xfrm>
-            <a:off x="2724150" y="2447925"/>
-            <a:ext cx="8382000" cy="619125"/>
+            <a:off x="2926080" y="2834639"/>
+            <a:ext cx="8321040" cy="914400"/>
           </a:xfrm>
           <a:prstGeom prst="rect">
             <a:avLst/>
@@ -13613,6 +13091,9 @@
           <a:lstStyle/>
           <a:p>
             <a:pPr algn="l">
+              <a:spcAft>
+                <a:spcPts val="600"/>
+              </a:spcAft>
               <a:defRPr sz="2025" b="0">
                 <a:solidFill>
                   <a:srgbClr val="101F37"/>
@@ -13631,17 +13112,78 @@
                 <a:ea typeface="Microsoft YaHei"/>
                 <a:cs typeface="Microsoft YaHei"/>
               </a:rPr>
-              <a:t>低帧率结果完成后，固定全部基线方法的表格</a:t>
+              <a:t>根据基线结果中暴露的问题确定方法设计</a:t>
+            </a:r>
+          </a:p>
+          <a:p>
+            <a:pPr algn="l">
+              <a:spcAft>
+                <a:spcPts val="600"/>
+              </a:spcAft>
+              <a:defRPr sz="2025" b="0">
+                <a:solidFill>
+                  <a:srgbClr val="101F37"/>
+                </a:solidFill>
+                <a:latin typeface="Microsoft YaHei"/>
+                <a:ea typeface="Microsoft YaHei"/>
+                <a:cs typeface="Microsoft YaHei"/>
+              </a:defRPr>
+            </a:pPr>
+            <a:r>
+              <a:rPr sz="2025" b="0">
+                <a:solidFill>
+                  <a:srgbClr val="101F37"/>
+                </a:solidFill>
+                <a:latin typeface="Microsoft YaHei"/>
+                <a:ea typeface="Microsoft YaHei"/>
+                <a:cs typeface="Microsoft YaHei"/>
+              </a:rPr>
+              <a:t>重点关注低帧率深度补全、主体边界和时序稳定</a:t>
             </a:r>
           </a:p>
         </p:txBody>
       </p:sp>
+      <p:cxnSp>
+        <p:nvCxnSpPr>
+          <p:cNvPr id="24" name="Connector 23"/>
+          <p:cNvCxnSpPr/>
+          <p:nvPr/>
+        </p:nvCxnSpPr>
+        <p:spPr>
+          <a:xfrm>
+            <a:off x="777240" y="4041648"/>
+            <a:ext cx="10469880" cy="0"/>
+          </a:xfrm>
+          <a:prstGeom prst="line">
+            <a:avLst/>
+          </a:prstGeom>
+          <a:ln w="9525">
+            <a:solidFill>
+              <a:srgbClr val="22C7E2"/>
+            </a:solidFill>
+          </a:ln>
+        </p:spPr>
+        <p:style>
+          <a:lnRef idx="2">
+            <a:schemeClr val="accent1"/>
+          </a:lnRef>
+          <a:fillRef idx="0">
+            <a:schemeClr val="accent1"/>
+          </a:fillRef>
+          <a:effectRef idx="1">
+            <a:schemeClr val="accent1"/>
+          </a:effectRef>
+          <a:fontRef idx="minor">
+            <a:schemeClr val="tx1"/>
+          </a:fontRef>
+        </p:style>
+      </p:cxnSp>
       <p:sp>
         <p:nvSpPr>
-          <p:cNvPr id="23" name="矩形 22">
+          <p:cNvPr id="9" name="矩形 8">
             <a:extLst>
               <a:ext uri="{FF2B5EF4-FFF2-40B4-BE49-F238E27FC236}">
-                <a16:creationId xmlns:a16="http://schemas.microsoft.com/office/drawing/2014/main" id="{91DFD6B8-B1E6-47BC-FB17-45A0E4843962}"/>
+                <a16:creationId xmlns:a16="http://schemas.microsoft.com/office/drawing/2014/main" id="{A0DB1E63-8F98-56F0-5AD9-E321506A6914}"/>
               </a:ext>
             </a:extLst>
           </p:cNvPr>
@@ -13652,8 +13194,8 @@
         </p:nvSpPr>
         <p:spPr>
           <a:xfrm>
-            <a:off x="781050" y="3514725"/>
-            <a:ext cx="1809750" cy="571500"/>
+            <a:off x="777240" y="4343400"/>
+            <a:ext cx="1809750" cy="914400"/>
           </a:xfrm>
           <a:prstGeom prst="rect">
             <a:avLst/>
@@ -13688,17 +13230,17 @@
                 <a:ea typeface="Microsoft YaHei"/>
                 <a:cs typeface="Microsoft YaHei"/>
               </a:rPr>
-              <a:t>自研方法</a:t>
+              <a:t>自建数据集</a:t>
             </a:r>
           </a:p>
         </p:txBody>
       </p:sp>
       <p:sp>
         <p:nvSpPr>
-          <p:cNvPr id="24" name="矩形 23">
+          <p:cNvPr id="10" name="矩形 9">
             <a:extLst>
               <a:ext uri="{FF2B5EF4-FFF2-40B4-BE49-F238E27FC236}">
-                <a16:creationId xmlns:a16="http://schemas.microsoft.com/office/drawing/2014/main" id="{F9CE8295-69D6-D893-0DF7-BDB64CFEAA38}"/>
+                <a16:creationId xmlns:a16="http://schemas.microsoft.com/office/drawing/2014/main" id="{50248E8E-737C-9BE3-5CB0-2F225DFAD313}"/>
               </a:ext>
             </a:extLst>
           </p:cNvPr>
@@ -13709,8 +13251,8 @@
         </p:nvSpPr>
         <p:spPr>
           <a:xfrm>
-            <a:off x="2724150" y="3514725"/>
-            <a:ext cx="8382000" cy="619125"/>
+            <a:off x="2926080" y="4343400"/>
+            <a:ext cx="8321040" cy="914400"/>
           </a:xfrm>
           <a:prstGeom prst="rect">
             <a:avLst/>
@@ -13727,6 +13269,9 @@
           <a:lstStyle/>
           <a:p>
             <a:pPr algn="l">
+              <a:spcAft>
+                <a:spcPts val="600"/>
+              </a:spcAft>
               <a:defRPr sz="2025" b="0">
                 <a:solidFill>
                   <a:srgbClr val="101F37"/>
@@ -13745,7 +13290,33 @@
                 <a:ea typeface="Microsoft YaHei"/>
                 <a:cs typeface="Microsoft YaHei"/>
               </a:rPr>
-              <a:t>开始实现与训练，结果补入同一套表格比较</a:t>
+              <a:t>构建贴近课题输入的数据：高帧率 RGB + 低帧率粗深度 + 对焦参数</a:t>
+            </a:r>
+          </a:p>
+          <a:p>
+            <a:pPr algn="l">
+              <a:spcAft>
+                <a:spcPts val="600"/>
+              </a:spcAft>
+              <a:defRPr sz="2025" b="0">
+                <a:solidFill>
+                  <a:srgbClr val="101F37"/>
+                </a:solidFill>
+                <a:latin typeface="Microsoft YaHei"/>
+                <a:ea typeface="Microsoft YaHei"/>
+                <a:cs typeface="Microsoft YaHei"/>
+              </a:defRPr>
+            </a:pPr>
+            <a:r>
+              <a:rPr sz="2025" b="0">
+                <a:solidFill>
+                  <a:srgbClr val="101F37"/>
+                </a:solidFill>
+                <a:latin typeface="Microsoft YaHei"/>
+                <a:ea typeface="Microsoft YaHei"/>
+                <a:cs typeface="Microsoft YaHei"/>
+              </a:rPr>
+              <a:t>所有方法使用相同输入，在独立测试集上检验泛化</a:t>
             </a:r>
           </a:p>
         </p:txBody>

</xml_diff>

<commit_message>
report: split synthetic results into ours and paper-reported tables
Co-Authored-By: Claude Opus 5.5 (1M context) <noreply@anthropic.com>
</commit_message>
<xml_diff>
--- a/汇报/2026-09-30_基线方法复现结果/基线方法复现结果_0930.pptx
+++ b/汇报/2026-09-30_基线方法复现结果/基线方法复现结果_0930.pptx
@@ -8057,47 +8057,1232 @@
                 <a:latin typeface="Arial"/>
                 <a:ea typeface="Microsoft YaHei"/>
               </a:rPr>
-              <a:t>200 段合成视频 × 25 帧，1024×576，有虚化真值；每格上方为本项目结果，下方灰色为论文报告值</a:t>
+              <a:t>200 段合成视频 × 25 帧，1024×576，有虚化真值；上表为本项目复现结果，下表为论文报告值</a:t>
             </a:r>
           </a:p>
         </p:txBody>
       </p:sp>
-      <p:sp>
-        <p:nvSpPr>
-          <p:cNvPr id="24" name="TextBox 23"/>
-          <p:cNvSpPr txBox="1"/>
+      <p:graphicFrame>
+        <p:nvGraphicFramePr>
+          <p:cNvPr id="24" name="Table 23"/>
+          <p:cNvGraphicFramePr>
+            <a:graphicFrameLocks noGrp="1"/>
+          </p:cNvGraphicFramePr>
           <p:nvPr/>
-        </p:nvSpPr>
-        <p:spPr>
-          <a:xfrm>
-            <a:off x="731520" y="1481328"/>
-            <a:ext cx="5166359" cy="365760"/>
-          </a:xfrm>
-          <a:prstGeom prst="rect">
-            <a:avLst/>
-          </a:prstGeom>
-          <a:noFill/>
-        </p:spPr>
-        <p:txBody>
-          <a:bodyPr wrap="square" anchor="ctr">
-            <a:spAutoFit/>
-          </a:bodyPr>
-          <a:lstStyle/>
-          <a:p>
-            <a:pPr algn="ctr"/>
-            <a:r>
-              <a:rPr sz="1700" b="1">
-                <a:solidFill>
-                  <a:srgbClr val="0D569A"/>
-                </a:solidFill>
-                <a:latin typeface="Arial"/>
-                <a:ea typeface="Microsoft YaHei"/>
-              </a:rPr>
-              <a:t>单帧质量</a:t>
-            </a:r>
-          </a:p>
-        </p:txBody>
-      </p:sp>
+        </p:nvGraphicFramePr>
+        <p:xfrm>
+          <a:off x="868679" y="1481328"/>
+          <a:ext cx="10332720" cy="2176272"/>
+        </p:xfrm>
+        <a:graphic>
+          <a:graphicData uri="http://schemas.openxmlformats.org/drawingml/2006/table">
+            <a:tbl>
+              <a:tblPr firstRow="1">
+                <a:tableStyleId>{5C22544A-7EE6-4342-B048-85BDC9FD1C3A}</a:tableStyleId>
+              </a:tblPr>
+              <a:tblGrid>
+                <a:gridCol w="2103120"/>
+                <a:gridCol w="1371600"/>
+                <a:gridCol w="1371600"/>
+                <a:gridCol w="1371600"/>
+                <a:gridCol w="1371600"/>
+                <a:gridCol w="1371600"/>
+                <a:gridCol w="1371600"/>
+              </a:tblGrid>
+              <a:tr h="310896">
+                <a:tc>
+                  <a:txBody>
+                    <a:bodyPr/>
+                    <a:lstStyle/>
+                    <a:p>
+                      <a:pPr algn="ctr"/>
+                      <a:r>
+                        <a:rPr sz="1500" b="1">
+                          <a:solidFill>
+                            <a:srgbClr val="FFFFFF"/>
+                          </a:solidFill>
+                          <a:latin typeface="Arial"/>
+                          <a:ea typeface="Microsoft YaHei"/>
+                        </a:rPr>
+                        <a:t>本项目复现</a:t>
+                      </a:r>
+                    </a:p>
+                  </a:txBody>
+                  <a:tcPr anchor="ctr" marL="45720" marR="45720" marT="18288" marB="18288">
+                    <a:solidFill>
+                      <a:srgbClr val="0D569A"/>
+                    </a:solidFill>
+                  </a:tcPr>
+                </a:tc>
+                <a:tc>
+                  <a:txBody>
+                    <a:bodyPr/>
+                    <a:lstStyle/>
+                    <a:p>
+                      <a:pPr algn="ctr"/>
+                      <a:r>
+                        <a:rPr sz="1500" b="1">
+                          <a:solidFill>
+                            <a:srgbClr val="FFFFFF"/>
+                          </a:solidFill>
+                          <a:latin typeface="Arial"/>
+                          <a:ea typeface="Microsoft YaHei"/>
+                        </a:rPr>
+                        <a:t>PSNR ↑</a:t>
+                      </a:r>
+                    </a:p>
+                  </a:txBody>
+                  <a:tcPr anchor="ctr" marL="45720" marR="45720" marT="18288" marB="18288">
+                    <a:solidFill>
+                      <a:srgbClr val="0D569A"/>
+                    </a:solidFill>
+                  </a:tcPr>
+                </a:tc>
+                <a:tc>
+                  <a:txBody>
+                    <a:bodyPr/>
+                    <a:lstStyle/>
+                    <a:p>
+                      <a:pPr algn="ctr"/>
+                      <a:r>
+                        <a:rPr sz="1500" b="1">
+                          <a:solidFill>
+                            <a:srgbClr val="FFFFFF"/>
+                          </a:solidFill>
+                          <a:latin typeface="Arial"/>
+                          <a:ea typeface="Microsoft YaHei"/>
+                        </a:rPr>
+                        <a:t>SSIM ↑</a:t>
+                      </a:r>
+                    </a:p>
+                  </a:txBody>
+                  <a:tcPr anchor="ctr" marL="45720" marR="45720" marT="18288" marB="18288">
+                    <a:solidFill>
+                      <a:srgbClr val="0D569A"/>
+                    </a:solidFill>
+                  </a:tcPr>
+                </a:tc>
+                <a:tc>
+                  <a:txBody>
+                    <a:bodyPr/>
+                    <a:lstStyle/>
+                    <a:p>
+                      <a:pPr algn="ctr"/>
+                      <a:r>
+                        <a:rPr sz="1500" b="1">
+                          <a:solidFill>
+                            <a:srgbClr val="FFFFFF"/>
+                          </a:solidFill>
+                          <a:latin typeface="Arial"/>
+                          <a:ea typeface="Microsoft YaHei"/>
+                        </a:rPr>
+                        <a:t>LPIPS ↓</a:t>
+                      </a:r>
+                    </a:p>
+                  </a:txBody>
+                  <a:tcPr anchor="ctr" marL="45720" marR="45720" marT="18288" marB="18288">
+                    <a:solidFill>
+                      <a:srgbClr val="0D569A"/>
+                    </a:solidFill>
+                  </a:tcPr>
+                </a:tc>
+                <a:tc>
+                  <a:txBody>
+                    <a:bodyPr/>
+                    <a:lstStyle/>
+                    <a:p>
+                      <a:pPr algn="ctr"/>
+                      <a:r>
+                        <a:rPr sz="1500" b="1">
+                          <a:solidFill>
+                            <a:srgbClr val="FFFFFF"/>
+                          </a:solidFill>
+                          <a:latin typeface="Arial"/>
+                          <a:ea typeface="Microsoft YaHei"/>
+                        </a:rPr>
+                        <a:t>FVD ↓</a:t>
+                      </a:r>
+                    </a:p>
+                  </a:txBody>
+                  <a:tcPr anchor="ctr" marL="45720" marR="45720" marT="18288" marB="18288">
+                    <a:solidFill>
+                      <a:srgbClr val="0D569A"/>
+                    </a:solidFill>
+                  </a:tcPr>
+                </a:tc>
+                <a:tc>
+                  <a:txBody>
+                    <a:bodyPr/>
+                    <a:lstStyle/>
+                    <a:p>
+                      <a:pPr algn="ctr"/>
+                      <a:r>
+                        <a:rPr sz="1500" b="1">
+                          <a:solidFill>
+                            <a:srgbClr val="FFFFFF"/>
+                          </a:solidFill>
+                          <a:latin typeface="Arial"/>
+                          <a:ea typeface="Microsoft YaHei"/>
+                        </a:rPr>
+                        <a:t>FD ↓</a:t>
+                      </a:r>
+                    </a:p>
+                  </a:txBody>
+                  <a:tcPr anchor="ctr" marL="45720" marR="45720" marT="18288" marB="18288">
+                    <a:solidFill>
+                      <a:srgbClr val="0D569A"/>
+                    </a:solidFill>
+                  </a:tcPr>
+                </a:tc>
+                <a:tc>
+                  <a:txBody>
+                    <a:bodyPr/>
+                    <a:lstStyle/>
+                    <a:p>
+                      <a:pPr algn="ctr"/>
+                      <a:r>
+                        <a:rPr sz="1500" b="1">
+                          <a:solidFill>
+                            <a:srgbClr val="FFFFFF"/>
+                          </a:solidFill>
+                          <a:latin typeface="Arial"/>
+                          <a:ea typeface="Microsoft YaHei"/>
+                        </a:rPr>
+                        <a:t>RM ↓</a:t>
+                      </a:r>
+                    </a:p>
+                  </a:txBody>
+                  <a:tcPr anchor="ctr" marL="45720" marR="45720" marT="18288" marB="18288">
+                    <a:solidFill>
+                      <a:srgbClr val="0D569A"/>
+                    </a:solidFill>
+                  </a:tcPr>
+                </a:tc>
+              </a:tr>
+              <a:tr h="310896">
+                <a:tc>
+                  <a:txBody>
+                    <a:bodyPr/>
+                    <a:lstStyle/>
+                    <a:p>
+                      <a:pPr algn="ctr"/>
+                      <a:r>
+                        <a:rPr sz="1500" b="1">
+                          <a:solidFill>
+                            <a:srgbClr val="101F37"/>
+                          </a:solidFill>
+                          <a:latin typeface="Arial"/>
+                          <a:ea typeface="Microsoft YaHei"/>
+                        </a:rPr>
+                        <a:t>DeepLens</a:t>
+                      </a:r>
+                    </a:p>
+                  </a:txBody>
+                  <a:tcPr anchor="ctr" marL="45720" marR="45720" marT="18288" marB="18288">
+                    <a:solidFill>
+                      <a:srgbClr val="EEF5FB"/>
+                    </a:solidFill>
+                  </a:tcPr>
+                </a:tc>
+                <a:tc>
+                  <a:txBody>
+                    <a:bodyPr/>
+                    <a:lstStyle/>
+                    <a:p>
+                      <a:pPr algn="ctr"/>
+                      <a:r>
+                        <a:rPr sz="1500" b="0">
+                          <a:solidFill>
+                            <a:srgbClr val="101F37"/>
+                          </a:solidFill>
+                          <a:latin typeface="Arial"/>
+                          <a:ea typeface="Microsoft YaHei"/>
+                        </a:rPr>
+                        <a:t>28.17</a:t>
+                      </a:r>
+                    </a:p>
+                  </a:txBody>
+                  <a:tcPr anchor="ctr" marL="45720" marR="45720" marT="18288" marB="18288">
+                    <a:solidFill>
+                      <a:srgbClr val="EEF5FB"/>
+                    </a:solidFill>
+                  </a:tcPr>
+                </a:tc>
+                <a:tc>
+                  <a:txBody>
+                    <a:bodyPr/>
+                    <a:lstStyle/>
+                    <a:p>
+                      <a:pPr algn="ctr"/>
+                      <a:r>
+                        <a:rPr sz="1500" b="0">
+                          <a:solidFill>
+                            <a:srgbClr val="101F37"/>
+                          </a:solidFill>
+                          <a:latin typeface="Arial"/>
+                          <a:ea typeface="Microsoft YaHei"/>
+                        </a:rPr>
+                        <a:t>0.944</a:t>
+                      </a:r>
+                    </a:p>
+                  </a:txBody>
+                  <a:tcPr anchor="ctr" marL="45720" marR="45720" marT="18288" marB="18288">
+                    <a:solidFill>
+                      <a:srgbClr val="EEF5FB"/>
+                    </a:solidFill>
+                  </a:tcPr>
+                </a:tc>
+                <a:tc>
+                  <a:txBody>
+                    <a:bodyPr/>
+                    <a:lstStyle/>
+                    <a:p>
+                      <a:pPr algn="ctr"/>
+                      <a:r>
+                        <a:rPr sz="1500" b="0">
+                          <a:solidFill>
+                            <a:srgbClr val="101F37"/>
+                          </a:solidFill>
+                          <a:latin typeface="Arial"/>
+                          <a:ea typeface="Microsoft YaHei"/>
+                        </a:rPr>
+                        <a:t>0.063</a:t>
+                      </a:r>
+                    </a:p>
+                  </a:txBody>
+                  <a:tcPr anchor="ctr" marL="45720" marR="45720" marT="18288" marB="18288">
+                    <a:solidFill>
+                      <a:srgbClr val="EEF5FB"/>
+                    </a:solidFill>
+                  </a:tcPr>
+                </a:tc>
+                <a:tc>
+                  <a:txBody>
+                    <a:bodyPr/>
+                    <a:lstStyle/>
+                    <a:p>
+                      <a:pPr algn="ctr"/>
+                      <a:r>
+                        <a:rPr sz="1500" b="0">
+                          <a:solidFill>
+                            <a:srgbClr val="101F37"/>
+                          </a:solidFill>
+                          <a:latin typeface="Arial"/>
+                          <a:ea typeface="Microsoft YaHei"/>
+                        </a:rPr>
+                        <a:t>40.12</a:t>
+                      </a:r>
+                    </a:p>
+                  </a:txBody>
+                  <a:tcPr anchor="ctr" marL="45720" marR="45720" marT="18288" marB="18288">
+                    <a:solidFill>
+                      <a:srgbClr val="EEF5FB"/>
+                    </a:solidFill>
+                  </a:tcPr>
+                </a:tc>
+                <a:tc>
+                  <a:txBody>
+                    <a:bodyPr/>
+                    <a:lstStyle/>
+                    <a:p>
+                      <a:pPr algn="ctr"/>
+                      <a:r>
+                        <a:rPr sz="1500" b="0">
+                          <a:solidFill>
+                            <a:srgbClr val="101F37"/>
+                          </a:solidFill>
+                          <a:latin typeface="Arial"/>
+                          <a:ea typeface="Microsoft YaHei"/>
+                        </a:rPr>
+                        <a:t>0.583</a:t>
+                      </a:r>
+                    </a:p>
+                  </a:txBody>
+                  <a:tcPr anchor="ctr" marL="45720" marR="45720" marT="18288" marB="18288">
+                    <a:solidFill>
+                      <a:srgbClr val="EEF5FB"/>
+                    </a:solidFill>
+                  </a:tcPr>
+                </a:tc>
+                <a:tc>
+                  <a:txBody>
+                    <a:bodyPr/>
+                    <a:lstStyle/>
+                    <a:p>
+                      <a:pPr algn="ctr"/>
+                      <a:r>
+                        <a:rPr sz="1500" b="0">
+                          <a:solidFill>
+                            <a:srgbClr val="101F37"/>
+                          </a:solidFill>
+                          <a:latin typeface="Arial"/>
+                          <a:ea typeface="Microsoft YaHei"/>
+                        </a:rPr>
+                        <a:t>0.0124</a:t>
+                      </a:r>
+                    </a:p>
+                  </a:txBody>
+                  <a:tcPr anchor="ctr" marL="45720" marR="45720" marT="18288" marB="18288">
+                    <a:solidFill>
+                      <a:srgbClr val="EEF5FB"/>
+                    </a:solidFill>
+                  </a:tcPr>
+                </a:tc>
+              </a:tr>
+              <a:tr h="310896">
+                <a:tc>
+                  <a:txBody>
+                    <a:bodyPr/>
+                    <a:lstStyle/>
+                    <a:p>
+                      <a:pPr algn="ctr"/>
+                      <a:r>
+                        <a:rPr sz="1500" b="1">
+                          <a:solidFill>
+                            <a:srgbClr val="101F37"/>
+                          </a:solidFill>
+                          <a:latin typeface="Arial"/>
+                          <a:ea typeface="Microsoft YaHei"/>
+                        </a:rPr>
+                        <a:t>Dr.Bokeh</a:t>
+                      </a:r>
+                    </a:p>
+                  </a:txBody>
+                  <a:tcPr anchor="ctr" marL="45720" marR="45720" marT="18288" marB="18288">
+                    <a:solidFill>
+                      <a:srgbClr val="FFFFFF"/>
+                    </a:solidFill>
+                  </a:tcPr>
+                </a:tc>
+                <a:tc>
+                  <a:txBody>
+                    <a:bodyPr/>
+                    <a:lstStyle/>
+                    <a:p>
+                      <a:pPr algn="ctr"/>
+                      <a:r>
+                        <a:rPr sz="1500" b="0">
+                          <a:solidFill>
+                            <a:srgbClr val="101F37"/>
+                          </a:solidFill>
+                          <a:latin typeface="Arial"/>
+                          <a:ea typeface="Microsoft YaHei"/>
+                        </a:rPr>
+                        <a:t>31.59</a:t>
+                      </a:r>
+                    </a:p>
+                  </a:txBody>
+                  <a:tcPr anchor="ctr" marL="45720" marR="45720" marT="18288" marB="18288">
+                    <a:solidFill>
+                      <a:srgbClr val="FFFFFF"/>
+                    </a:solidFill>
+                  </a:tcPr>
+                </a:tc>
+                <a:tc>
+                  <a:txBody>
+                    <a:bodyPr/>
+                    <a:lstStyle/>
+                    <a:p>
+                      <a:pPr algn="ctr"/>
+                      <a:r>
+                        <a:rPr sz="1500" b="0">
+                          <a:solidFill>
+                            <a:srgbClr val="101F37"/>
+                          </a:solidFill>
+                          <a:latin typeface="Arial"/>
+                          <a:ea typeface="Microsoft YaHei"/>
+                        </a:rPr>
+                        <a:t>0.973</a:t>
+                      </a:r>
+                    </a:p>
+                  </a:txBody>
+                  <a:tcPr anchor="ctr" marL="45720" marR="45720" marT="18288" marB="18288">
+                    <a:solidFill>
+                      <a:srgbClr val="FFFFFF"/>
+                    </a:solidFill>
+                  </a:tcPr>
+                </a:tc>
+                <a:tc>
+                  <a:txBody>
+                    <a:bodyPr/>
+                    <a:lstStyle/>
+                    <a:p>
+                      <a:pPr algn="ctr"/>
+                      <a:r>
+                        <a:rPr sz="1500" b="0">
+                          <a:solidFill>
+                            <a:srgbClr val="101F37"/>
+                          </a:solidFill>
+                          <a:latin typeface="Arial"/>
+                          <a:ea typeface="Microsoft YaHei"/>
+                        </a:rPr>
+                        <a:t>0.029</a:t>
+                      </a:r>
+                    </a:p>
+                  </a:txBody>
+                  <a:tcPr anchor="ctr" marL="45720" marR="45720" marT="18288" marB="18288">
+                    <a:solidFill>
+                      <a:srgbClr val="FFFFFF"/>
+                    </a:solidFill>
+                  </a:tcPr>
+                </a:tc>
+                <a:tc>
+                  <a:txBody>
+                    <a:bodyPr/>
+                    <a:lstStyle/>
+                    <a:p>
+                      <a:pPr algn="ctr"/>
+                      <a:r>
+                        <a:rPr sz="1500" b="0">
+                          <a:solidFill>
+                            <a:srgbClr val="101F37"/>
+                          </a:solidFill>
+                          <a:latin typeface="Arial"/>
+                          <a:ea typeface="Microsoft YaHei"/>
+                        </a:rPr>
+                        <a:t>25.86</a:t>
+                      </a:r>
+                    </a:p>
+                  </a:txBody>
+                  <a:tcPr anchor="ctr" marL="45720" marR="45720" marT="18288" marB="18288">
+                    <a:solidFill>
+                      <a:srgbClr val="FFFFFF"/>
+                    </a:solidFill>
+                  </a:tcPr>
+                </a:tc>
+                <a:tc>
+                  <a:txBody>
+                    <a:bodyPr/>
+                    <a:lstStyle/>
+                    <a:p>
+                      <a:pPr algn="ctr"/>
+                      <a:r>
+                        <a:rPr sz="1500" b="0">
+                          <a:solidFill>
+                            <a:srgbClr val="101F37"/>
+                          </a:solidFill>
+                          <a:latin typeface="Arial"/>
+                          <a:ea typeface="Microsoft YaHei"/>
+                        </a:rPr>
+                        <a:t>0.479</a:t>
+                      </a:r>
+                    </a:p>
+                  </a:txBody>
+                  <a:tcPr anchor="ctr" marL="45720" marR="45720" marT="18288" marB="18288">
+                    <a:solidFill>
+                      <a:srgbClr val="FFFFFF"/>
+                    </a:solidFill>
+                  </a:tcPr>
+                </a:tc>
+                <a:tc>
+                  <a:txBody>
+                    <a:bodyPr/>
+                    <a:lstStyle/>
+                    <a:p>
+                      <a:pPr algn="ctr"/>
+                      <a:r>
+                        <a:rPr sz="1500" b="0">
+                          <a:solidFill>
+                            <a:srgbClr val="101F37"/>
+                          </a:solidFill>
+                          <a:latin typeface="Arial"/>
+                          <a:ea typeface="Microsoft YaHei"/>
+                        </a:rPr>
+                        <a:t>0.0084</a:t>
+                      </a:r>
+                    </a:p>
+                  </a:txBody>
+                  <a:tcPr anchor="ctr" marL="45720" marR="45720" marT="18288" marB="18288">
+                    <a:solidFill>
+                      <a:srgbClr val="FFFFFF"/>
+                    </a:solidFill>
+                  </a:tcPr>
+                </a:tc>
+              </a:tr>
+              <a:tr h="310896">
+                <a:tc>
+                  <a:txBody>
+                    <a:bodyPr/>
+                    <a:lstStyle/>
+                    <a:p>
+                      <a:pPr algn="ctr"/>
+                      <a:r>
+                        <a:rPr sz="1500" b="1">
+                          <a:solidFill>
+                            <a:srgbClr val="101F37"/>
+                          </a:solidFill>
+                          <a:latin typeface="Arial"/>
+                          <a:ea typeface="Microsoft YaHei"/>
+                        </a:rPr>
+                        <a:t>BokehMe</a:t>
+                      </a:r>
+                    </a:p>
+                  </a:txBody>
+                  <a:tcPr anchor="ctr" marL="45720" marR="45720" marT="18288" marB="18288">
+                    <a:solidFill>
+                      <a:srgbClr val="EEF5FB"/>
+                    </a:solidFill>
+                  </a:tcPr>
+                </a:tc>
+                <a:tc>
+                  <a:txBody>
+                    <a:bodyPr/>
+                    <a:lstStyle/>
+                    <a:p>
+                      <a:pPr algn="ctr"/>
+                      <a:r>
+                        <a:rPr sz="1500" b="0">
+                          <a:solidFill>
+                            <a:srgbClr val="101F37"/>
+                          </a:solidFill>
+                          <a:latin typeface="Arial"/>
+                          <a:ea typeface="Microsoft YaHei"/>
+                        </a:rPr>
+                        <a:t>33.33</a:t>
+                      </a:r>
+                    </a:p>
+                  </a:txBody>
+                  <a:tcPr anchor="ctr" marL="45720" marR="45720" marT="18288" marB="18288">
+                    <a:solidFill>
+                      <a:srgbClr val="EEF5FB"/>
+                    </a:solidFill>
+                  </a:tcPr>
+                </a:tc>
+                <a:tc>
+                  <a:txBody>
+                    <a:bodyPr/>
+                    <a:lstStyle/>
+                    <a:p>
+                      <a:pPr algn="ctr"/>
+                      <a:r>
+                        <a:rPr sz="1500" b="0">
+                          <a:solidFill>
+                            <a:srgbClr val="101F37"/>
+                          </a:solidFill>
+                          <a:latin typeface="Arial"/>
+                          <a:ea typeface="Microsoft YaHei"/>
+                        </a:rPr>
+                        <a:t>0.979</a:t>
+                      </a:r>
+                    </a:p>
+                  </a:txBody>
+                  <a:tcPr anchor="ctr" marL="45720" marR="45720" marT="18288" marB="18288">
+                    <a:solidFill>
+                      <a:srgbClr val="EEF5FB"/>
+                    </a:solidFill>
+                  </a:tcPr>
+                </a:tc>
+                <a:tc>
+                  <a:txBody>
+                    <a:bodyPr/>
+                    <a:lstStyle/>
+                    <a:p>
+                      <a:pPr algn="ctr"/>
+                      <a:r>
+                        <a:rPr sz="1500" b="0">
+                          <a:solidFill>
+                            <a:srgbClr val="101F37"/>
+                          </a:solidFill>
+                          <a:latin typeface="Arial"/>
+                          <a:ea typeface="Microsoft YaHei"/>
+                        </a:rPr>
+                        <a:t>0.025</a:t>
+                      </a:r>
+                    </a:p>
+                  </a:txBody>
+                  <a:tcPr anchor="ctr" marL="45720" marR="45720" marT="18288" marB="18288">
+                    <a:solidFill>
+                      <a:srgbClr val="EEF5FB"/>
+                    </a:solidFill>
+                  </a:tcPr>
+                </a:tc>
+                <a:tc>
+                  <a:txBody>
+                    <a:bodyPr/>
+                    <a:lstStyle/>
+                    <a:p>
+                      <a:pPr algn="ctr"/>
+                      <a:r>
+                        <a:rPr sz="1500" b="0">
+                          <a:solidFill>
+                            <a:srgbClr val="101F37"/>
+                          </a:solidFill>
+                          <a:latin typeface="Arial"/>
+                          <a:ea typeface="Microsoft YaHei"/>
+                        </a:rPr>
+                        <a:t>18.55</a:t>
+                      </a:r>
+                    </a:p>
+                  </a:txBody>
+                  <a:tcPr anchor="ctr" marL="45720" marR="45720" marT="18288" marB="18288">
+                    <a:solidFill>
+                      <a:srgbClr val="EEF5FB"/>
+                    </a:solidFill>
+                  </a:tcPr>
+                </a:tc>
+                <a:tc>
+                  <a:txBody>
+                    <a:bodyPr/>
+                    <a:lstStyle/>
+                    <a:p>
+                      <a:pPr algn="ctr"/>
+                      <a:r>
+                        <a:rPr sz="1500" b="0">
+                          <a:solidFill>
+                            <a:srgbClr val="101F37"/>
+                          </a:solidFill>
+                          <a:latin typeface="Arial"/>
+                          <a:ea typeface="Microsoft YaHei"/>
+                        </a:rPr>
+                        <a:t>0.540</a:t>
+                      </a:r>
+                    </a:p>
+                  </a:txBody>
+                  <a:tcPr anchor="ctr" marL="45720" marR="45720" marT="18288" marB="18288">
+                    <a:solidFill>
+                      <a:srgbClr val="EEF5FB"/>
+                    </a:solidFill>
+                  </a:tcPr>
+                </a:tc>
+                <a:tc>
+                  <a:txBody>
+                    <a:bodyPr/>
+                    <a:lstStyle/>
+                    <a:p>
+                      <a:pPr algn="ctr"/>
+                      <a:r>
+                        <a:rPr sz="1500" b="0">
+                          <a:solidFill>
+                            <a:srgbClr val="101F37"/>
+                          </a:solidFill>
+                          <a:latin typeface="Arial"/>
+                          <a:ea typeface="Microsoft YaHei"/>
+                        </a:rPr>
+                        <a:t>0.0074</a:t>
+                      </a:r>
+                    </a:p>
+                  </a:txBody>
+                  <a:tcPr anchor="ctr" marL="45720" marR="45720" marT="18288" marB="18288">
+                    <a:solidFill>
+                      <a:srgbClr val="EEF5FB"/>
+                    </a:solidFill>
+                  </a:tcPr>
+                </a:tc>
+              </a:tr>
+              <a:tr h="310896">
+                <a:tc>
+                  <a:txBody>
+                    <a:bodyPr/>
+                    <a:lstStyle/>
+                    <a:p>
+                      <a:pPr algn="ctr"/>
+                      <a:r>
+                        <a:rPr sz="1500" b="1">
+                          <a:solidFill>
+                            <a:srgbClr val="101F37"/>
+                          </a:solidFill>
+                          <a:latin typeface="Arial"/>
+                          <a:ea typeface="Microsoft YaHei"/>
+                        </a:rPr>
+                        <a:t>MPIB</a:t>
+                      </a:r>
+                    </a:p>
+                  </a:txBody>
+                  <a:tcPr anchor="ctr" marL="45720" marR="45720" marT="18288" marB="18288">
+                    <a:solidFill>
+                      <a:srgbClr val="FFFFFF"/>
+                    </a:solidFill>
+                  </a:tcPr>
+                </a:tc>
+                <a:tc>
+                  <a:txBody>
+                    <a:bodyPr/>
+                    <a:lstStyle/>
+                    <a:p>
+                      <a:pPr algn="ctr"/>
+                      <a:r>
+                        <a:rPr sz="1500" b="0">
+                          <a:solidFill>
+                            <a:srgbClr val="101F37"/>
+                          </a:solidFill>
+                          <a:latin typeface="Arial"/>
+                          <a:ea typeface="Microsoft YaHei"/>
+                        </a:rPr>
+                        <a:t>31.62</a:t>
+                      </a:r>
+                    </a:p>
+                  </a:txBody>
+                  <a:tcPr anchor="ctr" marL="45720" marR="45720" marT="18288" marB="18288">
+                    <a:solidFill>
+                      <a:srgbClr val="FFFFFF"/>
+                    </a:solidFill>
+                  </a:tcPr>
+                </a:tc>
+                <a:tc>
+                  <a:txBody>
+                    <a:bodyPr/>
+                    <a:lstStyle/>
+                    <a:p>
+                      <a:pPr algn="ctr"/>
+                      <a:r>
+                        <a:rPr sz="1500" b="0">
+                          <a:solidFill>
+                            <a:srgbClr val="101F37"/>
+                          </a:solidFill>
+                          <a:latin typeface="Arial"/>
+                          <a:ea typeface="Microsoft YaHei"/>
+                        </a:rPr>
+                        <a:t>0.974</a:t>
+                      </a:r>
+                    </a:p>
+                  </a:txBody>
+                  <a:tcPr anchor="ctr" marL="45720" marR="45720" marT="18288" marB="18288">
+                    <a:solidFill>
+                      <a:srgbClr val="FFFFFF"/>
+                    </a:solidFill>
+                  </a:tcPr>
+                </a:tc>
+                <a:tc>
+                  <a:txBody>
+                    <a:bodyPr/>
+                    <a:lstStyle/>
+                    <a:p>
+                      <a:pPr algn="ctr"/>
+                      <a:r>
+                        <a:rPr sz="1500" b="0">
+                          <a:solidFill>
+                            <a:srgbClr val="101F37"/>
+                          </a:solidFill>
+                          <a:latin typeface="Arial"/>
+                          <a:ea typeface="Microsoft YaHei"/>
+                        </a:rPr>
+                        <a:t>0.028</a:t>
+                      </a:r>
+                    </a:p>
+                  </a:txBody>
+                  <a:tcPr anchor="ctr" marL="45720" marR="45720" marT="18288" marB="18288">
+                    <a:solidFill>
+                      <a:srgbClr val="FFFFFF"/>
+                    </a:solidFill>
+                  </a:tcPr>
+                </a:tc>
+                <a:tc>
+                  <a:txBody>
+                    <a:bodyPr/>
+                    <a:lstStyle/>
+                    <a:p>
+                      <a:pPr algn="ctr"/>
+                      <a:r>
+                        <a:rPr sz="1500" b="0">
+                          <a:solidFill>
+                            <a:srgbClr val="101F37"/>
+                          </a:solidFill>
+                          <a:latin typeface="Arial"/>
+                          <a:ea typeface="Microsoft YaHei"/>
+                        </a:rPr>
+                        <a:t>24.96</a:t>
+                      </a:r>
+                    </a:p>
+                  </a:txBody>
+                  <a:tcPr anchor="ctr" marL="45720" marR="45720" marT="18288" marB="18288">
+                    <a:solidFill>
+                      <a:srgbClr val="FFFFFF"/>
+                    </a:solidFill>
+                  </a:tcPr>
+                </a:tc>
+                <a:tc>
+                  <a:txBody>
+                    <a:bodyPr/>
+                    <a:lstStyle/>
+                    <a:p>
+                      <a:pPr algn="ctr"/>
+                      <a:r>
+                        <a:rPr sz="1500" b="0">
+                          <a:solidFill>
+                            <a:srgbClr val="101F37"/>
+                          </a:solidFill>
+                          <a:latin typeface="Arial"/>
+                          <a:ea typeface="Microsoft YaHei"/>
+                        </a:rPr>
+                        <a:t>0.450</a:t>
+                      </a:r>
+                    </a:p>
+                  </a:txBody>
+                  <a:tcPr anchor="ctr" marL="45720" marR="45720" marT="18288" marB="18288">
+                    <a:solidFill>
+                      <a:srgbClr val="FFFFFF"/>
+                    </a:solidFill>
+                  </a:tcPr>
+                </a:tc>
+                <a:tc>
+                  <a:txBody>
+                    <a:bodyPr/>
+                    <a:lstStyle/>
+                    <a:p>
+                      <a:pPr algn="ctr"/>
+                      <a:r>
+                        <a:rPr sz="1500" b="0">
+                          <a:solidFill>
+                            <a:srgbClr val="101F37"/>
+                          </a:solidFill>
+                          <a:latin typeface="Arial"/>
+                          <a:ea typeface="Microsoft YaHei"/>
+                        </a:rPr>
+                        <a:t>0.0082</a:t>
+                      </a:r>
+                    </a:p>
+                  </a:txBody>
+                  <a:tcPr anchor="ctr" marL="45720" marR="45720" marT="18288" marB="18288">
+                    <a:solidFill>
+                      <a:srgbClr val="FFFFFF"/>
+                    </a:solidFill>
+                  </a:tcPr>
+                </a:tc>
+              </a:tr>
+              <a:tr h="310896">
+                <a:tc>
+                  <a:txBody>
+                    <a:bodyPr/>
+                    <a:lstStyle/>
+                    <a:p>
+                      <a:pPr algn="ctr"/>
+                      <a:r>
+                        <a:rPr sz="1500" b="1">
+                          <a:solidFill>
+                            <a:srgbClr val="101F37"/>
+                          </a:solidFill>
+                          <a:latin typeface="Arial"/>
+                          <a:ea typeface="Microsoft YaHei"/>
+                        </a:rPr>
+                        <a:t>BokehDiff</a:t>
+                      </a:r>
+                    </a:p>
+                  </a:txBody>
+                  <a:tcPr anchor="ctr" marL="45720" marR="45720" marT="18288" marB="18288">
+                    <a:solidFill>
+                      <a:srgbClr val="EEF5FB"/>
+                    </a:solidFill>
+                  </a:tcPr>
+                </a:tc>
+                <a:tc>
+                  <a:txBody>
+                    <a:bodyPr/>
+                    <a:lstStyle/>
+                    <a:p>
+                      <a:pPr algn="ctr"/>
+                      <a:r>
+                        <a:rPr sz="1500" b="0">
+                          <a:solidFill>
+                            <a:srgbClr val="101F37"/>
+                          </a:solidFill>
+                          <a:latin typeface="Arial"/>
+                          <a:ea typeface="Microsoft YaHei"/>
+                        </a:rPr>
+                        <a:t>27.06</a:t>
+                      </a:r>
+                    </a:p>
+                  </a:txBody>
+                  <a:tcPr anchor="ctr" marL="45720" marR="45720" marT="18288" marB="18288">
+                    <a:solidFill>
+                      <a:srgbClr val="EEF5FB"/>
+                    </a:solidFill>
+                  </a:tcPr>
+                </a:tc>
+                <a:tc>
+                  <a:txBody>
+                    <a:bodyPr/>
+                    <a:lstStyle/>
+                    <a:p>
+                      <a:pPr algn="ctr"/>
+                      <a:r>
+                        <a:rPr sz="1500" b="0">
+                          <a:solidFill>
+                            <a:srgbClr val="101F37"/>
+                          </a:solidFill>
+                          <a:latin typeface="Arial"/>
+                          <a:ea typeface="Microsoft YaHei"/>
+                        </a:rPr>
+                        <a:t>0.844</a:t>
+                      </a:r>
+                    </a:p>
+                  </a:txBody>
+                  <a:tcPr anchor="ctr" marL="45720" marR="45720" marT="18288" marB="18288">
+                    <a:solidFill>
+                      <a:srgbClr val="EEF5FB"/>
+                    </a:solidFill>
+                  </a:tcPr>
+                </a:tc>
+                <a:tc>
+                  <a:txBody>
+                    <a:bodyPr/>
+                    <a:lstStyle/>
+                    <a:p>
+                      <a:pPr algn="ctr"/>
+                      <a:r>
+                        <a:rPr sz="1500" b="0">
+                          <a:solidFill>
+                            <a:srgbClr val="101F37"/>
+                          </a:solidFill>
+                          <a:latin typeface="Arial"/>
+                          <a:ea typeface="Microsoft YaHei"/>
+                        </a:rPr>
+                        <a:t>0.132</a:t>
+                      </a:r>
+                    </a:p>
+                  </a:txBody>
+                  <a:tcPr anchor="ctr" marL="45720" marR="45720" marT="18288" marB="18288">
+                    <a:solidFill>
+                      <a:srgbClr val="EEF5FB"/>
+                    </a:solidFill>
+                  </a:tcPr>
+                </a:tc>
+                <a:tc>
+                  <a:txBody>
+                    <a:bodyPr/>
+                    <a:lstStyle/>
+                    <a:p>
+                      <a:pPr algn="ctr"/>
+                      <a:r>
+                        <a:rPr sz="1500" b="0">
+                          <a:solidFill>
+                            <a:srgbClr val="101F37"/>
+                          </a:solidFill>
+                          <a:latin typeface="Arial"/>
+                          <a:ea typeface="Microsoft YaHei"/>
+                        </a:rPr>
+                        <a:t>66.00</a:t>
+                      </a:r>
+                    </a:p>
+                  </a:txBody>
+                  <a:tcPr anchor="ctr" marL="45720" marR="45720" marT="18288" marB="18288">
+                    <a:solidFill>
+                      <a:srgbClr val="EEF5FB"/>
+                    </a:solidFill>
+                  </a:tcPr>
+                </a:tc>
+                <a:tc>
+                  <a:txBody>
+                    <a:bodyPr/>
+                    <a:lstStyle/>
+                    <a:p>
+                      <a:pPr algn="ctr"/>
+                      <a:r>
+                        <a:rPr sz="1500" b="0">
+                          <a:solidFill>
+                            <a:srgbClr val="101F37"/>
+                          </a:solidFill>
+                          <a:latin typeface="Arial"/>
+                          <a:ea typeface="Microsoft YaHei"/>
+                        </a:rPr>
+                        <a:t>0.802</a:t>
+                      </a:r>
+                    </a:p>
+                  </a:txBody>
+                  <a:tcPr anchor="ctr" marL="45720" marR="45720" marT="18288" marB="18288">
+                    <a:solidFill>
+                      <a:srgbClr val="EEF5FB"/>
+                    </a:solidFill>
+                  </a:tcPr>
+                </a:tc>
+                <a:tc>
+                  <a:txBody>
+                    <a:bodyPr/>
+                    <a:lstStyle/>
+                    <a:p>
+                      <a:pPr algn="ctr"/>
+                      <a:r>
+                        <a:rPr sz="1500" b="0">
+                          <a:solidFill>
+                            <a:srgbClr val="101F37"/>
+                          </a:solidFill>
+                          <a:latin typeface="Arial"/>
+                          <a:ea typeface="Microsoft YaHei"/>
+                        </a:rPr>
+                        <a:t>0.0216</a:t>
+                      </a:r>
+                    </a:p>
+                  </a:txBody>
+                  <a:tcPr anchor="ctr" marL="45720" marR="45720" marT="18288" marB="18288">
+                    <a:solidFill>
+                      <a:srgbClr val="EEF5FB"/>
+                    </a:solidFill>
+                  </a:tcPr>
+                </a:tc>
+              </a:tr>
+              <a:tr h="310896">
+                <a:tc>
+                  <a:txBody>
+                    <a:bodyPr/>
+                    <a:lstStyle/>
+                    <a:p>
+                      <a:pPr algn="ctr"/>
+                      <a:r>
+                        <a:rPr sz="1500" b="1">
+                          <a:solidFill>
+                            <a:srgbClr val="101F37"/>
+                          </a:solidFill>
+                          <a:latin typeface="Arial"/>
+                          <a:ea typeface="Microsoft YaHei"/>
+                        </a:rPr>
+                        <a:t>Any-to-Bokeh</a:t>
+                      </a:r>
+                    </a:p>
+                  </a:txBody>
+                  <a:tcPr anchor="ctr" marL="45720" marR="45720" marT="18288" marB="18288">
+                    <a:solidFill>
+                      <a:srgbClr val="FFFFFF"/>
+                    </a:solidFill>
+                  </a:tcPr>
+                </a:tc>
+                <a:tc>
+                  <a:txBody>
+                    <a:bodyPr/>
+                    <a:lstStyle/>
+                    <a:p>
+                      <a:pPr algn="ctr"/>
+                      <a:r>
+                        <a:rPr sz="1500" b="1">
+                          <a:solidFill>
+                            <a:srgbClr val="101F37"/>
+                          </a:solidFill>
+                          <a:latin typeface="Arial"/>
+                          <a:ea typeface="Microsoft YaHei"/>
+                        </a:rPr>
+                        <a:t>39.71</a:t>
+                      </a:r>
+                    </a:p>
+                  </a:txBody>
+                  <a:tcPr anchor="ctr" marL="45720" marR="45720" marT="18288" marB="18288">
+                    <a:solidFill>
+                      <a:srgbClr val="FFFFFF"/>
+                    </a:solidFill>
+                  </a:tcPr>
+                </a:tc>
+                <a:tc>
+                  <a:txBody>
+                    <a:bodyPr/>
+                    <a:lstStyle/>
+                    <a:p>
+                      <a:pPr algn="ctr"/>
+                      <a:r>
+                        <a:rPr sz="1500" b="1">
+                          <a:solidFill>
+                            <a:srgbClr val="101F37"/>
+                          </a:solidFill>
+                          <a:latin typeface="Arial"/>
+                          <a:ea typeface="Microsoft YaHei"/>
+                        </a:rPr>
+                        <a:t>0.986</a:t>
+                      </a:r>
+                    </a:p>
+                  </a:txBody>
+                  <a:tcPr anchor="ctr" marL="45720" marR="45720" marT="18288" marB="18288">
+                    <a:solidFill>
+                      <a:srgbClr val="FFFFFF"/>
+                    </a:solidFill>
+                  </a:tcPr>
+                </a:tc>
+                <a:tc>
+                  <a:txBody>
+                    <a:bodyPr/>
+                    <a:lstStyle/>
+                    <a:p>
+                      <a:pPr algn="ctr"/>
+                      <a:r>
+                        <a:rPr sz="1500" b="1">
+                          <a:solidFill>
+                            <a:srgbClr val="101F37"/>
+                          </a:solidFill>
+                          <a:latin typeface="Arial"/>
+                          <a:ea typeface="Microsoft YaHei"/>
+                        </a:rPr>
+                        <a:t>0.015</a:t>
+                      </a:r>
+                    </a:p>
+                  </a:txBody>
+                  <a:tcPr anchor="ctr" marL="45720" marR="45720" marT="18288" marB="18288">
+                    <a:solidFill>
+                      <a:srgbClr val="FFFFFF"/>
+                    </a:solidFill>
+                  </a:tcPr>
+                </a:tc>
+                <a:tc>
+                  <a:txBody>
+                    <a:bodyPr/>
+                    <a:lstStyle/>
+                    <a:p>
+                      <a:pPr algn="ctr"/>
+                      <a:r>
+                        <a:rPr sz="1500" b="1">
+                          <a:solidFill>
+                            <a:srgbClr val="101F37"/>
+                          </a:solidFill>
+                          <a:latin typeface="Arial"/>
+                          <a:ea typeface="Microsoft YaHei"/>
+                        </a:rPr>
+                        <a:t>8.94</a:t>
+                      </a:r>
+                    </a:p>
+                  </a:txBody>
+                  <a:tcPr anchor="ctr" marL="45720" marR="45720" marT="18288" marB="18288">
+                    <a:solidFill>
+                      <a:srgbClr val="FFFFFF"/>
+                    </a:solidFill>
+                  </a:tcPr>
+                </a:tc>
+                <a:tc>
+                  <a:txBody>
+                    <a:bodyPr/>
+                    <a:lstStyle/>
+                    <a:p>
+                      <a:pPr algn="ctr"/>
+                      <a:r>
+                        <a:rPr sz="1500" b="1">
+                          <a:solidFill>
+                            <a:srgbClr val="101F37"/>
+                          </a:solidFill>
+                          <a:latin typeface="Arial"/>
+                          <a:ea typeface="Microsoft YaHei"/>
+                        </a:rPr>
+                        <a:t>0.445</a:t>
+                      </a:r>
+                    </a:p>
+                  </a:txBody>
+                  <a:tcPr anchor="ctr" marL="45720" marR="45720" marT="18288" marB="18288">
+                    <a:solidFill>
+                      <a:srgbClr val="FFFFFF"/>
+                    </a:solidFill>
+                  </a:tcPr>
+                </a:tc>
+                <a:tc>
+                  <a:txBody>
+                    <a:bodyPr/>
+                    <a:lstStyle/>
+                    <a:p>
+                      <a:pPr algn="ctr"/>
+                      <a:r>
+                        <a:rPr sz="1500" b="1">
+                          <a:solidFill>
+                            <a:srgbClr val="101F37"/>
+                          </a:solidFill>
+                          <a:latin typeface="Arial"/>
+                          <a:ea typeface="Microsoft YaHei"/>
+                        </a:rPr>
+                        <a:t>0.0056</a:t>
+                      </a:r>
+                    </a:p>
+                  </a:txBody>
+                  <a:tcPr anchor="ctr" marL="45720" marR="45720" marT="18288" marB="18288">
+                    <a:solidFill>
+                      <a:srgbClr val="FFFFFF"/>
+                    </a:solidFill>
+                  </a:tcPr>
+                </a:tc>
+              </a:tr>
+            </a:tbl>
+          </a:graphicData>
+        </a:graphic>
+      </p:graphicFrame>
       <p:graphicFrame>
         <p:nvGraphicFramePr>
           <p:cNvPr id="25" name="Table 24"/>
@@ -8107,8 +9292,8 @@
           <p:nvPr/>
         </p:nvGraphicFramePr>
         <p:xfrm>
-          <a:off x="731520" y="1874519"/>
-          <a:ext cx="5166359" cy="3840480"/>
+          <a:off x="868679" y="3886200"/>
+          <a:ext cx="10332720" cy="2176272"/>
         </p:xfrm>
         <a:graphic>
           <a:graphicData uri="http://schemas.openxmlformats.org/drawingml/2006/table">
@@ -8117,12 +9302,15 @@
                 <a:tableStyleId>{5C22544A-7EE6-4342-B048-85BDC9FD1C3A}</a:tableStyleId>
               </a:tblPr>
               <a:tblGrid>
-                <a:gridCol w="1874519"/>
-                <a:gridCol w="1097280"/>
-                <a:gridCol w="1097280"/>
-                <a:gridCol w="1097280"/>
+                <a:gridCol w="2103120"/>
+                <a:gridCol w="1371600"/>
+                <a:gridCol w="1371600"/>
+                <a:gridCol w="1371600"/>
+                <a:gridCol w="1371600"/>
+                <a:gridCol w="1371600"/>
+                <a:gridCol w="1371600"/>
               </a:tblGrid>
-              <a:tr h="548640">
+              <a:tr h="310896">
                 <a:tc>
                   <a:txBody>
                     <a:bodyPr/>
@@ -8137,7 +9325,7 @@
                           <a:latin typeface="Arial"/>
                           <a:ea typeface="Microsoft YaHei"/>
                         </a:rPr>
-                        <a:t>方法</a:t>
+                        <a:t>论文报告</a:t>
                       </a:r>
                     </a:p>
                   </a:txBody>
@@ -8219,8 +9407,80 @@
                     </a:solidFill>
                   </a:tcPr>
                 </a:tc>
+                <a:tc>
+                  <a:txBody>
+                    <a:bodyPr/>
+                    <a:lstStyle/>
+                    <a:p>
+                      <a:pPr algn="ctr"/>
+                      <a:r>
+                        <a:rPr sz="1500" b="1">
+                          <a:solidFill>
+                            <a:srgbClr val="FFFFFF"/>
+                          </a:solidFill>
+                          <a:latin typeface="Arial"/>
+                          <a:ea typeface="Microsoft YaHei"/>
+                        </a:rPr>
+                        <a:t>FVD ↓</a:t>
+                      </a:r>
+                    </a:p>
+                  </a:txBody>
+                  <a:tcPr anchor="ctr" marL="45720" marR="45720" marT="18288" marB="18288">
+                    <a:solidFill>
+                      <a:srgbClr val="0D569A"/>
+                    </a:solidFill>
+                  </a:tcPr>
+                </a:tc>
+                <a:tc>
+                  <a:txBody>
+                    <a:bodyPr/>
+                    <a:lstStyle/>
+                    <a:p>
+                      <a:pPr algn="ctr"/>
+                      <a:r>
+                        <a:rPr sz="1500" b="1">
+                          <a:solidFill>
+                            <a:srgbClr val="FFFFFF"/>
+                          </a:solidFill>
+                          <a:latin typeface="Arial"/>
+                          <a:ea typeface="Microsoft YaHei"/>
+                        </a:rPr>
+                        <a:t>FD ↓</a:t>
+                      </a:r>
+                    </a:p>
+                  </a:txBody>
+                  <a:tcPr anchor="ctr" marL="45720" marR="45720" marT="18288" marB="18288">
+                    <a:solidFill>
+                      <a:srgbClr val="0D569A"/>
+                    </a:solidFill>
+                  </a:tcPr>
+                </a:tc>
+                <a:tc>
+                  <a:txBody>
+                    <a:bodyPr/>
+                    <a:lstStyle/>
+                    <a:p>
+                      <a:pPr algn="ctr"/>
+                      <a:r>
+                        <a:rPr sz="1500" b="1">
+                          <a:solidFill>
+                            <a:srgbClr val="FFFFFF"/>
+                          </a:solidFill>
+                          <a:latin typeface="Arial"/>
+                          <a:ea typeface="Microsoft YaHei"/>
+                        </a:rPr>
+                        <a:t>RM ↓</a:t>
+                      </a:r>
+                    </a:p>
+                  </a:txBody>
+                  <a:tcPr anchor="ctr" marL="45720" marR="45720" marT="18288" marB="18288">
+                    <a:solidFill>
+                      <a:srgbClr val="0D569A"/>
+                    </a:solidFill>
+                  </a:tcPr>
+                </a:tc>
               </a:tr>
-              <a:tr h="548640">
+              <a:tr h="310896">
                 <a:tc>
                   <a:txBody>
                     <a:bodyPr/>
@@ -8259,19 +9519,6 @@
                           <a:latin typeface="Arial"/>
                           <a:ea typeface="Microsoft YaHei"/>
                         </a:rPr>
-                        <a:t>28.17</a:t>
-                      </a:r>
-                    </a:p>
-                    <a:p>
-                      <a:pPr algn="ctr"/>
-                      <a:r>
-                        <a:rPr sz="1100" b="0">
-                          <a:solidFill>
-                            <a:srgbClr val="6B7A90"/>
-                          </a:solidFill>
-                          <a:latin typeface="Arial"/>
-                          <a:ea typeface="Microsoft YaHei"/>
-                        </a:rPr>
                         <a:t>24.574</a:t>
                       </a:r>
                     </a:p>
@@ -8296,19 +9543,6 @@
                           <a:latin typeface="Arial"/>
                           <a:ea typeface="Microsoft YaHei"/>
                         </a:rPr>
-                        <a:t>0.944</a:t>
-                      </a:r>
-                    </a:p>
-                    <a:p>
-                      <a:pPr algn="ctr"/>
-                      <a:r>
-                        <a:rPr sz="1100" b="0">
-                          <a:solidFill>
-                            <a:srgbClr val="6B7A90"/>
-                          </a:solidFill>
-                          <a:latin typeface="Arial"/>
-                          <a:ea typeface="Microsoft YaHei"/>
-                        </a:rPr>
                         <a:t>0.819</a:t>
                       </a:r>
                     </a:p>
@@ -8333,19 +9567,6 @@
                           <a:latin typeface="Arial"/>
                           <a:ea typeface="Microsoft YaHei"/>
                         </a:rPr>
-                        <a:t>0.063</a:t>
-                      </a:r>
-                    </a:p>
-                    <a:p>
-                      <a:pPr algn="ctr"/>
-                      <a:r>
-                        <a:rPr sz="1100" b="0">
-                          <a:solidFill>
-                            <a:srgbClr val="6B7A90"/>
-                          </a:solidFill>
-                          <a:latin typeface="Arial"/>
-                          <a:ea typeface="Microsoft YaHei"/>
-                        </a:rPr>
                         <a:t>0.183</a:t>
                       </a:r>
                     </a:p>
@@ -8356,8 +9577,80 @@
                     </a:solidFill>
                   </a:tcPr>
                 </a:tc>
+                <a:tc>
+                  <a:txBody>
+                    <a:bodyPr/>
+                    <a:lstStyle/>
+                    <a:p>
+                      <a:pPr algn="ctr"/>
+                      <a:r>
+                        <a:rPr sz="1500" b="0">
+                          <a:solidFill>
+                            <a:srgbClr val="101F37"/>
+                          </a:solidFill>
+                          <a:latin typeface="Arial"/>
+                          <a:ea typeface="Microsoft YaHei"/>
+                        </a:rPr>
+                        <a:t>125.338</a:t>
+                      </a:r>
+                    </a:p>
+                  </a:txBody>
+                  <a:tcPr anchor="ctr" marL="45720" marR="45720" marT="18288" marB="18288">
+                    <a:solidFill>
+                      <a:srgbClr val="EEF5FB"/>
+                    </a:solidFill>
+                  </a:tcPr>
+                </a:tc>
+                <a:tc>
+                  <a:txBody>
+                    <a:bodyPr/>
+                    <a:lstStyle/>
+                    <a:p>
+                      <a:pPr algn="ctr"/>
+                      <a:r>
+                        <a:rPr sz="1500" b="0">
+                          <a:solidFill>
+                            <a:srgbClr val="101F37"/>
+                          </a:solidFill>
+                          <a:latin typeface="Arial"/>
+                          <a:ea typeface="Microsoft YaHei"/>
+                        </a:rPr>
+                        <a:t>1.162</a:t>
+                      </a:r>
+                    </a:p>
+                  </a:txBody>
+                  <a:tcPr anchor="ctr" marL="45720" marR="45720" marT="18288" marB="18288">
+                    <a:solidFill>
+                      <a:srgbClr val="EEF5FB"/>
+                    </a:solidFill>
+                  </a:tcPr>
+                </a:tc>
+                <a:tc>
+                  <a:txBody>
+                    <a:bodyPr/>
+                    <a:lstStyle/>
+                    <a:p>
+                      <a:pPr algn="ctr"/>
+                      <a:r>
+                        <a:rPr sz="1500" b="0">
+                          <a:solidFill>
+                            <a:srgbClr val="101F37"/>
+                          </a:solidFill>
+                          <a:latin typeface="Arial"/>
+                          <a:ea typeface="Microsoft YaHei"/>
+                        </a:rPr>
+                        <a:t>0.030</a:t>
+                      </a:r>
+                    </a:p>
+                  </a:txBody>
+                  <a:tcPr anchor="ctr" marL="45720" marR="45720" marT="18288" marB="18288">
+                    <a:solidFill>
+                      <a:srgbClr val="EEF5FB"/>
+                    </a:solidFill>
+                  </a:tcPr>
+                </a:tc>
               </a:tr>
-              <a:tr h="548640">
+              <a:tr h="310896">
                 <a:tc>
                   <a:txBody>
                     <a:bodyPr/>
@@ -8396,19 +9689,6 @@
                           <a:latin typeface="Arial"/>
                           <a:ea typeface="Microsoft YaHei"/>
                         </a:rPr>
-                        <a:t>31.59</a:t>
-                      </a:r>
-                    </a:p>
-                    <a:p>
-                      <a:pPr algn="ctr"/>
-                      <a:r>
-                        <a:rPr sz="1100" b="0">
-                          <a:solidFill>
-                            <a:srgbClr val="6B7A90"/>
-                          </a:solidFill>
-                          <a:latin typeface="Arial"/>
-                          <a:ea typeface="Microsoft YaHei"/>
-                        </a:rPr>
                         <a:t>31.273</a:t>
                       </a:r>
                     </a:p>
@@ -8433,19 +9713,6 @@
                           <a:latin typeface="Arial"/>
                           <a:ea typeface="Microsoft YaHei"/>
                         </a:rPr>
-                        <a:t>0.973</a:t>
-                      </a:r>
-                    </a:p>
-                    <a:p>
-                      <a:pPr algn="ctr"/>
-                      <a:r>
-                        <a:rPr sz="1100" b="0">
-                          <a:solidFill>
-                            <a:srgbClr val="6B7A90"/>
-                          </a:solidFill>
-                          <a:latin typeface="Arial"/>
-                          <a:ea typeface="Microsoft YaHei"/>
-                        </a:rPr>
                         <a:t>0.950</a:t>
                       </a:r>
                     </a:p>
@@ -8470,19 +9737,6 @@
                           <a:latin typeface="Arial"/>
                           <a:ea typeface="Microsoft YaHei"/>
                         </a:rPr>
-                        <a:t>0.029</a:t>
-                      </a:r>
-                    </a:p>
-                    <a:p>
-                      <a:pPr algn="ctr"/>
-                      <a:r>
-                        <a:rPr sz="1100" b="0">
-                          <a:solidFill>
-                            <a:srgbClr val="6B7A90"/>
-                          </a:solidFill>
-                          <a:latin typeface="Arial"/>
-                          <a:ea typeface="Microsoft YaHei"/>
-                        </a:rPr>
                         <a:t>0.046</a:t>
                       </a:r>
                     </a:p>
@@ -8493,8 +9747,80 @@
                     </a:solidFill>
                   </a:tcPr>
                 </a:tc>
+                <a:tc>
+                  <a:txBody>
+                    <a:bodyPr/>
+                    <a:lstStyle/>
+                    <a:p>
+                      <a:pPr algn="ctr"/>
+                      <a:r>
+                        <a:rPr sz="1500" b="0">
+                          <a:solidFill>
+                            <a:srgbClr val="101F37"/>
+                          </a:solidFill>
+                          <a:latin typeface="Arial"/>
+                          <a:ea typeface="Microsoft YaHei"/>
+                        </a:rPr>
+                        <a:t>32.710</a:t>
+                      </a:r>
+                    </a:p>
+                  </a:txBody>
+                  <a:tcPr anchor="ctr" marL="45720" marR="45720" marT="18288" marB="18288">
+                    <a:solidFill>
+                      <a:srgbClr val="FFFFFF"/>
+                    </a:solidFill>
+                  </a:tcPr>
+                </a:tc>
+                <a:tc>
+                  <a:txBody>
+                    <a:bodyPr/>
+                    <a:lstStyle/>
+                    <a:p>
+                      <a:pPr algn="ctr"/>
+                      <a:r>
+                        <a:rPr sz="1500" b="0">
+                          <a:solidFill>
+                            <a:srgbClr val="101F37"/>
+                          </a:solidFill>
+                          <a:latin typeface="Arial"/>
+                          <a:ea typeface="Microsoft YaHei"/>
+                        </a:rPr>
+                        <a:t>0.522</a:t>
+                      </a:r>
+                    </a:p>
+                  </a:txBody>
+                  <a:tcPr anchor="ctr" marL="45720" marR="45720" marT="18288" marB="18288">
+                    <a:solidFill>
+                      <a:srgbClr val="FFFFFF"/>
+                    </a:solidFill>
+                  </a:tcPr>
+                </a:tc>
+                <a:tc>
+                  <a:txBody>
+                    <a:bodyPr/>
+                    <a:lstStyle/>
+                    <a:p>
+                      <a:pPr algn="ctr"/>
+                      <a:r>
+                        <a:rPr sz="1500" b="0">
+                          <a:solidFill>
+                            <a:srgbClr val="101F37"/>
+                          </a:solidFill>
+                          <a:latin typeface="Arial"/>
+                          <a:ea typeface="Microsoft YaHei"/>
+                        </a:rPr>
+                        <a:t>0.011</a:t>
+                      </a:r>
+                    </a:p>
+                  </a:txBody>
+                  <a:tcPr anchor="ctr" marL="45720" marR="45720" marT="18288" marB="18288">
+                    <a:solidFill>
+                      <a:srgbClr val="FFFFFF"/>
+                    </a:solidFill>
+                  </a:tcPr>
+                </a:tc>
               </a:tr>
-              <a:tr h="548640">
+              <a:tr h="310896">
                 <a:tc>
                   <a:txBody>
                     <a:bodyPr/>
@@ -8533,19 +9859,6 @@
                           <a:latin typeface="Arial"/>
                           <a:ea typeface="Microsoft YaHei"/>
                         </a:rPr>
-                        <a:t>33.33</a:t>
-                      </a:r>
-                    </a:p>
-                    <a:p>
-                      <a:pPr algn="ctr"/>
-                      <a:r>
-                        <a:rPr sz="1100" b="0">
-                          <a:solidFill>
-                            <a:srgbClr val="6B7A90"/>
-                          </a:solidFill>
-                          <a:latin typeface="Arial"/>
-                          <a:ea typeface="Microsoft YaHei"/>
-                        </a:rPr>
                         <a:t>27.992</a:t>
                       </a:r>
                     </a:p>
@@ -8570,19 +9883,6 @@
                           <a:latin typeface="Arial"/>
                           <a:ea typeface="Microsoft YaHei"/>
                         </a:rPr>
-                        <a:t>0.979</a:t>
-                      </a:r>
-                    </a:p>
-                    <a:p>
-                      <a:pPr algn="ctr"/>
-                      <a:r>
-                        <a:rPr sz="1100" b="0">
-                          <a:solidFill>
-                            <a:srgbClr val="6B7A90"/>
-                          </a:solidFill>
-                          <a:latin typeface="Arial"/>
-                          <a:ea typeface="Microsoft YaHei"/>
-                        </a:rPr>
                         <a:t>0.936</a:t>
                       </a:r>
                     </a:p>
@@ -8607,19 +9907,6 @@
                           <a:latin typeface="Arial"/>
                           <a:ea typeface="Microsoft YaHei"/>
                         </a:rPr>
-                        <a:t>0.025</a:t>
-                      </a:r>
-                    </a:p>
-                    <a:p>
-                      <a:pPr algn="ctr"/>
-                      <a:r>
-                        <a:rPr sz="1100" b="0">
-                          <a:solidFill>
-                            <a:srgbClr val="6B7A90"/>
-                          </a:solidFill>
-                          <a:latin typeface="Arial"/>
-                          <a:ea typeface="Microsoft YaHei"/>
-                        </a:rPr>
                         <a:t>0.060</a:t>
                       </a:r>
                     </a:p>
@@ -8630,8 +9917,80 @@
                     </a:solidFill>
                   </a:tcPr>
                 </a:tc>
+                <a:tc>
+                  <a:txBody>
+                    <a:bodyPr/>
+                    <a:lstStyle/>
+                    <a:p>
+                      <a:pPr algn="ctr"/>
+                      <a:r>
+                        <a:rPr sz="1500" b="0">
+                          <a:solidFill>
+                            <a:srgbClr val="101F37"/>
+                          </a:solidFill>
+                          <a:latin typeface="Arial"/>
+                          <a:ea typeface="Microsoft YaHei"/>
+                        </a:rPr>
+                        <a:t>39.102</a:t>
+                      </a:r>
+                    </a:p>
+                  </a:txBody>
+                  <a:tcPr anchor="ctr" marL="45720" marR="45720" marT="18288" marB="18288">
+                    <a:solidFill>
+                      <a:srgbClr val="EEF5FB"/>
+                    </a:solidFill>
+                  </a:tcPr>
+                </a:tc>
+                <a:tc>
+                  <a:txBody>
+                    <a:bodyPr/>
+                    <a:lstStyle/>
+                    <a:p>
+                      <a:pPr algn="ctr"/>
+                      <a:r>
+                        <a:rPr sz="1500" b="0">
+                          <a:solidFill>
+                            <a:srgbClr val="101F37"/>
+                          </a:solidFill>
+                          <a:latin typeface="Arial"/>
+                          <a:ea typeface="Microsoft YaHei"/>
+                        </a:rPr>
+                        <a:t>0.536</a:t>
+                      </a:r>
+                    </a:p>
+                  </a:txBody>
+                  <a:tcPr anchor="ctr" marL="45720" marR="45720" marT="18288" marB="18288">
+                    <a:solidFill>
+                      <a:srgbClr val="EEF5FB"/>
+                    </a:solidFill>
+                  </a:tcPr>
+                </a:tc>
+                <a:tc>
+                  <a:txBody>
+                    <a:bodyPr/>
+                    <a:lstStyle/>
+                    <a:p>
+                      <a:pPr algn="ctr"/>
+                      <a:r>
+                        <a:rPr sz="1500" b="0">
+                          <a:solidFill>
+                            <a:srgbClr val="101F37"/>
+                          </a:solidFill>
+                          <a:latin typeface="Arial"/>
+                          <a:ea typeface="Microsoft YaHei"/>
+                        </a:rPr>
+                        <a:t>0.013</a:t>
+                      </a:r>
+                    </a:p>
+                  </a:txBody>
+                  <a:tcPr anchor="ctr" marL="45720" marR="45720" marT="18288" marB="18288">
+                    <a:solidFill>
+                      <a:srgbClr val="EEF5FB"/>
+                    </a:solidFill>
+                  </a:tcPr>
+                </a:tc>
               </a:tr>
-              <a:tr h="548640">
+              <a:tr h="310896">
                 <a:tc>
                   <a:txBody>
                     <a:bodyPr/>
@@ -8670,19 +10029,6 @@
                           <a:latin typeface="Arial"/>
                           <a:ea typeface="Microsoft YaHei"/>
                         </a:rPr>
-                        <a:t>31.62</a:t>
-                      </a:r>
-                    </a:p>
-                    <a:p>
-                      <a:pPr algn="ctr"/>
-                      <a:r>
-                        <a:rPr sz="1100" b="0">
-                          <a:solidFill>
-                            <a:srgbClr val="6B7A90"/>
-                          </a:solidFill>
-                          <a:latin typeface="Arial"/>
-                          <a:ea typeface="Microsoft YaHei"/>
-                        </a:rPr>
                         <a:t>31.390</a:t>
                       </a:r>
                     </a:p>
@@ -8707,22 +10053,349 @@
                           <a:latin typeface="Arial"/>
                           <a:ea typeface="Microsoft YaHei"/>
                         </a:rPr>
+                        <a:t>0.950</a:t>
+                      </a:r>
+                    </a:p>
+                  </a:txBody>
+                  <a:tcPr anchor="ctr" marL="45720" marR="45720" marT="18288" marB="18288">
+                    <a:solidFill>
+                      <a:srgbClr val="FFFFFF"/>
+                    </a:solidFill>
+                  </a:tcPr>
+                </a:tc>
+                <a:tc>
+                  <a:txBody>
+                    <a:bodyPr/>
+                    <a:lstStyle/>
+                    <a:p>
+                      <a:pPr algn="ctr"/>
+                      <a:r>
+                        <a:rPr sz="1500" b="0">
+                          <a:solidFill>
+                            <a:srgbClr val="101F37"/>
+                          </a:solidFill>
+                          <a:latin typeface="Arial"/>
+                          <a:ea typeface="Microsoft YaHei"/>
+                        </a:rPr>
+                        <a:t>0.040</a:t>
+                      </a:r>
+                    </a:p>
+                  </a:txBody>
+                  <a:tcPr anchor="ctr" marL="45720" marR="45720" marT="18288" marB="18288">
+                    <a:solidFill>
+                      <a:srgbClr val="FFFFFF"/>
+                    </a:solidFill>
+                  </a:tcPr>
+                </a:tc>
+                <a:tc>
+                  <a:txBody>
+                    <a:bodyPr/>
+                    <a:lstStyle/>
+                    <a:p>
+                      <a:pPr algn="ctr"/>
+                      <a:r>
+                        <a:rPr sz="1500" b="0">
+                          <a:solidFill>
+                            <a:srgbClr val="101F37"/>
+                          </a:solidFill>
+                          <a:latin typeface="Arial"/>
+                          <a:ea typeface="Microsoft YaHei"/>
+                        </a:rPr>
+                        <a:t>35.766</a:t>
+                      </a:r>
+                    </a:p>
+                  </a:txBody>
+                  <a:tcPr anchor="ctr" marL="45720" marR="45720" marT="18288" marB="18288">
+                    <a:solidFill>
+                      <a:srgbClr val="FFFFFF"/>
+                    </a:solidFill>
+                  </a:tcPr>
+                </a:tc>
+                <a:tc>
+                  <a:txBody>
+                    <a:bodyPr/>
+                    <a:lstStyle/>
+                    <a:p>
+                      <a:pPr algn="ctr"/>
+                      <a:r>
+                        <a:rPr sz="1500" b="0">
+                          <a:solidFill>
+                            <a:srgbClr val="101F37"/>
+                          </a:solidFill>
+                          <a:latin typeface="Arial"/>
+                          <a:ea typeface="Microsoft YaHei"/>
+                        </a:rPr>
+                        <a:t>0.481</a:t>
+                      </a:r>
+                    </a:p>
+                  </a:txBody>
+                  <a:tcPr anchor="ctr" marL="45720" marR="45720" marT="18288" marB="18288">
+                    <a:solidFill>
+                      <a:srgbClr val="FFFFFF"/>
+                    </a:solidFill>
+                  </a:tcPr>
+                </a:tc>
+                <a:tc>
+                  <a:txBody>
+                    <a:bodyPr/>
+                    <a:lstStyle/>
+                    <a:p>
+                      <a:pPr algn="ctr"/>
+                      <a:r>
+                        <a:rPr sz="1500" b="0">
+                          <a:solidFill>
+                            <a:srgbClr val="101F37"/>
+                          </a:solidFill>
+                          <a:latin typeface="Arial"/>
+                          <a:ea typeface="Microsoft YaHei"/>
+                        </a:rPr>
+                        <a:t>0.011</a:t>
+                      </a:r>
+                    </a:p>
+                  </a:txBody>
+                  <a:tcPr anchor="ctr" marL="45720" marR="45720" marT="18288" marB="18288">
+                    <a:solidFill>
+                      <a:srgbClr val="FFFFFF"/>
+                    </a:solidFill>
+                  </a:tcPr>
+                </a:tc>
+              </a:tr>
+              <a:tr h="310896">
+                <a:tc>
+                  <a:txBody>
+                    <a:bodyPr/>
+                    <a:lstStyle/>
+                    <a:p>
+                      <a:pPr algn="ctr"/>
+                      <a:r>
+                        <a:rPr sz="1500" b="1">
+                          <a:solidFill>
+                            <a:srgbClr val="101F37"/>
+                          </a:solidFill>
+                          <a:latin typeface="Arial"/>
+                          <a:ea typeface="Microsoft YaHei"/>
+                        </a:rPr>
+                        <a:t>BokehDiff</a:t>
+                      </a:r>
+                    </a:p>
+                  </a:txBody>
+                  <a:tcPr anchor="ctr" marL="45720" marR="45720" marT="18288" marB="18288">
+                    <a:solidFill>
+                      <a:srgbClr val="EEF5FB"/>
+                    </a:solidFill>
+                  </a:tcPr>
+                </a:tc>
+                <a:tc>
+                  <a:txBody>
+                    <a:bodyPr/>
+                    <a:lstStyle/>
+                    <a:p>
+                      <a:pPr algn="ctr"/>
+                      <a:r>
+                        <a:rPr sz="1500" b="0">
+                          <a:solidFill>
+                            <a:srgbClr val="101F37"/>
+                          </a:solidFill>
+                          <a:latin typeface="Arial"/>
+                          <a:ea typeface="Microsoft YaHei"/>
+                        </a:rPr>
+                        <a:t>27.525</a:t>
+                      </a:r>
+                    </a:p>
+                  </a:txBody>
+                  <a:tcPr anchor="ctr" marL="45720" marR="45720" marT="18288" marB="18288">
+                    <a:solidFill>
+                      <a:srgbClr val="EEF5FB"/>
+                    </a:solidFill>
+                  </a:tcPr>
+                </a:tc>
+                <a:tc>
+                  <a:txBody>
+                    <a:bodyPr/>
+                    <a:lstStyle/>
+                    <a:p>
+                      <a:pPr algn="ctr"/>
+                      <a:r>
+                        <a:rPr sz="1500" b="0">
+                          <a:solidFill>
+                            <a:srgbClr val="101F37"/>
+                          </a:solidFill>
+                          <a:latin typeface="Arial"/>
+                          <a:ea typeface="Microsoft YaHei"/>
+                        </a:rPr>
+                        <a:t>0.834</a:t>
+                      </a:r>
+                    </a:p>
+                  </a:txBody>
+                  <a:tcPr anchor="ctr" marL="45720" marR="45720" marT="18288" marB="18288">
+                    <a:solidFill>
+                      <a:srgbClr val="EEF5FB"/>
+                    </a:solidFill>
+                  </a:tcPr>
+                </a:tc>
+                <a:tc>
+                  <a:txBody>
+                    <a:bodyPr/>
+                    <a:lstStyle/>
+                    <a:p>
+                      <a:pPr algn="ctr"/>
+                      <a:r>
+                        <a:rPr sz="1500" b="0">
+                          <a:solidFill>
+                            <a:srgbClr val="101F37"/>
+                          </a:solidFill>
+                          <a:latin typeface="Arial"/>
+                          <a:ea typeface="Microsoft YaHei"/>
+                        </a:rPr>
+                        <a:t>0.127</a:t>
+                      </a:r>
+                    </a:p>
+                  </a:txBody>
+                  <a:tcPr anchor="ctr" marL="45720" marR="45720" marT="18288" marB="18288">
+                    <a:solidFill>
+                      <a:srgbClr val="EEF5FB"/>
+                    </a:solidFill>
+                  </a:tcPr>
+                </a:tc>
+                <a:tc>
+                  <a:txBody>
+                    <a:bodyPr/>
+                    <a:lstStyle/>
+                    <a:p>
+                      <a:pPr algn="ctr"/>
+                      <a:r>
+                        <a:rPr sz="1500" b="0">
+                          <a:solidFill>
+                            <a:srgbClr val="101F37"/>
+                          </a:solidFill>
+                          <a:latin typeface="Arial"/>
+                          <a:ea typeface="Microsoft YaHei"/>
+                        </a:rPr>
+                        <a:t>65.678</a:t>
+                      </a:r>
+                    </a:p>
+                  </a:txBody>
+                  <a:tcPr anchor="ctr" marL="45720" marR="45720" marT="18288" marB="18288">
+                    <a:solidFill>
+                      <a:srgbClr val="EEF5FB"/>
+                    </a:solidFill>
+                  </a:tcPr>
+                </a:tc>
+                <a:tc>
+                  <a:txBody>
+                    <a:bodyPr/>
+                    <a:lstStyle/>
+                    <a:p>
+                      <a:pPr algn="ctr"/>
+                      <a:r>
+                        <a:rPr sz="1500" b="0">
+                          <a:solidFill>
+                            <a:srgbClr val="101F37"/>
+                          </a:solidFill>
+                          <a:latin typeface="Arial"/>
+                          <a:ea typeface="Microsoft YaHei"/>
+                        </a:rPr>
+                        <a:t>0.660</a:t>
+                      </a:r>
+                    </a:p>
+                  </a:txBody>
+                  <a:tcPr anchor="ctr" marL="45720" marR="45720" marT="18288" marB="18288">
+                    <a:solidFill>
+                      <a:srgbClr val="EEF5FB"/>
+                    </a:solidFill>
+                  </a:tcPr>
+                </a:tc>
+                <a:tc>
+                  <a:txBody>
+                    <a:bodyPr/>
+                    <a:lstStyle/>
+                    <a:p>
+                      <a:pPr algn="ctr"/>
+                      <a:r>
+                        <a:rPr sz="1500" b="0">
+                          <a:solidFill>
+                            <a:srgbClr val="101F37"/>
+                          </a:solidFill>
+                          <a:latin typeface="Arial"/>
+                          <a:ea typeface="Microsoft YaHei"/>
+                        </a:rPr>
+                        <a:t>0.021</a:t>
+                      </a:r>
+                    </a:p>
+                  </a:txBody>
+                  <a:tcPr anchor="ctr" marL="45720" marR="45720" marT="18288" marB="18288">
+                    <a:solidFill>
+                      <a:srgbClr val="EEF5FB"/>
+                    </a:solidFill>
+                  </a:tcPr>
+                </a:tc>
+              </a:tr>
+              <a:tr h="310896">
+                <a:tc>
+                  <a:txBody>
+                    <a:bodyPr/>
+                    <a:lstStyle/>
+                    <a:p>
+                      <a:pPr algn="ctr"/>
+                      <a:r>
+                        <a:rPr sz="1500" b="1">
+                          <a:solidFill>
+                            <a:srgbClr val="101F37"/>
+                          </a:solidFill>
+                          <a:latin typeface="Arial"/>
+                          <a:ea typeface="Microsoft YaHei"/>
+                        </a:rPr>
+                        <a:t>Any-to-Bokeh</a:t>
+                      </a:r>
+                    </a:p>
+                  </a:txBody>
+                  <a:tcPr anchor="ctr" marL="45720" marR="45720" marT="18288" marB="18288">
+                    <a:solidFill>
+                      <a:srgbClr val="FFFFFF"/>
+                    </a:solidFill>
+                  </a:tcPr>
+                </a:tc>
+                <a:tc>
+                  <a:txBody>
+                    <a:bodyPr/>
+                    <a:lstStyle/>
+                    <a:p>
+                      <a:pPr algn="ctr"/>
+                      <a:r>
+                        <a:rPr sz="1500" b="1">
+                          <a:solidFill>
+                            <a:srgbClr val="101F37"/>
+                          </a:solidFill>
+                          <a:latin typeface="Arial"/>
+                          <a:ea typeface="Microsoft YaHei"/>
+                        </a:rPr>
+                        <a:t>38.899</a:t>
+                      </a:r>
+                    </a:p>
+                  </a:txBody>
+                  <a:tcPr anchor="ctr" marL="45720" marR="45720" marT="18288" marB="18288">
+                    <a:solidFill>
+                      <a:srgbClr val="FFFFFF"/>
+                    </a:solidFill>
+                  </a:tcPr>
+                </a:tc>
+                <a:tc>
+                  <a:txBody>
+                    <a:bodyPr/>
+                    <a:lstStyle/>
+                    <a:p>
+                      <a:pPr algn="ctr"/>
+                      <a:r>
+                        <a:rPr sz="1500" b="1">
+                          <a:solidFill>
+                            <a:srgbClr val="101F37"/>
+                          </a:solidFill>
+                          <a:latin typeface="Arial"/>
+                          <a:ea typeface="Microsoft YaHei"/>
+                        </a:rPr>
                         <a:t>0.974</a:t>
                       </a:r>
                     </a:p>
-                    <a:p>
-                      <a:pPr algn="ctr"/>
-                      <a:r>
-                        <a:rPr sz="1100" b="0">
-                          <a:solidFill>
-                            <a:srgbClr val="6B7A90"/>
-                          </a:solidFill>
-                          <a:latin typeface="Arial"/>
-                          <a:ea typeface="Microsoft YaHei"/>
-                        </a:rPr>
-                        <a:t>0.950</a:t>
-                      </a:r>
-                    </a:p>
                   </a:txBody>
                   <a:tcPr anchor="ctr" marL="45720" marR="45720" marT="18288" marB="18288">
                     <a:solidFill>
@@ -8737,27 +10410,14 @@
                     <a:p>
                       <a:pPr algn="ctr"/>
                       <a:r>
-                        <a:rPr sz="1500" b="0">
-                          <a:solidFill>
-                            <a:srgbClr val="101F37"/>
-                          </a:solidFill>
-                          <a:latin typeface="Arial"/>
-                          <a:ea typeface="Microsoft YaHei"/>
-                        </a:rPr>
-                        <a:t>0.028</a:t>
-                      </a:r>
-                    </a:p>
-                    <a:p>
-                      <a:pPr algn="ctr"/>
-                      <a:r>
-                        <a:rPr sz="1100" b="0">
-                          <a:solidFill>
-                            <a:srgbClr val="6B7A90"/>
-                          </a:solidFill>
-                          <a:latin typeface="Arial"/>
-                          <a:ea typeface="Microsoft YaHei"/>
-                        </a:rPr>
-                        <a:t>0.040</a:t>
+                        <a:rPr sz="1500" b="1">
+                          <a:solidFill>
+                            <a:srgbClr val="101F37"/>
+                          </a:solidFill>
+                          <a:latin typeface="Arial"/>
+                          <a:ea typeface="Microsoft YaHei"/>
+                        </a:rPr>
+                        <a:t>0.019</a:t>
                       </a:r>
                     </a:p>
                   </a:txBody>
@@ -8767,8 +10427,6 @@
                     </a:solidFill>
                   </a:tcPr>
                 </a:tc>
-              </a:tr>
-              <a:tr h="548640">
                 <a:tc>
                   <a:txBody>
                     <a:bodyPr/>
@@ -8783,129 +10441,16 @@
                           <a:latin typeface="Arial"/>
                           <a:ea typeface="Microsoft YaHei"/>
                         </a:rPr>
-                        <a:t>BokehDiff</a:t>
-                      </a:r>
-                    </a:p>
-                  </a:txBody>
-                  <a:tcPr anchor="ctr" marL="45720" marR="45720" marT="18288" marB="18288">
-                    <a:solidFill>
-                      <a:srgbClr val="EEF5FB"/>
-                    </a:solidFill>
-                  </a:tcPr>
-                </a:tc>
-                <a:tc>
-                  <a:txBody>
-                    <a:bodyPr/>
-                    <a:lstStyle/>
-                    <a:p>
-                      <a:pPr algn="ctr"/>
-                      <a:r>
-                        <a:rPr sz="1500" b="0">
-                          <a:solidFill>
-                            <a:srgbClr val="101F37"/>
-                          </a:solidFill>
-                          <a:latin typeface="Arial"/>
-                          <a:ea typeface="Microsoft YaHei"/>
-                        </a:rPr>
-                        <a:t>27.06</a:t>
-                      </a:r>
-                    </a:p>
-                    <a:p>
-                      <a:pPr algn="ctr"/>
-                      <a:r>
-                        <a:rPr sz="1100" b="0">
-                          <a:solidFill>
-                            <a:srgbClr val="6B7A90"/>
-                          </a:solidFill>
-                          <a:latin typeface="Arial"/>
-                          <a:ea typeface="Microsoft YaHei"/>
-                        </a:rPr>
-                        <a:t>27.525</a:t>
-                      </a:r>
-                    </a:p>
-                  </a:txBody>
-                  <a:tcPr anchor="ctr" marL="45720" marR="45720" marT="18288" marB="18288">
-                    <a:solidFill>
-                      <a:srgbClr val="EEF5FB"/>
-                    </a:solidFill>
-                  </a:tcPr>
-                </a:tc>
-                <a:tc>
-                  <a:txBody>
-                    <a:bodyPr/>
-                    <a:lstStyle/>
-                    <a:p>
-                      <a:pPr algn="ctr"/>
-                      <a:r>
-                        <a:rPr sz="1500" b="0">
-                          <a:solidFill>
-                            <a:srgbClr val="101F37"/>
-                          </a:solidFill>
-                          <a:latin typeface="Arial"/>
-                          <a:ea typeface="Microsoft YaHei"/>
-                        </a:rPr>
-                        <a:t>0.844</a:t>
-                      </a:r>
-                    </a:p>
-                    <a:p>
-                      <a:pPr algn="ctr"/>
-                      <a:r>
-                        <a:rPr sz="1100" b="0">
-                          <a:solidFill>
-                            <a:srgbClr val="6B7A90"/>
-                          </a:solidFill>
-                          <a:latin typeface="Arial"/>
-                          <a:ea typeface="Microsoft YaHei"/>
-                        </a:rPr>
-                        <a:t>0.834</a:t>
-                      </a:r>
-                    </a:p>
-                  </a:txBody>
-                  <a:tcPr anchor="ctr" marL="45720" marR="45720" marT="18288" marB="18288">
-                    <a:solidFill>
-                      <a:srgbClr val="EEF5FB"/>
-                    </a:solidFill>
-                  </a:tcPr>
-                </a:tc>
-                <a:tc>
-                  <a:txBody>
-                    <a:bodyPr/>
-                    <a:lstStyle/>
-                    <a:p>
-                      <a:pPr algn="ctr"/>
-                      <a:r>
-                        <a:rPr sz="1500" b="0">
-                          <a:solidFill>
-                            <a:srgbClr val="101F37"/>
-                          </a:solidFill>
-                          <a:latin typeface="Arial"/>
-                          <a:ea typeface="Microsoft YaHei"/>
-                        </a:rPr>
-                        <a:t>0.132</a:t>
-                      </a:r>
-                    </a:p>
-                    <a:p>
-                      <a:pPr algn="ctr"/>
-                      <a:r>
-                        <a:rPr sz="1100" b="0">
-                          <a:solidFill>
-                            <a:srgbClr val="6B7A90"/>
-                          </a:solidFill>
-                          <a:latin typeface="Arial"/>
-                          <a:ea typeface="Microsoft YaHei"/>
-                        </a:rPr>
-                        <a:t>0.127</a:t>
-                      </a:r>
-                    </a:p>
-                  </a:txBody>
-                  <a:tcPr anchor="ctr" marL="45720" marR="45720" marT="18288" marB="18288">
-                    <a:solidFill>
-                      <a:srgbClr val="EEF5FB"/>
-                    </a:solidFill>
-                  </a:tcPr>
-                </a:tc>
-              </a:tr>
-              <a:tr h="548640">
+                        <a:t>9.005</a:t>
+                      </a:r>
+                    </a:p>
+                  </a:txBody>
+                  <a:tcPr anchor="ctr" marL="45720" marR="45720" marT="18288" marB="18288">
+                    <a:solidFill>
+                      <a:srgbClr val="FFFFFF"/>
+                    </a:solidFill>
+                  </a:tcPr>
+                </a:tc>
                 <a:tc>
                   <a:txBody>
                     <a:bodyPr/>
@@ -8920,7 +10465,7 @@
                           <a:latin typeface="Arial"/>
                           <a:ea typeface="Microsoft YaHei"/>
                         </a:rPr>
-                        <a:t>Any-to-Bokeh</a:t>
+                        <a:t>0.431</a:t>
                       </a:r>
                     </a:p>
                   </a:txBody>
@@ -8940,1077 +10485,6 @@
                         <a:rPr sz="1500" b="1">
                           <a:solidFill>
                             <a:srgbClr val="101F37"/>
-                          </a:solidFill>
-                          <a:latin typeface="Arial"/>
-                          <a:ea typeface="Microsoft YaHei"/>
-                        </a:rPr>
-                        <a:t>39.71</a:t>
-                      </a:r>
-                    </a:p>
-                    <a:p>
-                      <a:pPr algn="ctr"/>
-                      <a:r>
-                        <a:rPr sz="1100" b="0">
-                          <a:solidFill>
-                            <a:srgbClr val="6B7A90"/>
-                          </a:solidFill>
-                          <a:latin typeface="Arial"/>
-                          <a:ea typeface="Microsoft YaHei"/>
-                        </a:rPr>
-                        <a:t>38.899</a:t>
-                      </a:r>
-                    </a:p>
-                  </a:txBody>
-                  <a:tcPr anchor="ctr" marL="45720" marR="45720" marT="18288" marB="18288">
-                    <a:solidFill>
-                      <a:srgbClr val="FFFFFF"/>
-                    </a:solidFill>
-                  </a:tcPr>
-                </a:tc>
-                <a:tc>
-                  <a:txBody>
-                    <a:bodyPr/>
-                    <a:lstStyle/>
-                    <a:p>
-                      <a:pPr algn="ctr"/>
-                      <a:r>
-                        <a:rPr sz="1500" b="1">
-                          <a:solidFill>
-                            <a:srgbClr val="101F37"/>
-                          </a:solidFill>
-                          <a:latin typeface="Arial"/>
-                          <a:ea typeface="Microsoft YaHei"/>
-                        </a:rPr>
-                        <a:t>0.986</a:t>
-                      </a:r>
-                    </a:p>
-                    <a:p>
-                      <a:pPr algn="ctr"/>
-                      <a:r>
-                        <a:rPr sz="1100" b="0">
-                          <a:solidFill>
-                            <a:srgbClr val="6B7A90"/>
-                          </a:solidFill>
-                          <a:latin typeface="Arial"/>
-                          <a:ea typeface="Microsoft YaHei"/>
-                        </a:rPr>
-                        <a:t>0.974</a:t>
-                      </a:r>
-                    </a:p>
-                  </a:txBody>
-                  <a:tcPr anchor="ctr" marL="45720" marR="45720" marT="18288" marB="18288">
-                    <a:solidFill>
-                      <a:srgbClr val="FFFFFF"/>
-                    </a:solidFill>
-                  </a:tcPr>
-                </a:tc>
-                <a:tc>
-                  <a:txBody>
-                    <a:bodyPr/>
-                    <a:lstStyle/>
-                    <a:p>
-                      <a:pPr algn="ctr"/>
-                      <a:r>
-                        <a:rPr sz="1500" b="1">
-                          <a:solidFill>
-                            <a:srgbClr val="101F37"/>
-                          </a:solidFill>
-                          <a:latin typeface="Arial"/>
-                          <a:ea typeface="Microsoft YaHei"/>
-                        </a:rPr>
-                        <a:t>0.015</a:t>
-                      </a:r>
-                    </a:p>
-                    <a:p>
-                      <a:pPr algn="ctr"/>
-                      <a:r>
-                        <a:rPr sz="1100" b="0">
-                          <a:solidFill>
-                            <a:srgbClr val="6B7A90"/>
-                          </a:solidFill>
-                          <a:latin typeface="Arial"/>
-                          <a:ea typeface="Microsoft YaHei"/>
-                        </a:rPr>
-                        <a:t>0.019</a:t>
-                      </a:r>
-                    </a:p>
-                  </a:txBody>
-                  <a:tcPr anchor="ctr" marL="45720" marR="45720" marT="18288" marB="18288">
-                    <a:solidFill>
-                      <a:srgbClr val="FFFFFF"/>
-                    </a:solidFill>
-                  </a:tcPr>
-                </a:tc>
-              </a:tr>
-            </a:tbl>
-          </a:graphicData>
-        </a:graphic>
-      </p:graphicFrame>
-      <p:sp>
-        <p:nvSpPr>
-          <p:cNvPr id="26" name="TextBox 25"/>
-          <p:cNvSpPr txBox="1"/>
-          <p:nvPr/>
-        </p:nvSpPr>
-        <p:spPr>
-          <a:xfrm>
-            <a:off x="6172200" y="1481328"/>
-            <a:ext cx="5166359" cy="365760"/>
-          </a:xfrm>
-          <a:prstGeom prst="rect">
-            <a:avLst/>
-          </a:prstGeom>
-          <a:noFill/>
-        </p:spPr>
-        <p:txBody>
-          <a:bodyPr wrap="square" anchor="ctr">
-            <a:spAutoFit/>
-          </a:bodyPr>
-          <a:lstStyle/>
-          <a:p>
-            <a:pPr algn="ctr"/>
-            <a:r>
-              <a:rPr sz="1700" b="1">
-                <a:solidFill>
-                  <a:srgbClr val="0D569A"/>
-                </a:solidFill>
-                <a:latin typeface="Arial"/>
-                <a:ea typeface="Microsoft YaHei"/>
-              </a:rPr>
-              <a:t>视频质量与时序稳定</a:t>
-            </a:r>
-          </a:p>
-        </p:txBody>
-      </p:sp>
-      <p:graphicFrame>
-        <p:nvGraphicFramePr>
-          <p:cNvPr id="27" name="Table 26"/>
-          <p:cNvGraphicFramePr>
-            <a:graphicFrameLocks noGrp="1"/>
-          </p:cNvGraphicFramePr>
-          <p:nvPr/>
-        </p:nvGraphicFramePr>
-        <p:xfrm>
-          <a:off x="6172200" y="1874519"/>
-          <a:ext cx="5166359" cy="3840480"/>
-        </p:xfrm>
-        <a:graphic>
-          <a:graphicData uri="http://schemas.openxmlformats.org/drawingml/2006/table">
-            <a:tbl>
-              <a:tblPr firstRow="1">
-                <a:tableStyleId>{5C22544A-7EE6-4342-B048-85BDC9FD1C3A}</a:tableStyleId>
-              </a:tblPr>
-              <a:tblGrid>
-                <a:gridCol w="1874519"/>
-                <a:gridCol w="1097280"/>
-                <a:gridCol w="1097280"/>
-                <a:gridCol w="1097280"/>
-              </a:tblGrid>
-              <a:tr h="548640">
-                <a:tc>
-                  <a:txBody>
-                    <a:bodyPr/>
-                    <a:lstStyle/>
-                    <a:p>
-                      <a:pPr algn="ctr"/>
-                      <a:r>
-                        <a:rPr sz="1500" b="1">
-                          <a:solidFill>
-                            <a:srgbClr val="FFFFFF"/>
-                          </a:solidFill>
-                          <a:latin typeface="Arial"/>
-                          <a:ea typeface="Microsoft YaHei"/>
-                        </a:rPr>
-                        <a:t>方法</a:t>
-                      </a:r>
-                    </a:p>
-                  </a:txBody>
-                  <a:tcPr anchor="ctr" marL="45720" marR="45720" marT="18288" marB="18288">
-                    <a:solidFill>
-                      <a:srgbClr val="0D569A"/>
-                    </a:solidFill>
-                  </a:tcPr>
-                </a:tc>
-                <a:tc>
-                  <a:txBody>
-                    <a:bodyPr/>
-                    <a:lstStyle/>
-                    <a:p>
-                      <a:pPr algn="ctr"/>
-                      <a:r>
-                        <a:rPr sz="1500" b="1">
-                          <a:solidFill>
-                            <a:srgbClr val="FFFFFF"/>
-                          </a:solidFill>
-                          <a:latin typeface="Arial"/>
-                          <a:ea typeface="Microsoft YaHei"/>
-                        </a:rPr>
-                        <a:t>FVD ↓</a:t>
-                      </a:r>
-                    </a:p>
-                  </a:txBody>
-                  <a:tcPr anchor="ctr" marL="45720" marR="45720" marT="18288" marB="18288">
-                    <a:solidFill>
-                      <a:srgbClr val="0D569A"/>
-                    </a:solidFill>
-                  </a:tcPr>
-                </a:tc>
-                <a:tc>
-                  <a:txBody>
-                    <a:bodyPr/>
-                    <a:lstStyle/>
-                    <a:p>
-                      <a:pPr algn="ctr"/>
-                      <a:r>
-                        <a:rPr sz="1500" b="1">
-                          <a:solidFill>
-                            <a:srgbClr val="FFFFFF"/>
-                          </a:solidFill>
-                          <a:latin typeface="Arial"/>
-                          <a:ea typeface="Microsoft YaHei"/>
-                        </a:rPr>
-                        <a:t>FD ↓</a:t>
-                      </a:r>
-                    </a:p>
-                  </a:txBody>
-                  <a:tcPr anchor="ctr" marL="45720" marR="45720" marT="18288" marB="18288">
-                    <a:solidFill>
-                      <a:srgbClr val="0D569A"/>
-                    </a:solidFill>
-                  </a:tcPr>
-                </a:tc>
-                <a:tc>
-                  <a:txBody>
-                    <a:bodyPr/>
-                    <a:lstStyle/>
-                    <a:p>
-                      <a:pPr algn="ctr"/>
-                      <a:r>
-                        <a:rPr sz="1500" b="1">
-                          <a:solidFill>
-                            <a:srgbClr val="FFFFFF"/>
-                          </a:solidFill>
-                          <a:latin typeface="Arial"/>
-                          <a:ea typeface="Microsoft YaHei"/>
-                        </a:rPr>
-                        <a:t>RM ↓</a:t>
-                      </a:r>
-                    </a:p>
-                  </a:txBody>
-                  <a:tcPr anchor="ctr" marL="45720" marR="45720" marT="18288" marB="18288">
-                    <a:solidFill>
-                      <a:srgbClr val="0D569A"/>
-                    </a:solidFill>
-                  </a:tcPr>
-                </a:tc>
-              </a:tr>
-              <a:tr h="548640">
-                <a:tc>
-                  <a:txBody>
-                    <a:bodyPr/>
-                    <a:lstStyle/>
-                    <a:p>
-                      <a:pPr algn="ctr"/>
-                      <a:r>
-                        <a:rPr sz="1500" b="1">
-                          <a:solidFill>
-                            <a:srgbClr val="101F37"/>
-                          </a:solidFill>
-                          <a:latin typeface="Arial"/>
-                          <a:ea typeface="Microsoft YaHei"/>
-                        </a:rPr>
-                        <a:t>DeepLens</a:t>
-                      </a:r>
-                    </a:p>
-                  </a:txBody>
-                  <a:tcPr anchor="ctr" marL="45720" marR="45720" marT="18288" marB="18288">
-                    <a:solidFill>
-                      <a:srgbClr val="EEF5FB"/>
-                    </a:solidFill>
-                  </a:tcPr>
-                </a:tc>
-                <a:tc>
-                  <a:txBody>
-                    <a:bodyPr/>
-                    <a:lstStyle/>
-                    <a:p>
-                      <a:pPr algn="ctr"/>
-                      <a:r>
-                        <a:rPr sz="1500" b="0">
-                          <a:solidFill>
-                            <a:srgbClr val="101F37"/>
-                          </a:solidFill>
-                          <a:latin typeface="Arial"/>
-                          <a:ea typeface="Microsoft YaHei"/>
-                        </a:rPr>
-                        <a:t>40.12</a:t>
-                      </a:r>
-                    </a:p>
-                    <a:p>
-                      <a:pPr algn="ctr"/>
-                      <a:r>
-                        <a:rPr sz="1100" b="0">
-                          <a:solidFill>
-                            <a:srgbClr val="6B7A90"/>
-                          </a:solidFill>
-                          <a:latin typeface="Arial"/>
-                          <a:ea typeface="Microsoft YaHei"/>
-                        </a:rPr>
-                        <a:t>125.338</a:t>
-                      </a:r>
-                    </a:p>
-                  </a:txBody>
-                  <a:tcPr anchor="ctr" marL="45720" marR="45720" marT="18288" marB="18288">
-                    <a:solidFill>
-                      <a:srgbClr val="EEF5FB"/>
-                    </a:solidFill>
-                  </a:tcPr>
-                </a:tc>
-                <a:tc>
-                  <a:txBody>
-                    <a:bodyPr/>
-                    <a:lstStyle/>
-                    <a:p>
-                      <a:pPr algn="ctr"/>
-                      <a:r>
-                        <a:rPr sz="1500" b="0">
-                          <a:solidFill>
-                            <a:srgbClr val="101F37"/>
-                          </a:solidFill>
-                          <a:latin typeface="Arial"/>
-                          <a:ea typeface="Microsoft YaHei"/>
-                        </a:rPr>
-                        <a:t>0.583</a:t>
-                      </a:r>
-                    </a:p>
-                    <a:p>
-                      <a:pPr algn="ctr"/>
-                      <a:r>
-                        <a:rPr sz="1100" b="0">
-                          <a:solidFill>
-                            <a:srgbClr val="6B7A90"/>
-                          </a:solidFill>
-                          <a:latin typeface="Arial"/>
-                          <a:ea typeface="Microsoft YaHei"/>
-                        </a:rPr>
-                        <a:t>1.162</a:t>
-                      </a:r>
-                    </a:p>
-                  </a:txBody>
-                  <a:tcPr anchor="ctr" marL="45720" marR="45720" marT="18288" marB="18288">
-                    <a:solidFill>
-                      <a:srgbClr val="EEF5FB"/>
-                    </a:solidFill>
-                  </a:tcPr>
-                </a:tc>
-                <a:tc>
-                  <a:txBody>
-                    <a:bodyPr/>
-                    <a:lstStyle/>
-                    <a:p>
-                      <a:pPr algn="ctr"/>
-                      <a:r>
-                        <a:rPr sz="1500" b="0">
-                          <a:solidFill>
-                            <a:srgbClr val="101F37"/>
-                          </a:solidFill>
-                          <a:latin typeface="Arial"/>
-                          <a:ea typeface="Microsoft YaHei"/>
-                        </a:rPr>
-                        <a:t>0.0124</a:t>
-                      </a:r>
-                    </a:p>
-                    <a:p>
-                      <a:pPr algn="ctr"/>
-                      <a:r>
-                        <a:rPr sz="1100" b="0">
-                          <a:solidFill>
-                            <a:srgbClr val="6B7A90"/>
-                          </a:solidFill>
-                          <a:latin typeface="Arial"/>
-                          <a:ea typeface="Microsoft YaHei"/>
-                        </a:rPr>
-                        <a:t>0.030</a:t>
-                      </a:r>
-                    </a:p>
-                  </a:txBody>
-                  <a:tcPr anchor="ctr" marL="45720" marR="45720" marT="18288" marB="18288">
-                    <a:solidFill>
-                      <a:srgbClr val="EEF5FB"/>
-                    </a:solidFill>
-                  </a:tcPr>
-                </a:tc>
-              </a:tr>
-              <a:tr h="548640">
-                <a:tc>
-                  <a:txBody>
-                    <a:bodyPr/>
-                    <a:lstStyle/>
-                    <a:p>
-                      <a:pPr algn="ctr"/>
-                      <a:r>
-                        <a:rPr sz="1500" b="1">
-                          <a:solidFill>
-                            <a:srgbClr val="101F37"/>
-                          </a:solidFill>
-                          <a:latin typeface="Arial"/>
-                          <a:ea typeface="Microsoft YaHei"/>
-                        </a:rPr>
-                        <a:t>Dr.Bokeh</a:t>
-                      </a:r>
-                    </a:p>
-                  </a:txBody>
-                  <a:tcPr anchor="ctr" marL="45720" marR="45720" marT="18288" marB="18288">
-                    <a:solidFill>
-                      <a:srgbClr val="FFFFFF"/>
-                    </a:solidFill>
-                  </a:tcPr>
-                </a:tc>
-                <a:tc>
-                  <a:txBody>
-                    <a:bodyPr/>
-                    <a:lstStyle/>
-                    <a:p>
-                      <a:pPr algn="ctr"/>
-                      <a:r>
-                        <a:rPr sz="1500" b="0">
-                          <a:solidFill>
-                            <a:srgbClr val="101F37"/>
-                          </a:solidFill>
-                          <a:latin typeface="Arial"/>
-                          <a:ea typeface="Microsoft YaHei"/>
-                        </a:rPr>
-                        <a:t>25.86</a:t>
-                      </a:r>
-                    </a:p>
-                    <a:p>
-                      <a:pPr algn="ctr"/>
-                      <a:r>
-                        <a:rPr sz="1100" b="0">
-                          <a:solidFill>
-                            <a:srgbClr val="6B7A90"/>
-                          </a:solidFill>
-                          <a:latin typeface="Arial"/>
-                          <a:ea typeface="Microsoft YaHei"/>
-                        </a:rPr>
-                        <a:t>32.710</a:t>
-                      </a:r>
-                    </a:p>
-                  </a:txBody>
-                  <a:tcPr anchor="ctr" marL="45720" marR="45720" marT="18288" marB="18288">
-                    <a:solidFill>
-                      <a:srgbClr val="FFFFFF"/>
-                    </a:solidFill>
-                  </a:tcPr>
-                </a:tc>
-                <a:tc>
-                  <a:txBody>
-                    <a:bodyPr/>
-                    <a:lstStyle/>
-                    <a:p>
-                      <a:pPr algn="ctr"/>
-                      <a:r>
-                        <a:rPr sz="1500" b="0">
-                          <a:solidFill>
-                            <a:srgbClr val="101F37"/>
-                          </a:solidFill>
-                          <a:latin typeface="Arial"/>
-                          <a:ea typeface="Microsoft YaHei"/>
-                        </a:rPr>
-                        <a:t>0.479</a:t>
-                      </a:r>
-                    </a:p>
-                    <a:p>
-                      <a:pPr algn="ctr"/>
-                      <a:r>
-                        <a:rPr sz="1100" b="0">
-                          <a:solidFill>
-                            <a:srgbClr val="6B7A90"/>
-                          </a:solidFill>
-                          <a:latin typeface="Arial"/>
-                          <a:ea typeface="Microsoft YaHei"/>
-                        </a:rPr>
-                        <a:t>0.522</a:t>
-                      </a:r>
-                    </a:p>
-                  </a:txBody>
-                  <a:tcPr anchor="ctr" marL="45720" marR="45720" marT="18288" marB="18288">
-                    <a:solidFill>
-                      <a:srgbClr val="FFFFFF"/>
-                    </a:solidFill>
-                  </a:tcPr>
-                </a:tc>
-                <a:tc>
-                  <a:txBody>
-                    <a:bodyPr/>
-                    <a:lstStyle/>
-                    <a:p>
-                      <a:pPr algn="ctr"/>
-                      <a:r>
-                        <a:rPr sz="1500" b="0">
-                          <a:solidFill>
-                            <a:srgbClr val="101F37"/>
-                          </a:solidFill>
-                          <a:latin typeface="Arial"/>
-                          <a:ea typeface="Microsoft YaHei"/>
-                        </a:rPr>
-                        <a:t>0.0084</a:t>
-                      </a:r>
-                    </a:p>
-                    <a:p>
-                      <a:pPr algn="ctr"/>
-                      <a:r>
-                        <a:rPr sz="1100" b="0">
-                          <a:solidFill>
-                            <a:srgbClr val="6B7A90"/>
-                          </a:solidFill>
-                          <a:latin typeface="Arial"/>
-                          <a:ea typeface="Microsoft YaHei"/>
-                        </a:rPr>
-                        <a:t>0.011</a:t>
-                      </a:r>
-                    </a:p>
-                  </a:txBody>
-                  <a:tcPr anchor="ctr" marL="45720" marR="45720" marT="18288" marB="18288">
-                    <a:solidFill>
-                      <a:srgbClr val="FFFFFF"/>
-                    </a:solidFill>
-                  </a:tcPr>
-                </a:tc>
-              </a:tr>
-              <a:tr h="548640">
-                <a:tc>
-                  <a:txBody>
-                    <a:bodyPr/>
-                    <a:lstStyle/>
-                    <a:p>
-                      <a:pPr algn="ctr"/>
-                      <a:r>
-                        <a:rPr sz="1500" b="1">
-                          <a:solidFill>
-                            <a:srgbClr val="101F37"/>
-                          </a:solidFill>
-                          <a:latin typeface="Arial"/>
-                          <a:ea typeface="Microsoft YaHei"/>
-                        </a:rPr>
-                        <a:t>BokehMe</a:t>
-                      </a:r>
-                    </a:p>
-                  </a:txBody>
-                  <a:tcPr anchor="ctr" marL="45720" marR="45720" marT="18288" marB="18288">
-                    <a:solidFill>
-                      <a:srgbClr val="EEF5FB"/>
-                    </a:solidFill>
-                  </a:tcPr>
-                </a:tc>
-                <a:tc>
-                  <a:txBody>
-                    <a:bodyPr/>
-                    <a:lstStyle/>
-                    <a:p>
-                      <a:pPr algn="ctr"/>
-                      <a:r>
-                        <a:rPr sz="1500" b="0">
-                          <a:solidFill>
-                            <a:srgbClr val="101F37"/>
-                          </a:solidFill>
-                          <a:latin typeface="Arial"/>
-                          <a:ea typeface="Microsoft YaHei"/>
-                        </a:rPr>
-                        <a:t>18.55</a:t>
-                      </a:r>
-                    </a:p>
-                    <a:p>
-                      <a:pPr algn="ctr"/>
-                      <a:r>
-                        <a:rPr sz="1100" b="0">
-                          <a:solidFill>
-                            <a:srgbClr val="6B7A90"/>
-                          </a:solidFill>
-                          <a:latin typeface="Arial"/>
-                          <a:ea typeface="Microsoft YaHei"/>
-                        </a:rPr>
-                        <a:t>39.102</a:t>
-                      </a:r>
-                    </a:p>
-                  </a:txBody>
-                  <a:tcPr anchor="ctr" marL="45720" marR="45720" marT="18288" marB="18288">
-                    <a:solidFill>
-                      <a:srgbClr val="EEF5FB"/>
-                    </a:solidFill>
-                  </a:tcPr>
-                </a:tc>
-                <a:tc>
-                  <a:txBody>
-                    <a:bodyPr/>
-                    <a:lstStyle/>
-                    <a:p>
-                      <a:pPr algn="ctr"/>
-                      <a:r>
-                        <a:rPr sz="1500" b="0">
-                          <a:solidFill>
-                            <a:srgbClr val="101F37"/>
-                          </a:solidFill>
-                          <a:latin typeface="Arial"/>
-                          <a:ea typeface="Microsoft YaHei"/>
-                        </a:rPr>
-                        <a:t>0.540</a:t>
-                      </a:r>
-                    </a:p>
-                    <a:p>
-                      <a:pPr algn="ctr"/>
-                      <a:r>
-                        <a:rPr sz="1100" b="0">
-                          <a:solidFill>
-                            <a:srgbClr val="6B7A90"/>
-                          </a:solidFill>
-                          <a:latin typeface="Arial"/>
-                          <a:ea typeface="Microsoft YaHei"/>
-                        </a:rPr>
-                        <a:t>0.536</a:t>
-                      </a:r>
-                    </a:p>
-                  </a:txBody>
-                  <a:tcPr anchor="ctr" marL="45720" marR="45720" marT="18288" marB="18288">
-                    <a:solidFill>
-                      <a:srgbClr val="EEF5FB"/>
-                    </a:solidFill>
-                  </a:tcPr>
-                </a:tc>
-                <a:tc>
-                  <a:txBody>
-                    <a:bodyPr/>
-                    <a:lstStyle/>
-                    <a:p>
-                      <a:pPr algn="ctr"/>
-                      <a:r>
-                        <a:rPr sz="1500" b="0">
-                          <a:solidFill>
-                            <a:srgbClr val="101F37"/>
-                          </a:solidFill>
-                          <a:latin typeface="Arial"/>
-                          <a:ea typeface="Microsoft YaHei"/>
-                        </a:rPr>
-                        <a:t>0.0074</a:t>
-                      </a:r>
-                    </a:p>
-                    <a:p>
-                      <a:pPr algn="ctr"/>
-                      <a:r>
-                        <a:rPr sz="1100" b="0">
-                          <a:solidFill>
-                            <a:srgbClr val="6B7A90"/>
-                          </a:solidFill>
-                          <a:latin typeface="Arial"/>
-                          <a:ea typeface="Microsoft YaHei"/>
-                        </a:rPr>
-                        <a:t>0.013</a:t>
-                      </a:r>
-                    </a:p>
-                  </a:txBody>
-                  <a:tcPr anchor="ctr" marL="45720" marR="45720" marT="18288" marB="18288">
-                    <a:solidFill>
-                      <a:srgbClr val="EEF5FB"/>
-                    </a:solidFill>
-                  </a:tcPr>
-                </a:tc>
-              </a:tr>
-              <a:tr h="548640">
-                <a:tc>
-                  <a:txBody>
-                    <a:bodyPr/>
-                    <a:lstStyle/>
-                    <a:p>
-                      <a:pPr algn="ctr"/>
-                      <a:r>
-                        <a:rPr sz="1500" b="1">
-                          <a:solidFill>
-                            <a:srgbClr val="101F37"/>
-                          </a:solidFill>
-                          <a:latin typeface="Arial"/>
-                          <a:ea typeface="Microsoft YaHei"/>
-                        </a:rPr>
-                        <a:t>MPIB</a:t>
-                      </a:r>
-                    </a:p>
-                  </a:txBody>
-                  <a:tcPr anchor="ctr" marL="45720" marR="45720" marT="18288" marB="18288">
-                    <a:solidFill>
-                      <a:srgbClr val="FFFFFF"/>
-                    </a:solidFill>
-                  </a:tcPr>
-                </a:tc>
-                <a:tc>
-                  <a:txBody>
-                    <a:bodyPr/>
-                    <a:lstStyle/>
-                    <a:p>
-                      <a:pPr algn="ctr"/>
-                      <a:r>
-                        <a:rPr sz="1500" b="0">
-                          <a:solidFill>
-                            <a:srgbClr val="101F37"/>
-                          </a:solidFill>
-                          <a:latin typeface="Arial"/>
-                          <a:ea typeface="Microsoft YaHei"/>
-                        </a:rPr>
-                        <a:t>24.96</a:t>
-                      </a:r>
-                    </a:p>
-                    <a:p>
-                      <a:pPr algn="ctr"/>
-                      <a:r>
-                        <a:rPr sz="1100" b="0">
-                          <a:solidFill>
-                            <a:srgbClr val="6B7A90"/>
-                          </a:solidFill>
-                          <a:latin typeface="Arial"/>
-                          <a:ea typeface="Microsoft YaHei"/>
-                        </a:rPr>
-                        <a:t>35.766</a:t>
-                      </a:r>
-                    </a:p>
-                  </a:txBody>
-                  <a:tcPr anchor="ctr" marL="45720" marR="45720" marT="18288" marB="18288">
-                    <a:solidFill>
-                      <a:srgbClr val="FFFFFF"/>
-                    </a:solidFill>
-                  </a:tcPr>
-                </a:tc>
-                <a:tc>
-                  <a:txBody>
-                    <a:bodyPr/>
-                    <a:lstStyle/>
-                    <a:p>
-                      <a:pPr algn="ctr"/>
-                      <a:r>
-                        <a:rPr sz="1500" b="0">
-                          <a:solidFill>
-                            <a:srgbClr val="101F37"/>
-                          </a:solidFill>
-                          <a:latin typeface="Arial"/>
-                          <a:ea typeface="Microsoft YaHei"/>
-                        </a:rPr>
-                        <a:t>0.450</a:t>
-                      </a:r>
-                    </a:p>
-                    <a:p>
-                      <a:pPr algn="ctr"/>
-                      <a:r>
-                        <a:rPr sz="1100" b="0">
-                          <a:solidFill>
-                            <a:srgbClr val="6B7A90"/>
-                          </a:solidFill>
-                          <a:latin typeface="Arial"/>
-                          <a:ea typeface="Microsoft YaHei"/>
-                        </a:rPr>
-                        <a:t>0.481</a:t>
-                      </a:r>
-                    </a:p>
-                  </a:txBody>
-                  <a:tcPr anchor="ctr" marL="45720" marR="45720" marT="18288" marB="18288">
-                    <a:solidFill>
-                      <a:srgbClr val="FFFFFF"/>
-                    </a:solidFill>
-                  </a:tcPr>
-                </a:tc>
-                <a:tc>
-                  <a:txBody>
-                    <a:bodyPr/>
-                    <a:lstStyle/>
-                    <a:p>
-                      <a:pPr algn="ctr"/>
-                      <a:r>
-                        <a:rPr sz="1500" b="0">
-                          <a:solidFill>
-                            <a:srgbClr val="101F37"/>
-                          </a:solidFill>
-                          <a:latin typeface="Arial"/>
-                          <a:ea typeface="Microsoft YaHei"/>
-                        </a:rPr>
-                        <a:t>0.0082</a:t>
-                      </a:r>
-                    </a:p>
-                    <a:p>
-                      <a:pPr algn="ctr"/>
-                      <a:r>
-                        <a:rPr sz="1100" b="0">
-                          <a:solidFill>
-                            <a:srgbClr val="6B7A90"/>
-                          </a:solidFill>
-                          <a:latin typeface="Arial"/>
-                          <a:ea typeface="Microsoft YaHei"/>
-                        </a:rPr>
-                        <a:t>0.011</a:t>
-                      </a:r>
-                    </a:p>
-                  </a:txBody>
-                  <a:tcPr anchor="ctr" marL="45720" marR="45720" marT="18288" marB="18288">
-                    <a:solidFill>
-                      <a:srgbClr val="FFFFFF"/>
-                    </a:solidFill>
-                  </a:tcPr>
-                </a:tc>
-              </a:tr>
-              <a:tr h="548640">
-                <a:tc>
-                  <a:txBody>
-                    <a:bodyPr/>
-                    <a:lstStyle/>
-                    <a:p>
-                      <a:pPr algn="ctr"/>
-                      <a:r>
-                        <a:rPr sz="1500" b="1">
-                          <a:solidFill>
-                            <a:srgbClr val="101F37"/>
-                          </a:solidFill>
-                          <a:latin typeface="Arial"/>
-                          <a:ea typeface="Microsoft YaHei"/>
-                        </a:rPr>
-                        <a:t>BokehDiff</a:t>
-                      </a:r>
-                    </a:p>
-                  </a:txBody>
-                  <a:tcPr anchor="ctr" marL="45720" marR="45720" marT="18288" marB="18288">
-                    <a:solidFill>
-                      <a:srgbClr val="EEF5FB"/>
-                    </a:solidFill>
-                  </a:tcPr>
-                </a:tc>
-                <a:tc>
-                  <a:txBody>
-                    <a:bodyPr/>
-                    <a:lstStyle/>
-                    <a:p>
-                      <a:pPr algn="ctr"/>
-                      <a:r>
-                        <a:rPr sz="1500" b="0">
-                          <a:solidFill>
-                            <a:srgbClr val="101F37"/>
-                          </a:solidFill>
-                          <a:latin typeface="Arial"/>
-                          <a:ea typeface="Microsoft YaHei"/>
-                        </a:rPr>
-                        <a:t>66.00</a:t>
-                      </a:r>
-                    </a:p>
-                    <a:p>
-                      <a:pPr algn="ctr"/>
-                      <a:r>
-                        <a:rPr sz="1100" b="0">
-                          <a:solidFill>
-                            <a:srgbClr val="6B7A90"/>
-                          </a:solidFill>
-                          <a:latin typeface="Arial"/>
-                          <a:ea typeface="Microsoft YaHei"/>
-                        </a:rPr>
-                        <a:t>65.678</a:t>
-                      </a:r>
-                    </a:p>
-                  </a:txBody>
-                  <a:tcPr anchor="ctr" marL="45720" marR="45720" marT="18288" marB="18288">
-                    <a:solidFill>
-                      <a:srgbClr val="EEF5FB"/>
-                    </a:solidFill>
-                  </a:tcPr>
-                </a:tc>
-                <a:tc>
-                  <a:txBody>
-                    <a:bodyPr/>
-                    <a:lstStyle/>
-                    <a:p>
-                      <a:pPr algn="ctr"/>
-                      <a:r>
-                        <a:rPr sz="1500" b="0">
-                          <a:solidFill>
-                            <a:srgbClr val="101F37"/>
-                          </a:solidFill>
-                          <a:latin typeface="Arial"/>
-                          <a:ea typeface="Microsoft YaHei"/>
-                        </a:rPr>
-                        <a:t>0.802</a:t>
-                      </a:r>
-                    </a:p>
-                    <a:p>
-                      <a:pPr algn="ctr"/>
-                      <a:r>
-                        <a:rPr sz="1100" b="0">
-                          <a:solidFill>
-                            <a:srgbClr val="6B7A90"/>
-                          </a:solidFill>
-                          <a:latin typeface="Arial"/>
-                          <a:ea typeface="Microsoft YaHei"/>
-                        </a:rPr>
-                        <a:t>0.660</a:t>
-                      </a:r>
-                    </a:p>
-                  </a:txBody>
-                  <a:tcPr anchor="ctr" marL="45720" marR="45720" marT="18288" marB="18288">
-                    <a:solidFill>
-                      <a:srgbClr val="EEF5FB"/>
-                    </a:solidFill>
-                  </a:tcPr>
-                </a:tc>
-                <a:tc>
-                  <a:txBody>
-                    <a:bodyPr/>
-                    <a:lstStyle/>
-                    <a:p>
-                      <a:pPr algn="ctr"/>
-                      <a:r>
-                        <a:rPr sz="1500" b="0">
-                          <a:solidFill>
-                            <a:srgbClr val="101F37"/>
-                          </a:solidFill>
-                          <a:latin typeface="Arial"/>
-                          <a:ea typeface="Microsoft YaHei"/>
-                        </a:rPr>
-                        <a:t>0.0216</a:t>
-                      </a:r>
-                    </a:p>
-                    <a:p>
-                      <a:pPr algn="ctr"/>
-                      <a:r>
-                        <a:rPr sz="1100" b="0">
-                          <a:solidFill>
-                            <a:srgbClr val="6B7A90"/>
-                          </a:solidFill>
-                          <a:latin typeface="Arial"/>
-                          <a:ea typeface="Microsoft YaHei"/>
-                        </a:rPr>
-                        <a:t>0.021</a:t>
-                      </a:r>
-                    </a:p>
-                  </a:txBody>
-                  <a:tcPr anchor="ctr" marL="45720" marR="45720" marT="18288" marB="18288">
-                    <a:solidFill>
-                      <a:srgbClr val="EEF5FB"/>
-                    </a:solidFill>
-                  </a:tcPr>
-                </a:tc>
-              </a:tr>
-              <a:tr h="548640">
-                <a:tc>
-                  <a:txBody>
-                    <a:bodyPr/>
-                    <a:lstStyle/>
-                    <a:p>
-                      <a:pPr algn="ctr"/>
-                      <a:r>
-                        <a:rPr sz="1500" b="1">
-                          <a:solidFill>
-                            <a:srgbClr val="101F37"/>
-                          </a:solidFill>
-                          <a:latin typeface="Arial"/>
-                          <a:ea typeface="Microsoft YaHei"/>
-                        </a:rPr>
-                        <a:t>Any-to-Bokeh</a:t>
-                      </a:r>
-                    </a:p>
-                  </a:txBody>
-                  <a:tcPr anchor="ctr" marL="45720" marR="45720" marT="18288" marB="18288">
-                    <a:solidFill>
-                      <a:srgbClr val="FFFFFF"/>
-                    </a:solidFill>
-                  </a:tcPr>
-                </a:tc>
-                <a:tc>
-                  <a:txBody>
-                    <a:bodyPr/>
-                    <a:lstStyle/>
-                    <a:p>
-                      <a:pPr algn="ctr"/>
-                      <a:r>
-                        <a:rPr sz="1500" b="1">
-                          <a:solidFill>
-                            <a:srgbClr val="101F37"/>
-                          </a:solidFill>
-                          <a:latin typeface="Arial"/>
-                          <a:ea typeface="Microsoft YaHei"/>
-                        </a:rPr>
-                        <a:t>8.94</a:t>
-                      </a:r>
-                    </a:p>
-                    <a:p>
-                      <a:pPr algn="ctr"/>
-                      <a:r>
-                        <a:rPr sz="1100" b="0">
-                          <a:solidFill>
-                            <a:srgbClr val="6B7A90"/>
-                          </a:solidFill>
-                          <a:latin typeface="Arial"/>
-                          <a:ea typeface="Microsoft YaHei"/>
-                        </a:rPr>
-                        <a:t>9.005</a:t>
-                      </a:r>
-                    </a:p>
-                  </a:txBody>
-                  <a:tcPr anchor="ctr" marL="45720" marR="45720" marT="18288" marB="18288">
-                    <a:solidFill>
-                      <a:srgbClr val="FFFFFF"/>
-                    </a:solidFill>
-                  </a:tcPr>
-                </a:tc>
-                <a:tc>
-                  <a:txBody>
-                    <a:bodyPr/>
-                    <a:lstStyle/>
-                    <a:p>
-                      <a:pPr algn="ctr"/>
-                      <a:r>
-                        <a:rPr sz="1500" b="1">
-                          <a:solidFill>
-                            <a:srgbClr val="101F37"/>
-                          </a:solidFill>
-                          <a:latin typeface="Arial"/>
-                          <a:ea typeface="Microsoft YaHei"/>
-                        </a:rPr>
-                        <a:t>0.445</a:t>
-                      </a:r>
-                    </a:p>
-                    <a:p>
-                      <a:pPr algn="ctr"/>
-                      <a:r>
-                        <a:rPr sz="1100" b="0">
-                          <a:solidFill>
-                            <a:srgbClr val="6B7A90"/>
-                          </a:solidFill>
-                          <a:latin typeface="Arial"/>
-                          <a:ea typeface="Microsoft YaHei"/>
-                        </a:rPr>
-                        <a:t>0.431</a:t>
-                      </a:r>
-                    </a:p>
-                  </a:txBody>
-                  <a:tcPr anchor="ctr" marL="45720" marR="45720" marT="18288" marB="18288">
-                    <a:solidFill>
-                      <a:srgbClr val="FFFFFF"/>
-                    </a:solidFill>
-                  </a:tcPr>
-                </a:tc>
-                <a:tc>
-                  <a:txBody>
-                    <a:bodyPr/>
-                    <a:lstStyle/>
-                    <a:p>
-                      <a:pPr algn="ctr"/>
-                      <a:r>
-                        <a:rPr sz="1500" b="1">
-                          <a:solidFill>
-                            <a:srgbClr val="101F37"/>
-                          </a:solidFill>
-                          <a:latin typeface="Arial"/>
-                          <a:ea typeface="Microsoft YaHei"/>
-                        </a:rPr>
-                        <a:t>0.0056</a:t>
-                      </a:r>
-                    </a:p>
-                    <a:p>
-                      <a:pPr algn="ctr"/>
-                      <a:r>
-                        <a:rPr sz="1100" b="0">
-                          <a:solidFill>
-                            <a:srgbClr val="6B7A90"/>
                           </a:solidFill>
                           <a:latin typeface="Arial"/>
                           <a:ea typeface="Microsoft YaHei"/>

</xml_diff>

<commit_message>
report: add mean abs deviation, BokehCrafter reference row, MagicBokeh plan, metric glossary
Co-Authored-By: Claude Opus 5.5 (1M context) <noreply@anthropic.com>
</commit_message>
<xml_diff>
--- a/汇报/2026-09-30_基线方法复现结果/基线方法复现结果_0930.pptx
+++ b/汇报/2026-09-30_基线方法复现结果/基线方法复现结果_0930.pptx
@@ -8071,8 +8071,8 @@
           <p:nvPr/>
         </p:nvGraphicFramePr>
         <p:xfrm>
-          <a:off x="868679" y="1481328"/>
-          <a:ext cx="10332720" cy="2176272"/>
+          <a:off x="868679" y="1463040"/>
+          <a:ext cx="10332720" cy="2267712"/>
         </p:xfrm>
         <a:graphic>
           <a:graphicData uri="http://schemas.openxmlformats.org/drawingml/2006/table">
@@ -8089,15 +8089,15 @@
                 <a:gridCol w="1371600"/>
                 <a:gridCol w="1371600"/>
               </a:tblGrid>
-              <a:tr h="310896">
-                <a:tc>
-                  <a:txBody>
-                    <a:bodyPr/>
-                    <a:lstStyle/>
-                    <a:p>
-                      <a:pPr algn="ctr"/>
-                      <a:r>
-                        <a:rPr sz="1500" b="1">
+              <a:tr h="283464">
+                <a:tc>
+                  <a:txBody>
+                    <a:bodyPr/>
+                    <a:lstStyle/>
+                    <a:p>
+                      <a:pPr algn="ctr"/>
+                      <a:r>
+                        <a:rPr sz="1400" b="1">
                           <a:solidFill>
                             <a:srgbClr val="FFFFFF"/>
                           </a:solidFill>
@@ -8121,7 +8121,7 @@
                     <a:p>
                       <a:pPr algn="ctr"/>
                       <a:r>
-                        <a:rPr sz="1500" b="1">
+                        <a:rPr sz="1400" b="1">
                           <a:solidFill>
                             <a:srgbClr val="FFFFFF"/>
                           </a:solidFill>
@@ -8145,7 +8145,7 @@
                     <a:p>
                       <a:pPr algn="ctr"/>
                       <a:r>
-                        <a:rPr sz="1500" b="1">
+                        <a:rPr sz="1400" b="1">
                           <a:solidFill>
                             <a:srgbClr val="FFFFFF"/>
                           </a:solidFill>
@@ -8169,7 +8169,7 @@
                     <a:p>
                       <a:pPr algn="ctr"/>
                       <a:r>
-                        <a:rPr sz="1500" b="1">
+                        <a:rPr sz="1400" b="1">
                           <a:solidFill>
                             <a:srgbClr val="FFFFFF"/>
                           </a:solidFill>
@@ -8193,7 +8193,7 @@
                     <a:p>
                       <a:pPr algn="ctr"/>
                       <a:r>
-                        <a:rPr sz="1500" b="1">
+                        <a:rPr sz="1400" b="1">
                           <a:solidFill>
                             <a:srgbClr val="FFFFFF"/>
                           </a:solidFill>
@@ -8217,7 +8217,7 @@
                     <a:p>
                       <a:pPr algn="ctr"/>
                       <a:r>
-                        <a:rPr sz="1500" b="1">
+                        <a:rPr sz="1400" b="1">
                           <a:solidFill>
                             <a:srgbClr val="FFFFFF"/>
                           </a:solidFill>
@@ -8241,7 +8241,7 @@
                     <a:p>
                       <a:pPr algn="ctr"/>
                       <a:r>
-                        <a:rPr sz="1500" b="1">
+                        <a:rPr sz="1400" b="1">
                           <a:solidFill>
                             <a:srgbClr val="FFFFFF"/>
                           </a:solidFill>
@@ -8259,15 +8259,15 @@
                   </a:tcPr>
                 </a:tc>
               </a:tr>
-              <a:tr h="310896">
-                <a:tc>
-                  <a:txBody>
-                    <a:bodyPr/>
-                    <a:lstStyle/>
-                    <a:p>
-                      <a:pPr algn="ctr"/>
-                      <a:r>
-                        <a:rPr sz="1500" b="1">
+              <a:tr h="283464">
+                <a:tc>
+                  <a:txBody>
+                    <a:bodyPr/>
+                    <a:lstStyle/>
+                    <a:p>
+                      <a:pPr algn="ctr"/>
+                      <a:r>
+                        <a:rPr sz="1400" b="1">
                           <a:solidFill>
                             <a:srgbClr val="101F37"/>
                           </a:solidFill>
@@ -8291,7 +8291,7 @@
                     <a:p>
                       <a:pPr algn="ctr"/>
                       <a:r>
-                        <a:rPr sz="1500" b="0">
+                        <a:rPr sz="1400" b="0">
                           <a:solidFill>
                             <a:srgbClr val="101F37"/>
                           </a:solidFill>
@@ -8315,7 +8315,7 @@
                     <a:p>
                       <a:pPr algn="ctr"/>
                       <a:r>
-                        <a:rPr sz="1500" b="0">
+                        <a:rPr sz="1400" b="0">
                           <a:solidFill>
                             <a:srgbClr val="101F37"/>
                           </a:solidFill>
@@ -8339,7 +8339,7 @@
                     <a:p>
                       <a:pPr algn="ctr"/>
                       <a:r>
-                        <a:rPr sz="1500" b="0">
+                        <a:rPr sz="1400" b="0">
                           <a:solidFill>
                             <a:srgbClr val="101F37"/>
                           </a:solidFill>
@@ -8363,7 +8363,7 @@
                     <a:p>
                       <a:pPr algn="ctr"/>
                       <a:r>
-                        <a:rPr sz="1500" b="0">
+                        <a:rPr sz="1400" b="0">
                           <a:solidFill>
                             <a:srgbClr val="101F37"/>
                           </a:solidFill>
@@ -8387,7 +8387,7 @@
                     <a:p>
                       <a:pPr algn="ctr"/>
                       <a:r>
-                        <a:rPr sz="1500" b="0">
+                        <a:rPr sz="1400" b="0">
                           <a:solidFill>
                             <a:srgbClr val="101F37"/>
                           </a:solidFill>
@@ -8411,7 +8411,7 @@
                     <a:p>
                       <a:pPr algn="ctr"/>
                       <a:r>
-                        <a:rPr sz="1500" b="0">
+                        <a:rPr sz="1400" b="0">
                           <a:solidFill>
                             <a:srgbClr val="101F37"/>
                           </a:solidFill>
@@ -8429,15 +8429,15 @@
                   </a:tcPr>
                 </a:tc>
               </a:tr>
-              <a:tr h="310896">
-                <a:tc>
-                  <a:txBody>
-                    <a:bodyPr/>
-                    <a:lstStyle/>
-                    <a:p>
-                      <a:pPr algn="ctr"/>
-                      <a:r>
-                        <a:rPr sz="1500" b="1">
+              <a:tr h="283464">
+                <a:tc>
+                  <a:txBody>
+                    <a:bodyPr/>
+                    <a:lstStyle/>
+                    <a:p>
+                      <a:pPr algn="ctr"/>
+                      <a:r>
+                        <a:rPr sz="1400" b="1">
                           <a:solidFill>
                             <a:srgbClr val="101F37"/>
                           </a:solidFill>
@@ -8461,7 +8461,7 @@
                     <a:p>
                       <a:pPr algn="ctr"/>
                       <a:r>
-                        <a:rPr sz="1500" b="0">
+                        <a:rPr sz="1400" b="0">
                           <a:solidFill>
                             <a:srgbClr val="101F37"/>
                           </a:solidFill>
@@ -8485,7 +8485,7 @@
                     <a:p>
                       <a:pPr algn="ctr"/>
                       <a:r>
-                        <a:rPr sz="1500" b="0">
+                        <a:rPr sz="1400" b="0">
                           <a:solidFill>
                             <a:srgbClr val="101F37"/>
                           </a:solidFill>
@@ -8509,7 +8509,7 @@
                     <a:p>
                       <a:pPr algn="ctr"/>
                       <a:r>
-                        <a:rPr sz="1500" b="0">
+                        <a:rPr sz="1400" b="0">
                           <a:solidFill>
                             <a:srgbClr val="101F37"/>
                           </a:solidFill>
@@ -8533,7 +8533,7 @@
                     <a:p>
                       <a:pPr algn="ctr"/>
                       <a:r>
-                        <a:rPr sz="1500" b="0">
+                        <a:rPr sz="1400" b="0">
                           <a:solidFill>
                             <a:srgbClr val="101F37"/>
                           </a:solidFill>
@@ -8557,7 +8557,7 @@
                     <a:p>
                       <a:pPr algn="ctr"/>
                       <a:r>
-                        <a:rPr sz="1500" b="0">
+                        <a:rPr sz="1400" b="0">
                           <a:solidFill>
                             <a:srgbClr val="101F37"/>
                           </a:solidFill>
@@ -8581,7 +8581,7 @@
                     <a:p>
                       <a:pPr algn="ctr"/>
                       <a:r>
-                        <a:rPr sz="1500" b="0">
+                        <a:rPr sz="1400" b="0">
                           <a:solidFill>
                             <a:srgbClr val="101F37"/>
                           </a:solidFill>
@@ -8599,15 +8599,15 @@
                   </a:tcPr>
                 </a:tc>
               </a:tr>
-              <a:tr h="310896">
-                <a:tc>
-                  <a:txBody>
-                    <a:bodyPr/>
-                    <a:lstStyle/>
-                    <a:p>
-                      <a:pPr algn="ctr"/>
-                      <a:r>
-                        <a:rPr sz="1500" b="1">
+              <a:tr h="283464">
+                <a:tc>
+                  <a:txBody>
+                    <a:bodyPr/>
+                    <a:lstStyle/>
+                    <a:p>
+                      <a:pPr algn="ctr"/>
+                      <a:r>
+                        <a:rPr sz="1400" b="1">
                           <a:solidFill>
                             <a:srgbClr val="101F37"/>
                           </a:solidFill>
@@ -8631,7 +8631,7 @@
                     <a:p>
                       <a:pPr algn="ctr"/>
                       <a:r>
-                        <a:rPr sz="1500" b="0">
+                        <a:rPr sz="1400" b="0">
                           <a:solidFill>
                             <a:srgbClr val="101F37"/>
                           </a:solidFill>
@@ -8655,7 +8655,7 @@
                     <a:p>
                       <a:pPr algn="ctr"/>
                       <a:r>
-                        <a:rPr sz="1500" b="0">
+                        <a:rPr sz="1400" b="0">
                           <a:solidFill>
                             <a:srgbClr val="101F37"/>
                           </a:solidFill>
@@ -8679,7 +8679,7 @@
                     <a:p>
                       <a:pPr algn="ctr"/>
                       <a:r>
-                        <a:rPr sz="1500" b="0">
+                        <a:rPr sz="1400" b="0">
                           <a:solidFill>
                             <a:srgbClr val="101F37"/>
                           </a:solidFill>
@@ -8703,7 +8703,7 @@
                     <a:p>
                       <a:pPr algn="ctr"/>
                       <a:r>
-                        <a:rPr sz="1500" b="0">
+                        <a:rPr sz="1400" b="0">
                           <a:solidFill>
                             <a:srgbClr val="101F37"/>
                           </a:solidFill>
@@ -8727,7 +8727,7 @@
                     <a:p>
                       <a:pPr algn="ctr"/>
                       <a:r>
-                        <a:rPr sz="1500" b="0">
+                        <a:rPr sz="1400" b="0">
                           <a:solidFill>
                             <a:srgbClr val="101F37"/>
                           </a:solidFill>
@@ -8751,7 +8751,7 @@
                     <a:p>
                       <a:pPr algn="ctr"/>
                       <a:r>
-                        <a:rPr sz="1500" b="0">
+                        <a:rPr sz="1400" b="0">
                           <a:solidFill>
                             <a:srgbClr val="101F37"/>
                           </a:solidFill>
@@ -8769,15 +8769,15 @@
                   </a:tcPr>
                 </a:tc>
               </a:tr>
-              <a:tr h="310896">
-                <a:tc>
-                  <a:txBody>
-                    <a:bodyPr/>
-                    <a:lstStyle/>
-                    <a:p>
-                      <a:pPr algn="ctr"/>
-                      <a:r>
-                        <a:rPr sz="1500" b="1">
+              <a:tr h="283464">
+                <a:tc>
+                  <a:txBody>
+                    <a:bodyPr/>
+                    <a:lstStyle/>
+                    <a:p>
+                      <a:pPr algn="ctr"/>
+                      <a:r>
+                        <a:rPr sz="1400" b="1">
                           <a:solidFill>
                             <a:srgbClr val="101F37"/>
                           </a:solidFill>
@@ -8801,7 +8801,7 @@
                     <a:p>
                       <a:pPr algn="ctr"/>
                       <a:r>
-                        <a:rPr sz="1500" b="0">
+                        <a:rPr sz="1400" b="0">
                           <a:solidFill>
                             <a:srgbClr val="101F37"/>
                           </a:solidFill>
@@ -8825,7 +8825,7 @@
                     <a:p>
                       <a:pPr algn="ctr"/>
                       <a:r>
-                        <a:rPr sz="1500" b="0">
+                        <a:rPr sz="1400" b="0">
                           <a:solidFill>
                             <a:srgbClr val="101F37"/>
                           </a:solidFill>
@@ -8849,7 +8849,7 @@
                     <a:p>
                       <a:pPr algn="ctr"/>
                       <a:r>
-                        <a:rPr sz="1500" b="0">
+                        <a:rPr sz="1400" b="0">
                           <a:solidFill>
                             <a:srgbClr val="101F37"/>
                           </a:solidFill>
@@ -8873,7 +8873,7 @@
                     <a:p>
                       <a:pPr algn="ctr"/>
                       <a:r>
-                        <a:rPr sz="1500" b="0">
+                        <a:rPr sz="1400" b="0">
                           <a:solidFill>
                             <a:srgbClr val="101F37"/>
                           </a:solidFill>
@@ -8897,7 +8897,7 @@
                     <a:p>
                       <a:pPr algn="ctr"/>
                       <a:r>
-                        <a:rPr sz="1500" b="0">
+                        <a:rPr sz="1400" b="0">
                           <a:solidFill>
                             <a:srgbClr val="101F37"/>
                           </a:solidFill>
@@ -8921,7 +8921,7 @@
                     <a:p>
                       <a:pPr algn="ctr"/>
                       <a:r>
-                        <a:rPr sz="1500" b="0">
+                        <a:rPr sz="1400" b="0">
                           <a:solidFill>
                             <a:srgbClr val="101F37"/>
                           </a:solidFill>
@@ -8939,15 +8939,15 @@
                   </a:tcPr>
                 </a:tc>
               </a:tr>
-              <a:tr h="310896">
-                <a:tc>
-                  <a:txBody>
-                    <a:bodyPr/>
-                    <a:lstStyle/>
-                    <a:p>
-                      <a:pPr algn="ctr"/>
-                      <a:r>
-                        <a:rPr sz="1500" b="1">
+              <a:tr h="283464">
+                <a:tc>
+                  <a:txBody>
+                    <a:bodyPr/>
+                    <a:lstStyle/>
+                    <a:p>
+                      <a:pPr algn="ctr"/>
+                      <a:r>
+                        <a:rPr sz="1400" b="1">
                           <a:solidFill>
                             <a:srgbClr val="101F37"/>
                           </a:solidFill>
@@ -8971,7 +8971,7 @@
                     <a:p>
                       <a:pPr algn="ctr"/>
                       <a:r>
-                        <a:rPr sz="1500" b="0">
+                        <a:rPr sz="1400" b="0">
                           <a:solidFill>
                             <a:srgbClr val="101F37"/>
                           </a:solidFill>
@@ -8995,7 +8995,7 @@
                     <a:p>
                       <a:pPr algn="ctr"/>
                       <a:r>
-                        <a:rPr sz="1500" b="0">
+                        <a:rPr sz="1400" b="0">
                           <a:solidFill>
                             <a:srgbClr val="101F37"/>
                           </a:solidFill>
@@ -9019,7 +9019,7 @@
                     <a:p>
                       <a:pPr algn="ctr"/>
                       <a:r>
-                        <a:rPr sz="1500" b="0">
+                        <a:rPr sz="1400" b="0">
                           <a:solidFill>
                             <a:srgbClr val="101F37"/>
                           </a:solidFill>
@@ -9043,7 +9043,7 @@
                     <a:p>
                       <a:pPr algn="ctr"/>
                       <a:r>
-                        <a:rPr sz="1500" b="0">
+                        <a:rPr sz="1400" b="0">
                           <a:solidFill>
                             <a:srgbClr val="101F37"/>
                           </a:solidFill>
@@ -9067,7 +9067,7 @@
                     <a:p>
                       <a:pPr algn="ctr"/>
                       <a:r>
-                        <a:rPr sz="1500" b="0">
+                        <a:rPr sz="1400" b="0">
                           <a:solidFill>
                             <a:srgbClr val="101F37"/>
                           </a:solidFill>
@@ -9091,7 +9091,7 @@
                     <a:p>
                       <a:pPr algn="ctr"/>
                       <a:r>
-                        <a:rPr sz="1500" b="0">
+                        <a:rPr sz="1400" b="0">
                           <a:solidFill>
                             <a:srgbClr val="101F37"/>
                           </a:solidFill>
@@ -9109,15 +9109,15 @@
                   </a:tcPr>
                 </a:tc>
               </a:tr>
-              <a:tr h="310896">
-                <a:tc>
-                  <a:txBody>
-                    <a:bodyPr/>
-                    <a:lstStyle/>
-                    <a:p>
-                      <a:pPr algn="ctr"/>
-                      <a:r>
-                        <a:rPr sz="1500" b="1">
+              <a:tr h="283464">
+                <a:tc>
+                  <a:txBody>
+                    <a:bodyPr/>
+                    <a:lstStyle/>
+                    <a:p>
+                      <a:pPr algn="ctr"/>
+                      <a:r>
+                        <a:rPr sz="1400" b="1">
                           <a:solidFill>
                             <a:srgbClr val="101F37"/>
                           </a:solidFill>
@@ -9141,7 +9141,7 @@
                     <a:p>
                       <a:pPr algn="ctr"/>
                       <a:r>
-                        <a:rPr sz="1500" b="1">
+                        <a:rPr sz="1400" b="1">
                           <a:solidFill>
                             <a:srgbClr val="101F37"/>
                           </a:solidFill>
@@ -9165,7 +9165,7 @@
                     <a:p>
                       <a:pPr algn="ctr"/>
                       <a:r>
-                        <a:rPr sz="1500" b="1">
+                        <a:rPr sz="1400" b="1">
                           <a:solidFill>
                             <a:srgbClr val="101F37"/>
                           </a:solidFill>
@@ -9189,7 +9189,7 @@
                     <a:p>
                       <a:pPr algn="ctr"/>
                       <a:r>
-                        <a:rPr sz="1500" b="1">
+                        <a:rPr sz="1400" b="1">
                           <a:solidFill>
                             <a:srgbClr val="101F37"/>
                           </a:solidFill>
@@ -9213,7 +9213,7 @@
                     <a:p>
                       <a:pPr algn="ctr"/>
                       <a:r>
-                        <a:rPr sz="1500" b="1">
+                        <a:rPr sz="1400" b="1">
                           <a:solidFill>
                             <a:srgbClr val="101F37"/>
                           </a:solidFill>
@@ -9237,7 +9237,7 @@
                     <a:p>
                       <a:pPr algn="ctr"/>
                       <a:r>
-                        <a:rPr sz="1500" b="1">
+                        <a:rPr sz="1400" b="1">
                           <a:solidFill>
                             <a:srgbClr val="101F37"/>
                           </a:solidFill>
@@ -9261,7 +9261,7 @@
                     <a:p>
                       <a:pPr algn="ctr"/>
                       <a:r>
-                        <a:rPr sz="1500" b="1">
+                        <a:rPr sz="1400" b="1">
                           <a:solidFill>
                             <a:srgbClr val="101F37"/>
                           </a:solidFill>
@@ -9275,6 +9275,176 @@
                   <a:tcPr anchor="ctr" marL="45720" marR="45720" marT="18288" marB="18288">
                     <a:solidFill>
                       <a:srgbClr val="FFFFFF"/>
+                    </a:solidFill>
+                  </a:tcPr>
+                </a:tc>
+              </a:tr>
+              <a:tr h="283464">
+                <a:tc>
+                  <a:txBody>
+                    <a:bodyPr/>
+                    <a:lstStyle/>
+                    <a:p>
+                      <a:pPr algn="ctr"/>
+                      <a:r>
+                        <a:rPr sz="1400" b="1">
+                          <a:solidFill>
+                            <a:srgbClr val="0D569A"/>
+                          </a:solidFill>
+                          <a:latin typeface="Arial"/>
+                          <a:ea typeface="Microsoft YaHei"/>
+                        </a:rPr>
+                        <a:t>平均绝对偏差</a:t>
+                      </a:r>
+                    </a:p>
+                  </a:txBody>
+                  <a:tcPr anchor="ctr" marL="45720" marR="45720" marT="18288" marB="18288">
+                    <a:solidFill>
+                      <a:srgbClr val="DCE9F5"/>
+                    </a:solidFill>
+                  </a:tcPr>
+                </a:tc>
+                <a:tc>
+                  <a:txBody>
+                    <a:bodyPr/>
+                    <a:lstStyle/>
+                    <a:p>
+                      <a:pPr algn="ctr"/>
+                      <a:r>
+                        <a:rPr sz="1400" b="0">
+                          <a:solidFill>
+                            <a:srgbClr val="0D569A"/>
+                          </a:solidFill>
+                          <a:latin typeface="Arial"/>
+                          <a:ea typeface="Microsoft YaHei"/>
+                        </a:rPr>
+                        <a:t>1.79</a:t>
+                      </a:r>
+                    </a:p>
+                  </a:txBody>
+                  <a:tcPr anchor="ctr" marL="45720" marR="45720" marT="18288" marB="18288">
+                    <a:solidFill>
+                      <a:srgbClr val="DCE9F5"/>
+                    </a:solidFill>
+                  </a:tcPr>
+                </a:tc>
+                <a:tc>
+                  <a:txBody>
+                    <a:bodyPr/>
+                    <a:lstStyle/>
+                    <a:p>
+                      <a:pPr algn="ctr"/>
+                      <a:r>
+                        <a:rPr sz="1400" b="0">
+                          <a:solidFill>
+                            <a:srgbClr val="0D569A"/>
+                          </a:solidFill>
+                          <a:latin typeface="Arial"/>
+                          <a:ea typeface="Microsoft YaHei"/>
+                        </a:rPr>
+                        <a:t>0.040</a:t>
+                      </a:r>
+                    </a:p>
+                  </a:txBody>
+                  <a:tcPr anchor="ctr" marL="45720" marR="45720" marT="18288" marB="18288">
+                    <a:solidFill>
+                      <a:srgbClr val="DCE9F5"/>
+                    </a:solidFill>
+                  </a:tcPr>
+                </a:tc>
+                <a:tc>
+                  <a:txBody>
+                    <a:bodyPr/>
+                    <a:lstStyle/>
+                    <a:p>
+                      <a:pPr algn="ctr"/>
+                      <a:r>
+                        <a:rPr sz="1400" b="0">
+                          <a:solidFill>
+                            <a:srgbClr val="0D569A"/>
+                          </a:solidFill>
+                          <a:latin typeface="Arial"/>
+                          <a:ea typeface="Microsoft YaHei"/>
+                        </a:rPr>
+                        <a:t>0.032</a:t>
+                      </a:r>
+                    </a:p>
+                  </a:txBody>
+                  <a:tcPr anchor="ctr" marL="45720" marR="45720" marT="18288" marB="18288">
+                    <a:solidFill>
+                      <a:srgbClr val="DCE9F5"/>
+                    </a:solidFill>
+                  </a:tcPr>
+                </a:tc>
+                <a:tc>
+                  <a:txBody>
+                    <a:bodyPr/>
+                    <a:lstStyle/>
+                    <a:p>
+                      <a:pPr algn="ctr"/>
+                      <a:r>
+                        <a:rPr sz="1400" b="0">
+                          <a:solidFill>
+                            <a:srgbClr val="0D569A"/>
+                          </a:solidFill>
+                          <a:latin typeface="Arial"/>
+                          <a:ea typeface="Microsoft YaHei"/>
+                        </a:rPr>
+                        <a:t>20.64</a:t>
+                      </a:r>
+                    </a:p>
+                  </a:txBody>
+                  <a:tcPr anchor="ctr" marL="45720" marR="45720" marT="18288" marB="18288">
+                    <a:solidFill>
+                      <a:srgbClr val="DCE9F5"/>
+                    </a:solidFill>
+                  </a:tcPr>
+                </a:tc>
+                <a:tc>
+                  <a:txBody>
+                    <a:bodyPr/>
+                    <a:lstStyle/>
+                    <a:p>
+                      <a:pPr algn="ctr"/>
+                      <a:r>
+                        <a:rPr sz="1400" b="0">
+                          <a:solidFill>
+                            <a:srgbClr val="0D569A"/>
+                          </a:solidFill>
+                          <a:latin typeface="Arial"/>
+                          <a:ea typeface="Microsoft YaHei"/>
+                        </a:rPr>
+                        <a:t>0.136</a:t>
+                      </a:r>
+                    </a:p>
+                  </a:txBody>
+                  <a:tcPr anchor="ctr" marL="45720" marR="45720" marT="18288" marB="18288">
+                    <a:solidFill>
+                      <a:srgbClr val="DCE9F5"/>
+                    </a:solidFill>
+                  </a:tcPr>
+                </a:tc>
+                <a:tc>
+                  <a:txBody>
+                    <a:bodyPr/>
+                    <a:lstStyle/>
+                    <a:p>
+                      <a:pPr algn="ctr"/>
+                      <a:r>
+                        <a:rPr sz="1400" b="0">
+                          <a:solidFill>
+                            <a:srgbClr val="0D569A"/>
+                          </a:solidFill>
+                          <a:latin typeface="Arial"/>
+                          <a:ea typeface="Microsoft YaHei"/>
+                        </a:rPr>
+                        <a:t>0.0051</a:t>
+                      </a:r>
+                    </a:p>
+                  </a:txBody>
+                  <a:tcPr anchor="ctr" marL="45720" marR="45720" marT="18288" marB="18288">
+                    <a:solidFill>
+                      <a:srgbClr val="DCE9F5"/>
                     </a:solidFill>
                   </a:tcPr>
                 </a:tc>
@@ -9292,8 +9462,8 @@
           <p:nvPr/>
         </p:nvGraphicFramePr>
         <p:xfrm>
-          <a:off x="868679" y="3886200"/>
-          <a:ext cx="10332720" cy="2176272"/>
+          <a:off x="868679" y="3840480"/>
+          <a:ext cx="10332720" cy="2267712"/>
         </p:xfrm>
         <a:graphic>
           <a:graphicData uri="http://schemas.openxmlformats.org/drawingml/2006/table">
@@ -9310,15 +9480,15 @@
                 <a:gridCol w="1371600"/>
                 <a:gridCol w="1371600"/>
               </a:tblGrid>
-              <a:tr h="310896">
-                <a:tc>
-                  <a:txBody>
-                    <a:bodyPr/>
-                    <a:lstStyle/>
-                    <a:p>
-                      <a:pPr algn="ctr"/>
-                      <a:r>
-                        <a:rPr sz="1500" b="1">
+              <a:tr h="283464">
+                <a:tc>
+                  <a:txBody>
+                    <a:bodyPr/>
+                    <a:lstStyle/>
+                    <a:p>
+                      <a:pPr algn="ctr"/>
+                      <a:r>
+                        <a:rPr sz="1400" b="1">
                           <a:solidFill>
                             <a:srgbClr val="FFFFFF"/>
                           </a:solidFill>
@@ -9342,7 +9512,7 @@
                     <a:p>
                       <a:pPr algn="ctr"/>
                       <a:r>
-                        <a:rPr sz="1500" b="1">
+                        <a:rPr sz="1400" b="1">
                           <a:solidFill>
                             <a:srgbClr val="FFFFFF"/>
                           </a:solidFill>
@@ -9366,7 +9536,7 @@
                     <a:p>
                       <a:pPr algn="ctr"/>
                       <a:r>
-                        <a:rPr sz="1500" b="1">
+                        <a:rPr sz="1400" b="1">
                           <a:solidFill>
                             <a:srgbClr val="FFFFFF"/>
                           </a:solidFill>
@@ -9390,7 +9560,7 @@
                     <a:p>
                       <a:pPr algn="ctr"/>
                       <a:r>
-                        <a:rPr sz="1500" b="1">
+                        <a:rPr sz="1400" b="1">
                           <a:solidFill>
                             <a:srgbClr val="FFFFFF"/>
                           </a:solidFill>
@@ -9414,7 +9584,7 @@
                     <a:p>
                       <a:pPr algn="ctr"/>
                       <a:r>
-                        <a:rPr sz="1500" b="1">
+                        <a:rPr sz="1400" b="1">
                           <a:solidFill>
                             <a:srgbClr val="FFFFFF"/>
                           </a:solidFill>
@@ -9438,7 +9608,7 @@
                     <a:p>
                       <a:pPr algn="ctr"/>
                       <a:r>
-                        <a:rPr sz="1500" b="1">
+                        <a:rPr sz="1400" b="1">
                           <a:solidFill>
                             <a:srgbClr val="FFFFFF"/>
                           </a:solidFill>
@@ -9462,7 +9632,7 @@
                     <a:p>
                       <a:pPr algn="ctr"/>
                       <a:r>
-                        <a:rPr sz="1500" b="1">
+                        <a:rPr sz="1400" b="1">
                           <a:solidFill>
                             <a:srgbClr val="FFFFFF"/>
                           </a:solidFill>
@@ -9480,15 +9650,15 @@
                   </a:tcPr>
                 </a:tc>
               </a:tr>
-              <a:tr h="310896">
-                <a:tc>
-                  <a:txBody>
-                    <a:bodyPr/>
-                    <a:lstStyle/>
-                    <a:p>
-                      <a:pPr algn="ctr"/>
-                      <a:r>
-                        <a:rPr sz="1500" b="1">
+              <a:tr h="283464">
+                <a:tc>
+                  <a:txBody>
+                    <a:bodyPr/>
+                    <a:lstStyle/>
+                    <a:p>
+                      <a:pPr algn="ctr"/>
+                      <a:r>
+                        <a:rPr sz="1400" b="1">
                           <a:solidFill>
                             <a:srgbClr val="101F37"/>
                           </a:solidFill>
@@ -9512,7 +9682,7 @@
                     <a:p>
                       <a:pPr algn="ctr"/>
                       <a:r>
-                        <a:rPr sz="1500" b="0">
+                        <a:rPr sz="1400" b="0">
                           <a:solidFill>
                             <a:srgbClr val="101F37"/>
                           </a:solidFill>
@@ -9536,7 +9706,7 @@
                     <a:p>
                       <a:pPr algn="ctr"/>
                       <a:r>
-                        <a:rPr sz="1500" b="0">
+                        <a:rPr sz="1400" b="0">
                           <a:solidFill>
                             <a:srgbClr val="101F37"/>
                           </a:solidFill>
@@ -9560,7 +9730,7 @@
                     <a:p>
                       <a:pPr algn="ctr"/>
                       <a:r>
-                        <a:rPr sz="1500" b="0">
+                        <a:rPr sz="1400" b="0">
                           <a:solidFill>
                             <a:srgbClr val="101F37"/>
                           </a:solidFill>
@@ -9584,7 +9754,7 @@
                     <a:p>
                       <a:pPr algn="ctr"/>
                       <a:r>
-                        <a:rPr sz="1500" b="0">
+                        <a:rPr sz="1400" b="0">
                           <a:solidFill>
                             <a:srgbClr val="101F37"/>
                           </a:solidFill>
@@ -9608,7 +9778,7 @@
                     <a:p>
                       <a:pPr algn="ctr"/>
                       <a:r>
-                        <a:rPr sz="1500" b="0">
+                        <a:rPr sz="1400" b="0">
                           <a:solidFill>
                             <a:srgbClr val="101F37"/>
                           </a:solidFill>
@@ -9632,7 +9802,7 @@
                     <a:p>
                       <a:pPr algn="ctr"/>
                       <a:r>
-                        <a:rPr sz="1500" b="0">
+                        <a:rPr sz="1400" b="0">
                           <a:solidFill>
                             <a:srgbClr val="101F37"/>
                           </a:solidFill>
@@ -9650,15 +9820,15 @@
                   </a:tcPr>
                 </a:tc>
               </a:tr>
-              <a:tr h="310896">
-                <a:tc>
-                  <a:txBody>
-                    <a:bodyPr/>
-                    <a:lstStyle/>
-                    <a:p>
-                      <a:pPr algn="ctr"/>
-                      <a:r>
-                        <a:rPr sz="1500" b="1">
+              <a:tr h="283464">
+                <a:tc>
+                  <a:txBody>
+                    <a:bodyPr/>
+                    <a:lstStyle/>
+                    <a:p>
+                      <a:pPr algn="ctr"/>
+                      <a:r>
+                        <a:rPr sz="1400" b="1">
                           <a:solidFill>
                             <a:srgbClr val="101F37"/>
                           </a:solidFill>
@@ -9682,7 +9852,7 @@
                     <a:p>
                       <a:pPr algn="ctr"/>
                       <a:r>
-                        <a:rPr sz="1500" b="0">
+                        <a:rPr sz="1400" b="0">
                           <a:solidFill>
                             <a:srgbClr val="101F37"/>
                           </a:solidFill>
@@ -9706,7 +9876,7 @@
                     <a:p>
                       <a:pPr algn="ctr"/>
                       <a:r>
-                        <a:rPr sz="1500" b="0">
+                        <a:rPr sz="1400" b="0">
                           <a:solidFill>
                             <a:srgbClr val="101F37"/>
                           </a:solidFill>
@@ -9730,7 +9900,7 @@
                     <a:p>
                       <a:pPr algn="ctr"/>
                       <a:r>
-                        <a:rPr sz="1500" b="0">
+                        <a:rPr sz="1400" b="0">
                           <a:solidFill>
                             <a:srgbClr val="101F37"/>
                           </a:solidFill>
@@ -9754,7 +9924,7 @@
                     <a:p>
                       <a:pPr algn="ctr"/>
                       <a:r>
-                        <a:rPr sz="1500" b="0">
+                        <a:rPr sz="1400" b="0">
                           <a:solidFill>
                             <a:srgbClr val="101F37"/>
                           </a:solidFill>
@@ -9778,7 +9948,7 @@
                     <a:p>
                       <a:pPr algn="ctr"/>
                       <a:r>
-                        <a:rPr sz="1500" b="0">
+                        <a:rPr sz="1400" b="0">
                           <a:solidFill>
                             <a:srgbClr val="101F37"/>
                           </a:solidFill>
@@ -9802,7 +9972,7 @@
                     <a:p>
                       <a:pPr algn="ctr"/>
                       <a:r>
-                        <a:rPr sz="1500" b="0">
+                        <a:rPr sz="1400" b="0">
                           <a:solidFill>
                             <a:srgbClr val="101F37"/>
                           </a:solidFill>
@@ -9820,15 +9990,15 @@
                   </a:tcPr>
                 </a:tc>
               </a:tr>
-              <a:tr h="310896">
-                <a:tc>
-                  <a:txBody>
-                    <a:bodyPr/>
-                    <a:lstStyle/>
-                    <a:p>
-                      <a:pPr algn="ctr"/>
-                      <a:r>
-                        <a:rPr sz="1500" b="1">
+              <a:tr h="283464">
+                <a:tc>
+                  <a:txBody>
+                    <a:bodyPr/>
+                    <a:lstStyle/>
+                    <a:p>
+                      <a:pPr algn="ctr"/>
+                      <a:r>
+                        <a:rPr sz="1400" b="1">
                           <a:solidFill>
                             <a:srgbClr val="101F37"/>
                           </a:solidFill>
@@ -9852,7 +10022,7 @@
                     <a:p>
                       <a:pPr algn="ctr"/>
                       <a:r>
-                        <a:rPr sz="1500" b="0">
+                        <a:rPr sz="1400" b="0">
                           <a:solidFill>
                             <a:srgbClr val="101F37"/>
                           </a:solidFill>
@@ -9876,7 +10046,7 @@
                     <a:p>
                       <a:pPr algn="ctr"/>
                       <a:r>
-                        <a:rPr sz="1500" b="0">
+                        <a:rPr sz="1400" b="0">
                           <a:solidFill>
                             <a:srgbClr val="101F37"/>
                           </a:solidFill>
@@ -9900,7 +10070,7 @@
                     <a:p>
                       <a:pPr algn="ctr"/>
                       <a:r>
-                        <a:rPr sz="1500" b="0">
+                        <a:rPr sz="1400" b="0">
                           <a:solidFill>
                             <a:srgbClr val="101F37"/>
                           </a:solidFill>
@@ -9924,7 +10094,7 @@
                     <a:p>
                       <a:pPr algn="ctr"/>
                       <a:r>
-                        <a:rPr sz="1500" b="0">
+                        <a:rPr sz="1400" b="0">
                           <a:solidFill>
                             <a:srgbClr val="101F37"/>
                           </a:solidFill>
@@ -9948,7 +10118,7 @@
                     <a:p>
                       <a:pPr algn="ctr"/>
                       <a:r>
-                        <a:rPr sz="1500" b="0">
+                        <a:rPr sz="1400" b="0">
                           <a:solidFill>
                             <a:srgbClr val="101F37"/>
                           </a:solidFill>
@@ -9972,7 +10142,7 @@
                     <a:p>
                       <a:pPr algn="ctr"/>
                       <a:r>
-                        <a:rPr sz="1500" b="0">
+                        <a:rPr sz="1400" b="0">
                           <a:solidFill>
                             <a:srgbClr val="101F37"/>
                           </a:solidFill>
@@ -9990,15 +10160,15 @@
                   </a:tcPr>
                 </a:tc>
               </a:tr>
-              <a:tr h="310896">
-                <a:tc>
-                  <a:txBody>
-                    <a:bodyPr/>
-                    <a:lstStyle/>
-                    <a:p>
-                      <a:pPr algn="ctr"/>
-                      <a:r>
-                        <a:rPr sz="1500" b="1">
+              <a:tr h="283464">
+                <a:tc>
+                  <a:txBody>
+                    <a:bodyPr/>
+                    <a:lstStyle/>
+                    <a:p>
+                      <a:pPr algn="ctr"/>
+                      <a:r>
+                        <a:rPr sz="1400" b="1">
                           <a:solidFill>
                             <a:srgbClr val="101F37"/>
                           </a:solidFill>
@@ -10022,7 +10192,7 @@
                     <a:p>
                       <a:pPr algn="ctr"/>
                       <a:r>
-                        <a:rPr sz="1500" b="0">
+                        <a:rPr sz="1400" b="0">
                           <a:solidFill>
                             <a:srgbClr val="101F37"/>
                           </a:solidFill>
@@ -10046,7 +10216,7 @@
                     <a:p>
                       <a:pPr algn="ctr"/>
                       <a:r>
-                        <a:rPr sz="1500" b="0">
+                        <a:rPr sz="1400" b="0">
                           <a:solidFill>
                             <a:srgbClr val="101F37"/>
                           </a:solidFill>
@@ -10070,7 +10240,7 @@
                     <a:p>
                       <a:pPr algn="ctr"/>
                       <a:r>
-                        <a:rPr sz="1500" b="0">
+                        <a:rPr sz="1400" b="0">
                           <a:solidFill>
                             <a:srgbClr val="101F37"/>
                           </a:solidFill>
@@ -10094,7 +10264,7 @@
                     <a:p>
                       <a:pPr algn="ctr"/>
                       <a:r>
-                        <a:rPr sz="1500" b="0">
+                        <a:rPr sz="1400" b="0">
                           <a:solidFill>
                             <a:srgbClr val="101F37"/>
                           </a:solidFill>
@@ -10118,7 +10288,7 @@
                     <a:p>
                       <a:pPr algn="ctr"/>
                       <a:r>
-                        <a:rPr sz="1500" b="0">
+                        <a:rPr sz="1400" b="0">
                           <a:solidFill>
                             <a:srgbClr val="101F37"/>
                           </a:solidFill>
@@ -10142,7 +10312,7 @@
                     <a:p>
                       <a:pPr algn="ctr"/>
                       <a:r>
-                        <a:rPr sz="1500" b="0">
+                        <a:rPr sz="1400" b="0">
                           <a:solidFill>
                             <a:srgbClr val="101F37"/>
                           </a:solidFill>
@@ -10160,15 +10330,15 @@
                   </a:tcPr>
                 </a:tc>
               </a:tr>
-              <a:tr h="310896">
-                <a:tc>
-                  <a:txBody>
-                    <a:bodyPr/>
-                    <a:lstStyle/>
-                    <a:p>
-                      <a:pPr algn="ctr"/>
-                      <a:r>
-                        <a:rPr sz="1500" b="1">
+              <a:tr h="283464">
+                <a:tc>
+                  <a:txBody>
+                    <a:bodyPr/>
+                    <a:lstStyle/>
+                    <a:p>
+                      <a:pPr algn="ctr"/>
+                      <a:r>
+                        <a:rPr sz="1400" b="1">
                           <a:solidFill>
                             <a:srgbClr val="101F37"/>
                           </a:solidFill>
@@ -10192,7 +10362,7 @@
                     <a:p>
                       <a:pPr algn="ctr"/>
                       <a:r>
-                        <a:rPr sz="1500" b="0">
+                        <a:rPr sz="1400" b="0">
                           <a:solidFill>
                             <a:srgbClr val="101F37"/>
                           </a:solidFill>
@@ -10216,7 +10386,7 @@
                     <a:p>
                       <a:pPr algn="ctr"/>
                       <a:r>
-                        <a:rPr sz="1500" b="0">
+                        <a:rPr sz="1400" b="0">
                           <a:solidFill>
                             <a:srgbClr val="101F37"/>
                           </a:solidFill>
@@ -10240,7 +10410,7 @@
                     <a:p>
                       <a:pPr algn="ctr"/>
                       <a:r>
-                        <a:rPr sz="1500" b="0">
+                        <a:rPr sz="1400" b="0">
                           <a:solidFill>
                             <a:srgbClr val="101F37"/>
                           </a:solidFill>
@@ -10264,7 +10434,7 @@
                     <a:p>
                       <a:pPr algn="ctr"/>
                       <a:r>
-                        <a:rPr sz="1500" b="0">
+                        <a:rPr sz="1400" b="0">
                           <a:solidFill>
                             <a:srgbClr val="101F37"/>
                           </a:solidFill>
@@ -10288,7 +10458,7 @@
                     <a:p>
                       <a:pPr algn="ctr"/>
                       <a:r>
-                        <a:rPr sz="1500" b="0">
+                        <a:rPr sz="1400" b="0">
                           <a:solidFill>
                             <a:srgbClr val="101F37"/>
                           </a:solidFill>
@@ -10312,7 +10482,7 @@
                     <a:p>
                       <a:pPr algn="ctr"/>
                       <a:r>
-                        <a:rPr sz="1500" b="0">
+                        <a:rPr sz="1400" b="0">
                           <a:solidFill>
                             <a:srgbClr val="101F37"/>
                           </a:solidFill>
@@ -10330,15 +10500,15 @@
                   </a:tcPr>
                 </a:tc>
               </a:tr>
-              <a:tr h="310896">
-                <a:tc>
-                  <a:txBody>
-                    <a:bodyPr/>
-                    <a:lstStyle/>
-                    <a:p>
-                      <a:pPr algn="ctr"/>
-                      <a:r>
-                        <a:rPr sz="1500" b="1">
+              <a:tr h="283464">
+                <a:tc>
+                  <a:txBody>
+                    <a:bodyPr/>
+                    <a:lstStyle/>
+                    <a:p>
+                      <a:pPr algn="ctr"/>
+                      <a:r>
+                        <a:rPr sz="1400" b="1">
                           <a:solidFill>
                             <a:srgbClr val="101F37"/>
                           </a:solidFill>
@@ -10362,7 +10532,7 @@
                     <a:p>
                       <a:pPr algn="ctr"/>
                       <a:r>
-                        <a:rPr sz="1500" b="1">
+                        <a:rPr sz="1400" b="1">
                           <a:solidFill>
                             <a:srgbClr val="101F37"/>
                           </a:solidFill>
@@ -10386,7 +10556,7 @@
                     <a:p>
                       <a:pPr algn="ctr"/>
                       <a:r>
-                        <a:rPr sz="1500" b="1">
+                        <a:rPr sz="1400" b="1">
                           <a:solidFill>
                             <a:srgbClr val="101F37"/>
                           </a:solidFill>
@@ -10410,7 +10580,7 @@
                     <a:p>
                       <a:pPr algn="ctr"/>
                       <a:r>
-                        <a:rPr sz="1500" b="1">
+                        <a:rPr sz="1400" b="1">
                           <a:solidFill>
                             <a:srgbClr val="101F37"/>
                           </a:solidFill>
@@ -10434,7 +10604,7 @@
                     <a:p>
                       <a:pPr algn="ctr"/>
                       <a:r>
-                        <a:rPr sz="1500" b="1">
+                        <a:rPr sz="1400" b="1">
                           <a:solidFill>
                             <a:srgbClr val="101F37"/>
                           </a:solidFill>
@@ -10458,7 +10628,7 @@
                     <a:p>
                       <a:pPr algn="ctr"/>
                       <a:r>
-                        <a:rPr sz="1500" b="1">
+                        <a:rPr sz="1400" b="1">
                           <a:solidFill>
                             <a:srgbClr val="101F37"/>
                           </a:solidFill>
@@ -10482,7 +10652,7 @@
                     <a:p>
                       <a:pPr algn="ctr"/>
                       <a:r>
-                        <a:rPr sz="1500" b="1">
+                        <a:rPr sz="1400" b="1">
                           <a:solidFill>
                             <a:srgbClr val="101F37"/>
                           </a:solidFill>
@@ -10496,6 +10666,176 @@
                   <a:tcPr anchor="ctr" marL="45720" marR="45720" marT="18288" marB="18288">
                     <a:solidFill>
                       <a:srgbClr val="FFFFFF"/>
+                    </a:solidFill>
+                  </a:tcPr>
+                </a:tc>
+              </a:tr>
+              <a:tr h="283464">
+                <a:tc>
+                  <a:txBody>
+                    <a:bodyPr/>
+                    <a:lstStyle/>
+                    <a:p>
+                      <a:pPr algn="ctr"/>
+                      <a:r>
+                        <a:rPr sz="1400" b="1">
+                          <a:solidFill>
+                            <a:srgbClr val="6B7A90"/>
+                          </a:solidFill>
+                          <a:latin typeface="Arial"/>
+                          <a:ea typeface="Microsoft YaHei"/>
+                        </a:rPr>
+                        <a:t>BokehCrafter*</a:t>
+                      </a:r>
+                    </a:p>
+                  </a:txBody>
+                  <a:tcPr anchor="ctr" marL="45720" marR="45720" marT="18288" marB="18288">
+                    <a:solidFill>
+                      <a:srgbClr val="DCE9F5"/>
+                    </a:solidFill>
+                  </a:tcPr>
+                </a:tc>
+                <a:tc>
+                  <a:txBody>
+                    <a:bodyPr/>
+                    <a:lstStyle/>
+                    <a:p>
+                      <a:pPr algn="ctr"/>
+                      <a:r>
+                        <a:rPr sz="1400" b="0">
+                          <a:solidFill>
+                            <a:srgbClr val="6B7A90"/>
+                          </a:solidFill>
+                          <a:latin typeface="Arial"/>
+                          <a:ea typeface="Microsoft YaHei"/>
+                        </a:rPr>
+                        <a:t>27.86</a:t>
+                      </a:r>
+                    </a:p>
+                  </a:txBody>
+                  <a:tcPr anchor="ctr" marL="45720" marR="45720" marT="18288" marB="18288">
+                    <a:solidFill>
+                      <a:srgbClr val="DCE9F5"/>
+                    </a:solidFill>
+                  </a:tcPr>
+                </a:tc>
+                <a:tc>
+                  <a:txBody>
+                    <a:bodyPr/>
+                    <a:lstStyle/>
+                    <a:p>
+                      <a:pPr algn="ctr"/>
+                      <a:r>
+                        <a:rPr sz="1400" b="0">
+                          <a:solidFill>
+                            <a:srgbClr val="6B7A90"/>
+                          </a:solidFill>
+                          <a:latin typeface="Arial"/>
+                          <a:ea typeface="Microsoft YaHei"/>
+                        </a:rPr>
+                        <a:t>0.886</a:t>
+                      </a:r>
+                    </a:p>
+                  </a:txBody>
+                  <a:tcPr anchor="ctr" marL="45720" marR="45720" marT="18288" marB="18288">
+                    <a:solidFill>
+                      <a:srgbClr val="DCE9F5"/>
+                    </a:solidFill>
+                  </a:tcPr>
+                </a:tc>
+                <a:tc>
+                  <a:txBody>
+                    <a:bodyPr/>
+                    <a:lstStyle/>
+                    <a:p>
+                      <a:pPr algn="ctr"/>
+                      <a:r>
+                        <a:rPr sz="1400" b="0">
+                          <a:solidFill>
+                            <a:srgbClr val="6B7A90"/>
+                          </a:solidFill>
+                          <a:latin typeface="Arial"/>
+                          <a:ea typeface="Microsoft YaHei"/>
+                        </a:rPr>
+                        <a:t>0.122</a:t>
+                      </a:r>
+                    </a:p>
+                  </a:txBody>
+                  <a:tcPr anchor="ctr" marL="45720" marR="45720" marT="18288" marB="18288">
+                    <a:solidFill>
+                      <a:srgbClr val="DCE9F5"/>
+                    </a:solidFill>
+                  </a:tcPr>
+                </a:tc>
+                <a:tc>
+                  <a:txBody>
+                    <a:bodyPr/>
+                    <a:lstStyle/>
+                    <a:p>
+                      <a:pPr algn="ctr"/>
+                      <a:r>
+                        <a:rPr sz="1400" b="0">
+                          <a:solidFill>
+                            <a:srgbClr val="6B7A90"/>
+                          </a:solidFill>
+                          <a:latin typeface="Arial"/>
+                          <a:ea typeface="Microsoft YaHei"/>
+                        </a:rPr>
+                        <a:t>—</a:t>
+                      </a:r>
+                    </a:p>
+                  </a:txBody>
+                  <a:tcPr anchor="ctr" marL="45720" marR="45720" marT="18288" marB="18288">
+                    <a:solidFill>
+                      <a:srgbClr val="DCE9F5"/>
+                    </a:solidFill>
+                  </a:tcPr>
+                </a:tc>
+                <a:tc>
+                  <a:txBody>
+                    <a:bodyPr/>
+                    <a:lstStyle/>
+                    <a:p>
+                      <a:pPr algn="ctr"/>
+                      <a:r>
+                        <a:rPr sz="1400" b="0">
+                          <a:solidFill>
+                            <a:srgbClr val="6B7A90"/>
+                          </a:solidFill>
+                          <a:latin typeface="Arial"/>
+                          <a:ea typeface="Microsoft YaHei"/>
+                        </a:rPr>
+                        <a:t>—</a:t>
+                      </a:r>
+                    </a:p>
+                  </a:txBody>
+                  <a:tcPr anchor="ctr" marL="45720" marR="45720" marT="18288" marB="18288">
+                    <a:solidFill>
+                      <a:srgbClr val="DCE9F5"/>
+                    </a:solidFill>
+                  </a:tcPr>
+                </a:tc>
+                <a:tc>
+                  <a:txBody>
+                    <a:bodyPr/>
+                    <a:lstStyle/>
+                    <a:p>
+                      <a:pPr algn="ctr"/>
+                      <a:r>
+                        <a:rPr sz="1400" b="0">
+                          <a:solidFill>
+                            <a:srgbClr val="6B7A90"/>
+                          </a:solidFill>
+                          <a:latin typeface="Arial"/>
+                          <a:ea typeface="Microsoft YaHei"/>
+                        </a:rPr>
+                        <a:t>—</a:t>
+                      </a:r>
+                    </a:p>
+                  </a:txBody>
+                  <a:tcPr anchor="ctr" marL="45720" marR="45720" marT="18288" marB="18288">
+                    <a:solidFill>
+                      <a:srgbClr val="DCE9F5"/>
                     </a:solidFill>
                   </a:tcPr>
                 </a:tc>
@@ -10504,6 +10844,42 @@
           </a:graphicData>
         </a:graphic>
       </p:graphicFrame>
+      <p:sp>
+        <p:nvSpPr>
+          <p:cNvPr id="26" name="TextBox 25"/>
+          <p:cNvSpPr txBox="1"/>
+          <p:nvPr/>
+        </p:nvSpPr>
+        <p:spPr>
+          <a:xfrm>
+            <a:off x="868679" y="6144768"/>
+            <a:ext cx="10332720" cy="274320"/>
+          </a:xfrm>
+          <a:prstGeom prst="rect">
+            <a:avLst/>
+          </a:prstGeom>
+          <a:noFill/>
+        </p:spPr>
+        <p:txBody>
+          <a:bodyPr wrap="square" anchor="ctr">
+            <a:spAutoFit/>
+          </a:bodyPr>
+          <a:lstStyle/>
+          <a:p>
+            <a:pPr algn="l"/>
+            <a:r>
+              <a:rPr sz="1200" b="0">
+                <a:solidFill>
+                  <a:srgbClr val="6B7A90"/>
+                </a:solidFill>
+                <a:latin typeface="Arial"/>
+                <a:ea typeface="Microsoft YaHei"/>
+              </a:rPr>
+              <a:t>* BokehCrafter 未开源，无法复现；数值取自其论文（自建 VBS 数据集，三档虚化平均），数据集不同，仅作参考</a:t>
+            </a:r>
+          </a:p>
+        </p:txBody>
+      </p:sp>
     </p:spTree>
   </p:cSld>
   <p:clrMapOvr>
@@ -13312,7 +13688,7 @@
         </p:nvSpPr>
         <p:spPr>
           <a:xfrm>
-            <a:off x="777240" y="1325880"/>
+            <a:off x="777240" y="1234440"/>
             <a:ext cx="1809750" cy="914400"/>
           </a:xfrm>
           <a:prstGeom prst="rect">
@@ -13348,7 +13724,7 @@
                 <a:ea typeface="Microsoft YaHei"/>
                 <a:cs typeface="Microsoft YaHei"/>
               </a:rPr>
-              <a:t>低帧率评价</a:t>
+              <a:t>新增基线</a:t>
             </a:r>
           </a:p>
         </p:txBody>
@@ -13369,7 +13745,7 @@
         </p:nvSpPr>
         <p:spPr>
           <a:xfrm>
-            <a:off x="2926080" y="1325880"/>
+            <a:off x="2926080" y="1234440"/>
             <a:ext cx="8321040" cy="914400"/>
           </a:xfrm>
           <a:prstGeom prst="rect">
@@ -13408,7 +13784,7 @@
                 <a:ea typeface="Microsoft YaHei"/>
                 <a:cs typeface="Microsoft YaHei"/>
               </a:rPr>
-              <a:t>深度帧率降到 15 / 10 / 5 / 2 fps，缺失帧用统一的简单方法补齐</a:t>
+              <a:t>计划加入 MagicBokeh：单图输入，自行预测深度并用于虚化</a:t>
             </a:r>
           </a:p>
           <a:p>
@@ -13434,7 +13810,7 @@
                 <a:ea typeface="Microsoft YaHei"/>
                 <a:cs typeface="Microsoft YaHei"/>
               </a:rPr>
-              <a:t>比较六种方法随深度帧率下降的变化</a:t>
+              <a:t>与现有六种方法使用同一套数据和指标比较</a:t>
             </a:r>
           </a:p>
         </p:txBody>
@@ -13447,7 +13823,7 @@
         </p:nvCxnSpPr>
         <p:spPr>
           <a:xfrm>
-            <a:off x="777240" y="2532888"/>
+            <a:off x="777240" y="2286000"/>
             <a:ext cx="10469880" cy="0"/>
           </a:xfrm>
           <a:prstGeom prst="line">
@@ -13490,7 +13866,7 @@
         </p:nvSpPr>
         <p:spPr>
           <a:xfrm>
-            <a:off x="777240" y="2834639"/>
+            <a:off x="777240" y="2423160"/>
             <a:ext cx="1809750" cy="914400"/>
           </a:xfrm>
           <a:prstGeom prst="rect">
@@ -13526,7 +13902,7 @@
                 <a:ea typeface="Microsoft YaHei"/>
                 <a:cs typeface="Microsoft YaHei"/>
               </a:rPr>
-              <a:t>自研方法</a:t>
+              <a:t>低帧率评价</a:t>
             </a:r>
           </a:p>
         </p:txBody>
@@ -13547,7 +13923,7 @@
         </p:nvSpPr>
         <p:spPr>
           <a:xfrm>
-            <a:off x="2926080" y="2834639"/>
+            <a:off x="2926080" y="2423160"/>
             <a:ext cx="8321040" cy="914400"/>
           </a:xfrm>
           <a:prstGeom prst="rect">
@@ -13586,7 +13962,7 @@
                 <a:ea typeface="Microsoft YaHei"/>
                 <a:cs typeface="Microsoft YaHei"/>
               </a:rPr>
-              <a:t>根据基线结果中暴露的问题确定方法设计</a:t>
+              <a:t>深度帧率降到 15 / 10 / 5 / 2 fps，缺失帧用统一的简单方法补齐</a:t>
             </a:r>
           </a:p>
           <a:p>
@@ -13612,7 +13988,7 @@
                 <a:ea typeface="Microsoft YaHei"/>
                 <a:cs typeface="Microsoft YaHei"/>
               </a:rPr>
-              <a:t>重点关注低帧率深度补全、主体边界和时序稳定</a:t>
+              <a:t>比较各基线方法随深度帧率下降的变化</a:t>
             </a:r>
           </a:p>
         </p:txBody>
@@ -13625,7 +14001,7 @@
         </p:nvCxnSpPr>
         <p:spPr>
           <a:xfrm>
-            <a:off x="777240" y="4041648"/>
+            <a:off x="777240" y="3474720"/>
             <a:ext cx="10469880" cy="0"/>
           </a:xfrm>
           <a:prstGeom prst="line">
@@ -13668,7 +14044,7 @@
         </p:nvSpPr>
         <p:spPr>
           <a:xfrm>
-            <a:off x="777240" y="4343400"/>
+            <a:off x="777240" y="3611880"/>
             <a:ext cx="1809750" cy="914400"/>
           </a:xfrm>
           <a:prstGeom prst="rect">
@@ -13704,7 +14080,7 @@
                 <a:ea typeface="Microsoft YaHei"/>
                 <a:cs typeface="Microsoft YaHei"/>
               </a:rPr>
-              <a:t>自建数据集</a:t>
+              <a:t>自研方法</a:t>
             </a:r>
           </a:p>
         </p:txBody>
@@ -13725,7 +14101,185 @@
         </p:nvSpPr>
         <p:spPr>
           <a:xfrm>
-            <a:off x="2926080" y="4343400"/>
+            <a:off x="2926080" y="3611880"/>
+            <a:ext cx="8321040" cy="914400"/>
+          </a:xfrm>
+          <a:prstGeom prst="rect">
+            <a:avLst/>
+          </a:prstGeom>
+          <a:noFill/>
+          <a:ln w="0">
+            <a:noFill/>
+          </a:ln>
+        </p:spPr>
+        <p:txBody>
+          <a:bodyPr wrap="square" lIns="0" tIns="0" rIns="0" bIns="0" anchor="ctr">
+            <a:noAutofit/>
+          </a:bodyPr>
+          <a:lstStyle/>
+          <a:p>
+            <a:pPr algn="l">
+              <a:spcAft>
+                <a:spcPts val="600"/>
+              </a:spcAft>
+              <a:defRPr sz="2025" b="0">
+                <a:solidFill>
+                  <a:srgbClr val="101F37"/>
+                </a:solidFill>
+                <a:latin typeface="Microsoft YaHei"/>
+                <a:ea typeface="Microsoft YaHei"/>
+                <a:cs typeface="Microsoft YaHei"/>
+              </a:defRPr>
+            </a:pPr>
+            <a:r>
+              <a:rPr sz="2025" b="0">
+                <a:solidFill>
+                  <a:srgbClr val="101F37"/>
+                </a:solidFill>
+                <a:latin typeface="Microsoft YaHei"/>
+                <a:ea typeface="Microsoft YaHei"/>
+                <a:cs typeface="Microsoft YaHei"/>
+              </a:rPr>
+              <a:t>根据基线结果中暴露的问题确定方法设计</a:t>
+            </a:r>
+          </a:p>
+          <a:p>
+            <a:pPr algn="l">
+              <a:spcAft>
+                <a:spcPts val="600"/>
+              </a:spcAft>
+              <a:defRPr sz="2025" b="0">
+                <a:solidFill>
+                  <a:srgbClr val="101F37"/>
+                </a:solidFill>
+                <a:latin typeface="Microsoft YaHei"/>
+                <a:ea typeface="Microsoft YaHei"/>
+                <a:cs typeface="Microsoft YaHei"/>
+              </a:defRPr>
+            </a:pPr>
+            <a:r>
+              <a:rPr sz="2025" b="0">
+                <a:solidFill>
+                  <a:srgbClr val="101F37"/>
+                </a:solidFill>
+                <a:latin typeface="Microsoft YaHei"/>
+                <a:ea typeface="Microsoft YaHei"/>
+                <a:cs typeface="Microsoft YaHei"/>
+              </a:rPr>
+              <a:t>重点关注低帧率深度补全、主体边界和时序稳定</a:t>
+            </a:r>
+          </a:p>
+        </p:txBody>
+      </p:sp>
+      <p:cxnSp>
+        <p:nvCxnSpPr>
+          <p:cNvPr id="25" name="Connector 24"/>
+          <p:cNvCxnSpPr/>
+          <p:nvPr/>
+        </p:nvCxnSpPr>
+        <p:spPr>
+          <a:xfrm>
+            <a:off x="777240" y="4663440"/>
+            <a:ext cx="10469880" cy="0"/>
+          </a:xfrm>
+          <a:prstGeom prst="line">
+            <a:avLst/>
+          </a:prstGeom>
+          <a:ln w="9525">
+            <a:solidFill>
+              <a:srgbClr val="22C7E2"/>
+            </a:solidFill>
+          </a:ln>
+        </p:spPr>
+        <p:style>
+          <a:lnRef idx="2">
+            <a:schemeClr val="accent1"/>
+          </a:lnRef>
+          <a:fillRef idx="0">
+            <a:schemeClr val="accent1"/>
+          </a:fillRef>
+          <a:effectRef idx="1">
+            <a:schemeClr val="accent1"/>
+          </a:effectRef>
+          <a:fontRef idx="minor">
+            <a:schemeClr val="tx1"/>
+          </a:fontRef>
+        </p:style>
+      </p:cxnSp>
+      <p:sp>
+        <p:nvSpPr>
+          <p:cNvPr id="9" name="矩形 8">
+            <a:extLst>
+              <a:ext uri="{FF2B5EF4-FFF2-40B4-BE49-F238E27FC236}">
+                <a16:creationId xmlns:a16="http://schemas.microsoft.com/office/drawing/2014/main" id="{A0DB1E63-8F98-56F0-5AD9-E321506A6914}"/>
+              </a:ext>
+            </a:extLst>
+          </p:cNvPr>
+          <p:cNvSpPr>
+            <a:spLocks noGrp="1"/>
+          </p:cNvSpPr>
+          <p:nvPr/>
+        </p:nvSpPr>
+        <p:spPr>
+          <a:xfrm>
+            <a:off x="777240" y="4800600"/>
+            <a:ext cx="1809750" cy="914400"/>
+          </a:xfrm>
+          <a:prstGeom prst="rect">
+            <a:avLst/>
+          </a:prstGeom>
+          <a:noFill/>
+          <a:ln w="0">
+            <a:noFill/>
+          </a:ln>
+        </p:spPr>
+        <p:txBody>
+          <a:bodyPr wrap="square" lIns="0" tIns="0" rIns="0" bIns="0" anchor="ctr">
+            <a:noAutofit/>
+          </a:bodyPr>
+          <a:lstStyle/>
+          <a:p>
+            <a:pPr algn="l">
+              <a:defRPr sz="2100" b="1">
+                <a:solidFill>
+                  <a:srgbClr val="0D569A"/>
+                </a:solidFill>
+                <a:latin typeface="Microsoft YaHei"/>
+                <a:ea typeface="Microsoft YaHei"/>
+                <a:cs typeface="Microsoft YaHei"/>
+              </a:defRPr>
+            </a:pPr>
+            <a:r>
+              <a:rPr sz="2100" b="1">
+                <a:solidFill>
+                  <a:srgbClr val="0D569A"/>
+                </a:solidFill>
+                <a:latin typeface="Microsoft YaHei"/>
+                <a:ea typeface="Microsoft YaHei"/>
+                <a:cs typeface="Microsoft YaHei"/>
+              </a:rPr>
+              <a:t>自建数据集</a:t>
+            </a:r>
+          </a:p>
+        </p:txBody>
+      </p:sp>
+      <p:sp>
+        <p:nvSpPr>
+          <p:cNvPr id="10" name="矩形 9">
+            <a:extLst>
+              <a:ext uri="{FF2B5EF4-FFF2-40B4-BE49-F238E27FC236}">
+                <a16:creationId xmlns:a16="http://schemas.microsoft.com/office/drawing/2014/main" id="{50248E8E-737C-9BE3-5CB0-2F225DFAD313}"/>
+              </a:ext>
+            </a:extLst>
+          </p:cNvPr>
+          <p:cNvSpPr>
+            <a:spLocks noGrp="1"/>
+          </p:cNvSpPr>
+          <p:nvPr/>
+        </p:nvSpPr>
+        <p:spPr>
+          <a:xfrm>
+            <a:off x="2926080" y="4800600"/>
             <a:ext cx="8321040" cy="914400"/>
           </a:xfrm>
           <a:prstGeom prst="rect">

</xml_diff>